<commit_message>
Archive des niveaux d'alerte du 2026-10-28
</commit_message>
<xml_diff>
--- a/web/rapports/mensuel/2026-10.pptx
+++ b/web/rapports/mensuel/2026-10.pptx
@@ -43,9 +43,10 @@
     <p:sldId id="291" r:id="rId37"/>
     <p:sldId id="292" r:id="rId38"/>
     <p:sldId id="293" r:id="rId39"/>
+    <p:sldId id="294" r:id="rId40"/>
   </p:sldIdLst>
   <p:notesMasterIdLst>
-    <p:notesMasterId r:id="rId40"/>
+    <p:notesMasterId r:id="rId41"/>
   </p:notesMasterIdLst>
   <p:sldSz cx="12192000" cy="6858000"/>
   <p:notesSz cx="6858000" cy="12192000"/>
@@ -3291,6 +3292,94 @@
             <a:fld id="{F7021451-1387-4CA6-816F-3879F97B5CBC}" type="slidenum">
               <a:rPr lang="en-US"/>
               <a:t>38</a:t>
+            </a:fld>
+            <a:endParaRPr lang="en-US"/>
+          </a:p>
+        </p:txBody>
+      </p:sp>
+    </p:spTree>
+    <p:extLst>
+      <p:ext uri="{BB962C8B-B14F-4D97-AF65-F5344CB8AC3E}">
+        <p14:creationId xmlns:p14="http://schemas.microsoft.com/office/powerpoint/2010/main" val="1024086991"/>
+      </p:ext>
+    </p:extLst>
+  </p:cSld>
+  <p:clrMapOvr>
+    <a:masterClrMapping/>
+  </p:clrMapOvr>
+</p:notes>
+</file>
+
+<file path=ppt/notesSlides/notesSlide39.xml><?xml version="1.0" encoding="utf-8"?>
+<p:notes xmlns:a="http://schemas.openxmlformats.org/drawingml/2006/main" xmlns:r="http://schemas.openxmlformats.org/officeDocument/2006/relationships" xmlns:p="http://schemas.openxmlformats.org/presentationml/2006/main">
+  <p:cSld>
+    <p:spTree>
+      <p:nvGrpSpPr>
+        <p:cNvPr id="1" name=""/>
+        <p:cNvGrpSpPr/>
+        <p:nvPr/>
+      </p:nvGrpSpPr>
+      <p:grpSpPr>
+        <a:xfrm>
+          <a:off x="0" y="0"/>
+          <a:ext cx="0" cy="0"/>
+          <a:chOff x="0" y="0"/>
+          <a:chExt cx="0" cy="0"/>
+        </a:xfrm>
+      </p:grpSpPr>
+      <p:sp>
+        <p:nvSpPr>
+          <p:cNvPr id="2" name="Slide Image Placeholder 1"/>
+          <p:cNvSpPr>
+            <a:spLocks noGrp="1" noRot="1" noChangeAspect="1"/>
+          </p:cNvSpPr>
+          <p:nvPr>
+            <p:ph type="sldImg"/>
+          </p:nvPr>
+        </p:nvSpPr>
+        <p:spPr/>
+      </p:sp>
+      <p:sp>
+        <p:nvSpPr>
+          <p:cNvPr id="3" name="Notes Placeholder 2"/>
+          <p:cNvSpPr>
+            <a:spLocks noGrp="1"/>
+          </p:cNvSpPr>
+          <p:nvPr>
+            <p:ph type="body" idx="1"/>
+          </p:nvPr>
+        </p:nvSpPr>
+        <p:spPr/>
+        <p:txBody>
+          <a:bodyPr/>
+          <a:lstStyle/>
+          <a:p>
+            <a:r>
+              <a:rPr lang="en-US" dirty="0"/>
+              <a:t/>
+            </a:r>
+            <a:endParaRPr lang="en-US" dirty="0"/>
+          </a:p>
+        </p:txBody>
+      </p:sp>
+      <p:sp>
+        <p:nvSpPr>
+          <p:cNvPr id="4" name="Slide Number Placeholder 3"/>
+          <p:cNvSpPr>
+            <a:spLocks noGrp="1"/>
+          </p:cNvSpPr>
+          <p:nvPr>
+            <p:ph type="sldNum" sz="quarter" idx="10"/>
+          </p:nvPr>
+        </p:nvSpPr>
+        <p:spPr/>
+        <p:txBody>
+          <a:bodyPr/>
+          <a:lstStyle/>
+          <a:p>
+            <a:fld id="{F7021451-1387-4CA6-816F-3879F97B5CBC}" type="slidenum">
+              <a:rPr lang="en-US"/>
+              <a:t>39</a:t>
             </a:fld>
             <a:endParaRPr lang="en-US"/>
           </a:p>
@@ -4350,7 +4439,7 @@
                 <a:ea typeface="Calibri" pitchFamily="34" charset="-122"/>
                 <a:cs typeface="Calibri" pitchFamily="34" charset="-120"/>
               </a:rPr>
-              <a:t>27 OCTOBRE 2026</a:t>
+              <a:t>28 OCTOBRE 2026</a:t>
             </a:r>
             <a:endParaRPr lang="en-US" sz="2000" dirty="0"/>
           </a:p>
@@ -4396,7 +4485,7 @@
                 <a:ea typeface="Calibri" pitchFamily="34" charset="-122"/>
                 <a:cs typeface="Calibri" pitchFamily="34" charset="-120"/>
               </a:rPr>
-              <a:t>Période du 1er au 27 octobre 2026</a:t>
+              <a:t>Période du 1er au 28 octobre 2026</a:t>
             </a:r>
             <a:endParaRPr lang="en-US" sz="1400" dirty="0"/>
           </a:p>
@@ -4504,7 +4593,7 @@
                 <a:ea typeface="Calibri" pitchFamily="34" charset="-122"/>
                 <a:cs typeface="Calibri" pitchFamily="34" charset="-120"/>
               </a:rPr>
-              <a:t>|  27/10/26   |   1</a:t>
+              <a:t>|  28/10/26   |   1</a:t>
             </a:r>
             <a:endParaRPr lang="en-US" sz="1000" dirty="0"/>
           </a:p>
@@ -5267,7 +5356,7 @@
                 <a:ea typeface="Calibri" pitchFamily="34" charset="-122"/>
                 <a:cs typeface="Calibri" pitchFamily="34" charset="-120"/>
               </a:rPr>
-              <a:t>|  27/10/26   |   10</a:t>
+              <a:t>|  28/10/26   |   10</a:t>
             </a:r>
             <a:endParaRPr lang="en-US" sz="1000" dirty="0"/>
           </a:p>
@@ -5533,7 +5622,7 @@
                 <a:ea typeface="Calibri" pitchFamily="34" charset="-122"/>
                 <a:cs typeface="Calibri" pitchFamily="34" charset="-120"/>
               </a:rPr>
-              <a:t>Indice de confiance : moyenne (incident vérifié le plus récent : 120 jours ; 2 signaux du jour)</a:t>
+              <a:t>Indice de confiance : faible (incident vérifié le plus récent : 121 jours ; aucun signal du jour)</a:t>
             </a:r>
             <a:endParaRPr lang="en-US" sz="1100" dirty="0"/>
           </a:p>
@@ -5871,7 +5960,7 @@
                 <a:ea typeface="Calibri" pitchFamily="34" charset="-122"/>
                 <a:cs typeface="Calibri" pitchFamily="34" charset="-120"/>
               </a:rPr>
-              <a:t>|  27/10/26   |   11</a:t>
+              <a:t>|  28/10/26   |   11</a:t>
             </a:r>
             <a:endParaRPr lang="en-US" sz="1000" dirty="0"/>
           </a:p>
@@ -6290,7 +6379,7 @@
                 <a:ea typeface="Calibri" pitchFamily="34" charset="-122"/>
                 <a:cs typeface="Calibri" pitchFamily="34" charset="-120"/>
               </a:rPr>
-              <a:t>|  27/10/26   |   12</a:t>
+              <a:t>|  28/10/26   |   12</a:t>
             </a:r>
             <a:endParaRPr lang="en-US" sz="1000" dirty="0"/>
           </a:p>
@@ -6492,7 +6581,7 @@
                 <a:ea typeface="Calibri" pitchFamily="34" charset="-122"/>
                 <a:cs typeface="Calibri" pitchFamily="34" charset="-120"/>
               </a:rPr>
-              <a:t>|  27/10/26   |   13</a:t>
+              <a:t>|  28/10/26   |   13</a:t>
             </a:r>
             <a:endParaRPr lang="en-US" sz="1000" dirty="0"/>
           </a:p>
@@ -6733,7 +6822,7 @@
                 <a:ea typeface="Calibri" pitchFamily="34" charset="-122"/>
                 <a:cs typeface="Calibri" pitchFamily="34" charset="-120"/>
               </a:rPr>
-              <a:t>Indice de confiance : faible (incident vérifié le plus récent : 120 jours ; aucun signal du jour)</a:t>
+              <a:t>Indice de confiance : moyenne (incident vérifié le plus récent : 121 jours ; 1 signal du jour)</a:t>
             </a:r>
             <a:endParaRPr lang="en-US" sz="1100" dirty="0"/>
           </a:p>
@@ -7088,7 +7177,7 @@
                 <a:ea typeface="Calibri" pitchFamily="34" charset="-122"/>
                 <a:cs typeface="Calibri" pitchFamily="34" charset="-120"/>
               </a:rPr>
-              <a:t>|  27/10/26   |   14</a:t>
+              <a:t>|  28/10/26   |   14</a:t>
             </a:r>
             <a:endParaRPr lang="en-US" sz="1000" dirty="0"/>
           </a:p>
@@ -7439,7 +7528,7 @@
                 <a:ea typeface="Calibri" pitchFamily="34" charset="-122"/>
                 <a:cs typeface="Calibri" pitchFamily="34" charset="-120"/>
               </a:rPr>
-              <a:t>SÉCURITÉ NUMÉRIQUE AU BURKINA : LA BCLCC LANCE LA 2ᵉ SEMAINE NATIONALE DE LUTTE CONTRE LA CYBERCRIMINALITÉ</a:t>
+              <a:t>ENTREPRENEURIAT FÉMININ À KORSIMORO : LE COMBAT INSPIRANT DES FEMMES POUR L’AUTONOMIE FINANCIÈRE</a:t>
             </a:r>
             <a:endParaRPr lang="en-US" sz="1300" dirty="0"/>
           </a:p>
@@ -7484,7 +7573,7 @@
                   </a:extLst>
                 </a:hlinkClick>
               </a:rPr>
-              <a:t>Faso7</a:t>
+              <a:t>Burkina24</a:t>
             </a:r>
             <a:pPr indent="0" marL="0">
               <a:spcAft>
@@ -7501,7 +7590,24 @@
                 <a:ea typeface="Calibri" pitchFamily="34" charset="-122"/>
                 <a:cs typeface="Calibri" pitchFamily="34" charset="-120"/>
               </a:rPr>
-              <a:t> — 24 octobre 2026, 13 h UTC</a:t>
+              <a:t> — 28 octobre 2026, 8 h UTC   ·   </a:t>
+            </a:r>
+            <a:pPr indent="0" marL="0">
+              <a:spcAft>
+                <a:spcPts val="200"/>
+              </a:spcAft>
+              <a:buNone/>
+            </a:pPr>
+            <a:r>
+              <a:rPr lang="en-US" sz="1300" b="1" dirty="0">
+                <a:solidFill>
+                  <a:srgbClr val="1F2937"/>
+                </a:solidFill>
+                <a:latin typeface="Calibri" pitchFamily="34" charset="0"/>
+                <a:ea typeface="Calibri" pitchFamily="34" charset="-122"/>
+                <a:cs typeface="Calibri" pitchFamily="34" charset="-120"/>
+              </a:rPr>
+              <a:t>Cotation : Probable</a:t>
             </a:r>
             <a:endParaRPr lang="en-US" sz="1300" dirty="0"/>
           </a:p>
@@ -7525,7 +7631,7 @@
                 <a:ea typeface="Calibri" pitchFamily="34" charset="-122"/>
                 <a:cs typeface="Calibri" pitchFamily="34" charset="-120"/>
               </a:rPr>
-              <a:t>COOPÉRATION: LE MINISTRE DE LA SÉCURITÉ REÇOIT UNE DÉLÉGATION DE L’UICN</a:t>
+              <a:t>SÉCURITÉ NUMÉRIQUE AU BURKINA : LA BCLCC LANCE LA 2ᵉ SEMAINE NATIONALE DE LUTTE CONTRE LA CYBERCRIMINALITÉ</a:t>
             </a:r>
             <a:endParaRPr lang="en-US" sz="1300" dirty="0"/>
           </a:p>
@@ -7570,7 +7676,7 @@
                   </a:extLst>
                 </a:hlinkClick>
               </a:rPr>
-              <a:t>Wakat Sera</a:t>
+              <a:t>Faso7</a:t>
             </a:r>
             <a:pPr indent="0" marL="0">
               <a:spcAft>
@@ -7587,7 +7693,7 @@
                 <a:ea typeface="Calibri" pitchFamily="34" charset="-122"/>
                 <a:cs typeface="Calibri" pitchFamily="34" charset="-120"/>
               </a:rPr>
-              <a:t> — 24 octobre 2026, 12 h UTC</a:t>
+              <a:t> — 24 octobre 2026, 13 h UTC</a:t>
             </a:r>
             <a:endParaRPr lang="en-US" sz="1300" dirty="0"/>
           </a:p>
@@ -7611,7 +7717,7 @@
                 <a:ea typeface="Calibri" pitchFamily="34" charset="-122"/>
                 <a:cs typeface="Calibri" pitchFamily="34" charset="-120"/>
               </a:rPr>
-              <a:t>CONSTRUCTION AU BURKINA FASO : L’ORDRE DES INGÉNIEURS ALERTE SUR LES RISQUES LIÉS AUX FAUX PROFESSIONNELS</a:t>
+              <a:t>COOPÉRATION: LE MINISTRE DE LA SÉCURITÉ REÇOIT UNE DÉLÉGATION DE L’UICN</a:t>
             </a:r>
             <a:endParaRPr lang="en-US" sz="1300" dirty="0"/>
           </a:p>
@@ -7656,7 +7762,7 @@
                   </a:extLst>
                 </a:hlinkClick>
               </a:rPr>
-              <a:t>Faso7</a:t>
+              <a:t>Wakat Sera</a:t>
             </a:r>
             <a:pPr indent="0" marL="0">
               <a:spcAft>
@@ -7673,7 +7779,7 @@
                 <a:ea typeface="Calibri" pitchFamily="34" charset="-122"/>
                 <a:cs typeface="Calibri" pitchFamily="34" charset="-120"/>
               </a:rPr>
-              <a:t> — 23 octobre 2026, 14 h UTC</a:t>
+              <a:t> — 24 octobre 2026, 12 h UTC</a:t>
             </a:r>
             <a:endParaRPr lang="en-US" sz="1300" dirty="0"/>
           </a:p>
@@ -7697,7 +7803,7 @@
                 <a:ea typeface="Calibri" pitchFamily="34" charset="-122"/>
                 <a:cs typeface="Calibri" pitchFamily="34" charset="-120"/>
               </a:rPr>
-              <a:t>BURKINA FASO-TURQUIE : UNE OFFENSIVE DIPLOMATIQUE D’ENVERGURE POUR CONSOLIDER LA COOPÉRATION BILATÉRALE</a:t>
+              <a:t>CONSTRUCTION AU BURKINA FASO : L’ORDRE DES INGÉNIEURS ALERTE SUR LES RISQUES LIÉS AUX FAUX PROFESSIONNELS</a:t>
             </a:r>
             <a:endParaRPr lang="en-US" sz="1300" dirty="0"/>
           </a:p>
@@ -7742,7 +7848,7 @@
                   </a:extLst>
                 </a:hlinkClick>
               </a:rPr>
-              <a:t>Alwihda Info (Tchad)</a:t>
+              <a:t>Faso7</a:t>
             </a:r>
             <a:pPr indent="0" marL="0">
               <a:spcAft>
@@ -7759,7 +7865,7 @@
                 <a:ea typeface="Calibri" pitchFamily="34" charset="-122"/>
                 <a:cs typeface="Calibri" pitchFamily="34" charset="-120"/>
               </a:rPr>
-              <a:t> — 23 octobre 2026, 9 h UTC</a:t>
+              <a:t> — 23 octobre 2026, 14 h UTC</a:t>
             </a:r>
             <a:endParaRPr lang="en-US" sz="1300" dirty="0"/>
           </a:p>
@@ -7843,7 +7949,7 @@
                 <a:ea typeface="Calibri" pitchFamily="34" charset="-122"/>
                 <a:cs typeface="Calibri" pitchFamily="34" charset="-120"/>
               </a:rPr>
-              <a:t>|  27/10/26   |   15</a:t>
+              <a:t>|  28/10/26   |   15</a:t>
             </a:r>
             <a:endParaRPr lang="en-US" sz="1000" dirty="0"/>
           </a:p>
@@ -8091,7 +8197,7 @@
                 <a:ea typeface="Calibri" pitchFamily="34" charset="-122"/>
                 <a:cs typeface="Calibri" pitchFamily="34" charset="-120"/>
               </a:rPr>
-              <a:t>EXPANSION GÉOGRAPHIQUE DU TERRORISME SAHÉLIEN - IMPLICATIONS POUR LE GHANA</a:t>
+              <a:t>BURKINA FASO-TURQUIE : UNE OFFENSIVE DIPLOMATIQUE D’ENVERGURE POUR CONSOLIDER LA COOPÉRATION BILATÉRALE</a:t>
             </a:r>
             <a:endParaRPr lang="en-US" sz="1300" dirty="0"/>
           </a:p>
@@ -8136,7 +8242,7 @@
                   </a:extLst>
                 </a:hlinkClick>
               </a:rPr>
-              <a:t>AllAfrica (GH)</a:t>
+              <a:t>Alwihda Info (Tchad)</a:t>
             </a:r>
             <a:pPr indent="0" marL="0">
               <a:spcAft>
@@ -8153,24 +8259,7 @@
                 <a:ea typeface="Calibri" pitchFamily="34" charset="-122"/>
                 <a:cs typeface="Calibri" pitchFamily="34" charset="-120"/>
               </a:rPr>
-              <a:t> — 17 octobre 2026, 19 h UTC   ·   </a:t>
-            </a:r>
-            <a:pPr indent="0" marL="0">
-              <a:spcAft>
-                <a:spcPts val="200"/>
-              </a:spcAft>
-              <a:buNone/>
-            </a:pPr>
-            <a:r>
-              <a:rPr lang="en-US" sz="1300" b="1" dirty="0">
-                <a:solidFill>
-                  <a:srgbClr val="1F2937"/>
-                </a:solidFill>
-                <a:latin typeface="Calibri" pitchFamily="34" charset="0"/>
-                <a:ea typeface="Calibri" pitchFamily="34" charset="-122"/>
-                <a:cs typeface="Calibri" pitchFamily="34" charset="-120"/>
-              </a:rPr>
-              <a:t>Cotation : Probable</a:t>
+              <a:t> — 23 octobre 2026, 9 h UTC</a:t>
             </a:r>
             <a:endParaRPr lang="en-US" sz="1300" dirty="0"/>
           </a:p>
@@ -8194,7 +8283,7 @@
                 <a:ea typeface="Calibri" pitchFamily="34" charset="-122"/>
                 <a:cs typeface="Calibri" pitchFamily="34" charset="-120"/>
               </a:rPr>
-              <a:t>VIS D’APPEL À CANDIDATURES POUR LE RECRUTEMENT DE PERSONNEL À LA RADIO CONFÉDÉRALE DAANDÈ LIPTAKO</a:t>
+              <a:t>EXPANSION GÉOGRAPHIQUE DU TERRORISME SAHÉLIEN - IMPLICATIONS POUR LE GHANA</a:t>
             </a:r>
             <a:endParaRPr lang="en-US" sz="1300" dirty="0"/>
           </a:p>
@@ -8239,7 +8328,7 @@
                   </a:extLst>
                 </a:hlinkClick>
               </a:rPr>
-              <a:t>Le Sahel</a:t>
+              <a:t>AllAfrica (GH)</a:t>
             </a:r>
             <a:pPr indent="0" marL="0">
               <a:spcAft>
@@ -8256,7 +8345,7 @@
                 <a:ea typeface="Calibri" pitchFamily="34" charset="-122"/>
                 <a:cs typeface="Calibri" pitchFamily="34" charset="-120"/>
               </a:rPr>
-              <a:t> — 27 octobre 2026, 16 h UTC   ·   </a:t>
+              <a:t> — 17 octobre 2026, 19 h UTC   ·   </a:t>
             </a:r>
             <a:pPr indent="0" marL="0">
               <a:spcAft>
@@ -8273,7 +8362,7 @@
                 <a:ea typeface="Calibri" pitchFamily="34" charset="-122"/>
                 <a:cs typeface="Calibri" pitchFamily="34" charset="-120"/>
               </a:rPr>
-              <a:t>Cotation : Non confirmé</a:t>
+              <a:t>Cotation : Probable</a:t>
             </a:r>
             <a:endParaRPr lang="en-US" sz="1300" dirty="0"/>
           </a:p>
@@ -8297,7 +8386,7 @@
                 <a:ea typeface="Calibri" pitchFamily="34" charset="-122"/>
                 <a:cs typeface="Calibri" pitchFamily="34" charset="-120"/>
               </a:rPr>
-              <a:t>ROAMING UEMOA : 4 PAYS UNISSENT LEURS RÉSEAUX POUR ALLÉGER LA FACTURE DES USAGERS</a:t>
+              <a:t>VIS D’APPEL À CANDIDATURES POUR LE RECRUTEMENT DE PERSONNEL À LA RADIO CONFÉDÉRALE DAANDÈ LIPTAKO</a:t>
             </a:r>
             <a:endParaRPr lang="en-US" sz="1300" dirty="0"/>
           </a:p>
@@ -8342,7 +8431,7 @@
                   </a:extLst>
                 </a:hlinkClick>
               </a:rPr>
-              <a:t>Linfodrome</a:t>
+              <a:t>Le Sahel</a:t>
             </a:r>
             <a:pPr indent="0" marL="0">
               <a:spcAft>
@@ -8359,7 +8448,24 @@
                 <a:ea typeface="Calibri" pitchFamily="34" charset="-122"/>
                 <a:cs typeface="Calibri" pitchFamily="34" charset="-120"/>
               </a:rPr>
-              <a:t> — 27 octobre 2026, 11 h UTC</a:t>
+              <a:t> — 27 octobre 2026, 16 h UTC   ·   </a:t>
+            </a:r>
+            <a:pPr indent="0" marL="0">
+              <a:spcAft>
+                <a:spcPts val="200"/>
+              </a:spcAft>
+              <a:buNone/>
+            </a:pPr>
+            <a:r>
+              <a:rPr lang="en-US" sz="1300" b="1" dirty="0">
+                <a:solidFill>
+                  <a:srgbClr val="1F2937"/>
+                </a:solidFill>
+                <a:latin typeface="Calibri" pitchFamily="34" charset="0"/>
+                <a:ea typeface="Calibri" pitchFamily="34" charset="-122"/>
+                <a:cs typeface="Calibri" pitchFamily="34" charset="-120"/>
+              </a:rPr>
+              <a:t>Cotation : Non confirmé</a:t>
             </a:r>
             <a:endParaRPr lang="en-US" sz="1300" dirty="0"/>
           </a:p>
@@ -8383,7 +8489,7 @@
                 <a:ea typeface="Calibri" pitchFamily="34" charset="-122"/>
                 <a:cs typeface="Calibri" pitchFamily="34" charset="-120"/>
               </a:rPr>
-              <a:t>BURKINA FASO : RIMTALBA JEAN EMMANUEL OUÉDRAOGO ATTENDU AU SOMMET RUSSIE-AFRIQUE À MOSCOU</a:t>
+              <a:t>ROAMING UEMOA : 4 PAYS UNISSENT LEURS RÉSEAUX POUR ALLÉGER LA FACTURE DES USAGERS</a:t>
             </a:r>
             <a:endParaRPr lang="en-US" sz="1300" dirty="0"/>
           </a:p>
@@ -8428,7 +8534,7 @@
                   </a:extLst>
                 </a:hlinkClick>
               </a:rPr>
-              <a:t>Malijet</a:t>
+              <a:t>Linfodrome</a:t>
             </a:r>
             <a:pPr indent="0" marL="0">
               <a:spcAft>
@@ -8445,7 +8551,7 @@
                 <a:ea typeface="Calibri" pitchFamily="34" charset="-122"/>
                 <a:cs typeface="Calibri" pitchFamily="34" charset="-120"/>
               </a:rPr>
-              <a:t> — 26 octobre 2026, 23 h UTC</a:t>
+              <a:t> — 27 octobre 2026, 11 h UTC</a:t>
             </a:r>
             <a:endParaRPr lang="en-US" sz="1300" dirty="0"/>
           </a:p>
@@ -8529,7 +8635,7 @@
                 <a:ea typeface="Calibri" pitchFamily="34" charset="-122"/>
                 <a:cs typeface="Calibri" pitchFamily="34" charset="-120"/>
               </a:rPr>
-              <a:t>|  27/10/26   |   16</a:t>
+              <a:t>|  28/10/26   |   16</a:t>
             </a:r>
             <a:endParaRPr lang="en-US" sz="1000" dirty="0"/>
           </a:p>
@@ -8795,7 +8901,7 @@
                 <a:ea typeface="Calibri" pitchFamily="34" charset="-122"/>
                 <a:cs typeface="Calibri" pitchFamily="34" charset="-120"/>
               </a:rPr>
-              <a:t>Indice de confiance : faible (incident vérifié le plus récent : 121 jours ; aucun signal du jour)</a:t>
+              <a:t>Indice de confiance : moyenne (incident vérifié le plus récent : 121 jours ; 4 signaux du jour)</a:t>
             </a:r>
             <a:endParaRPr lang="en-US" sz="1100" dirty="0"/>
           </a:p>
@@ -8849,7 +8955,7 @@
         <p:spPr>
           <a:xfrm>
             <a:off x="640080" y="2029968"/>
-            <a:ext cx="6812280" cy="3867912"/>
+            <a:ext cx="10972800" cy="3867912"/>
           </a:xfrm>
           <a:prstGeom prst="rect">
             <a:avLst/>
@@ -9072,81 +9178,9 @@
           </a:p>
         </p:txBody>
       </p:sp>
-      <p:pic>
-        <p:nvPicPr>
-          <p:cNvPr id="12" name="Image 0" descr="preencoded.png">
-            <a:hlinkClick r:id="rId3" tooltip=""/>
-          </p:cNvPr>
-          <p:cNvPicPr>
-            <a:picLocks noChangeAspect="1"/>
-          </p:cNvPicPr>
-          <p:nvPr/>
-        </p:nvPicPr>
-        <p:blipFill>
-          <a:blip r:embed="rId2"/>
-          <a:stretch>
-            <a:fillRect/>
-          </a:stretch>
-        </p:blipFill>
-        <p:spPr>
-          <a:xfrm>
-            <a:off x="7635240" y="2075688"/>
-            <a:ext cx="4114800" cy="3465433"/>
-          </a:xfrm>
-          <a:prstGeom prst="rect">
-            <a:avLst/>
-          </a:prstGeom>
-        </p:spPr>
-      </p:pic>
-      <p:sp>
-        <p:nvSpPr>
-          <p:cNvPr id="13" name="Text 10"/>
-          <p:cNvSpPr/>
-          <p:nvPr/>
-        </p:nvSpPr>
-        <p:spPr>
-          <a:xfrm>
-            <a:off x="7635240" y="5577697"/>
-            <a:ext cx="4114800" cy="256032"/>
-          </a:xfrm>
-          <a:prstGeom prst="rect">
-            <a:avLst/>
-          </a:prstGeom>
-          <a:noFill/>
-          <a:ln/>
-        </p:spPr>
-        <p:txBody>
-          <a:bodyPr wrap="square" rtlCol="0" anchor="ctr"/>
-          <a:lstStyle/>
-          <a:p>
-            <a:pPr algn="r" indent="0" marL="0">
-              <a:buNone/>
-            </a:pPr>
-            <a:r>
-              <a:rPr lang="en-US" sz="900" u="sng" dirty="0">
-                <a:solidFill>
-                  <a:srgbClr val="1F6B5E"/>
-                </a:solidFill>
-                <a:latin typeface="Calibri" pitchFamily="34" charset="0"/>
-                <a:ea typeface="Calibri" pitchFamily="34" charset="-122"/>
-                <a:cs typeface="Calibri" pitchFamily="34" charset="-120"/>
-                <a:hlinkClick r:id="rId4" invalidUrl="" action="" tgtFrame="" tooltip="" history="1" highlightClick="0" endSnd="0">
-                  <a:extLst>
-                    <a:ext uri="{A12FA001-AC4F-418D-AE19-62706E023703}">
-                      <ahyp:hlinkClr xmlns:ahyp="http://schemas.microsoft.com/office/drawing/2018/hyperlinkcolor" val="tx"/>
-                    </a:ext>
-                  </a:extLst>
-                </a:hlinkClick>
-              </a:rPr>
-              <a:t>Photo : © mali24.info</a:t>
-            </a:r>
-            <a:endParaRPr lang="en-US" sz="900" dirty="0"/>
-          </a:p>
-        </p:txBody>
-      </p:sp>
-      <p:sp>
-        <p:nvSpPr>
-          <p:cNvPr id="14" name="Text 11"/>
+      <p:sp>
+        <p:nvSpPr>
+          <p:cNvPr id="12" name="Text 10"/>
           <p:cNvSpPr/>
           <p:nvPr/>
         </p:nvSpPr>
@@ -9191,7 +9225,7 @@
       </p:sp>
       <p:sp>
         <p:nvSpPr>
-          <p:cNvPr id="15" name="Text 12"/>
+          <p:cNvPr id="13" name="Text 11"/>
           <p:cNvSpPr/>
           <p:nvPr/>
         </p:nvSpPr>
@@ -9222,7 +9256,7 @@
                 <a:ea typeface="Calibri" pitchFamily="34" charset="-122"/>
                 <a:cs typeface="Calibri" pitchFamily="34" charset="-120"/>
               </a:rPr>
-              <a:t>|  27/10/26   |   17</a:t>
+              <a:t>|  28/10/26   |   17</a:t>
             </a:r>
             <a:endParaRPr lang="en-US" sz="1000" dirty="0"/>
           </a:p>
@@ -10019,7 +10053,7 @@
                 <a:ea typeface="Calibri" pitchFamily="34" charset="-122"/>
                 <a:cs typeface="Calibri" pitchFamily="34" charset="-120"/>
               </a:rPr>
-              <a:t>|  27/10/26   |   18</a:t>
+              <a:t>|  28/10/26   |   18</a:t>
             </a:r>
             <a:endParaRPr lang="en-US" sz="1000" dirty="0"/>
           </a:p>
@@ -10730,7 +10764,7 @@
                 <a:ea typeface="Calibri" pitchFamily="34" charset="-122"/>
                 <a:cs typeface="Calibri" pitchFamily="34" charset="-120"/>
               </a:rPr>
-              <a:t>|  27/10/26   |   19</a:t>
+              <a:t>|  28/10/26   |   19</a:t>
             </a:r>
             <a:endParaRPr lang="en-US" sz="1000" dirty="0"/>
           </a:p>
@@ -11571,7 +11605,7 @@
                 <a:ea typeface="Calibri" pitchFamily="34" charset="-122"/>
                 <a:cs typeface="Calibri" pitchFamily="34" charset="-120"/>
               </a:rPr>
-              <a:t>TCHAD-NIGER : UNE NOUVELLE ESCALADE ENTRE MAHAMAT IDRISS DÉBY ET ABDOURAHAMANE TIANI</a:t>
+              <a:t>FRAPPE DE DRONE À AGADEZ : LE NIGER CONVOQUE L’AMBASSADEUR DU TCHAD ET ANNONCE DE…</a:t>
             </a:r>
             <a:endParaRPr lang="en-US" sz="900" dirty="0"/>
           </a:p>
@@ -11615,7 +11649,7 @@
                 <a:ea typeface="Calibri" pitchFamily="34" charset="-122"/>
                 <a:cs typeface="Calibri" pitchFamily="34" charset="-120"/>
               </a:rPr>
-              <a:t>SEVEN SHOT DEAD BY GUNMEN AT CHURCH FUNERAL IN JORDAN, OFFICIALS SAY</a:t>
+              <a:t>WOMAN KILLED BY TEMA-AFIENYA TRAIN AS RESIDENTS DEMAND FOOTBRIDGE</a:t>
             </a:r>
             <a:endParaRPr lang="en-US" sz="900" dirty="0"/>
           </a:p>
@@ -11791,7 +11825,7 @@
                 <a:ea typeface="Calibri" pitchFamily="34" charset="-122"/>
                 <a:cs typeface="Calibri" pitchFamily="34" charset="-120"/>
               </a:rPr>
-              <a:t>(EN) LIBERIA: DOLPHIN KILLED, BUTCHERED BEFORE NAFAA RESCUE TEAM ARRIVED</a:t>
+              <a:t>LIBÉRIA : UN DAUPHIN TUÉ ET MASSACRÉ AVANT L'ARRIVÉE DE L'ÉQUIPE DE SECOURS DE LA…</a:t>
             </a:r>
             <a:endParaRPr lang="en-US" sz="900" dirty="0"/>
           </a:p>
@@ -11835,7 +11869,7 @@
                 <a:ea typeface="Calibri" pitchFamily="34" charset="-122"/>
                 <a:cs typeface="Calibri" pitchFamily="34" charset="-120"/>
               </a:rPr>
-              <a:t>IMMEUBLE EFFONDRÉ À THIÈS : UN MORT ET DEUX BLESSÉS, SELON LE BILAN PROVISOIRE</a:t>
+              <a:t>TOUBA : UN DÉBAT SUR LES MOTEURS DE JAKARTA SE TERMINE PAR LA MORT DE BAYE M. DIOP</a:t>
             </a:r>
             <a:endParaRPr lang="en-US" sz="900" dirty="0"/>
           </a:p>
@@ -11919,7 +11953,7 @@
                 <a:ea typeface="Calibri" pitchFamily="34" charset="-122"/>
                 <a:cs typeface="Calibri" pitchFamily="34" charset="-120"/>
               </a:rPr>
-              <a:t>|  27/10/26   |   2</a:t>
+              <a:t>|  28/10/26   |   2</a:t>
             </a:r>
             <a:endParaRPr lang="en-US" sz="1000" dirty="0"/>
           </a:p>
@@ -12185,7 +12219,7 @@
                 <a:ea typeface="Calibri" pitchFamily="34" charset="-122"/>
                 <a:cs typeface="Calibri" pitchFamily="34" charset="-120"/>
               </a:rPr>
-              <a:t>Indice de confiance : moyenne (incident vérifié le plus récent : 118 jours ; 3 signaux du jour)</a:t>
+              <a:t>Indice de confiance : faible (incident vérifié le plus récent : 119 jours ; aucun signal du jour)</a:t>
             </a:r>
             <a:endParaRPr lang="en-US" sz="1100" dirty="0"/>
           </a:p>
@@ -12224,7 +12258,7 @@
                 <a:ea typeface="Arial Narrow" pitchFamily="34" charset="-122"/>
                 <a:cs typeface="Arial Narrow" pitchFamily="34" charset="-120"/>
               </a:rPr>
-              <a:t>Tchad-Niger : une nouvelle escalade entre Mahamat Idriss Déby et Abdourahamane Tiani</a:t>
+              <a:t>Frappe de drone à Agadez : le Niger convoque l’ambassadeur du Tchad et annonce des recours internationaux</a:t>
             </a:r>
             <a:endParaRPr lang="en-US" sz="2200" dirty="0"/>
           </a:p>
@@ -12261,7 +12295,7 @@
               <a:buNone/>
             </a:pPr>
             <a:r>
-              <a:rPr lang="en-US" sz="1500" b="1" dirty="0">
+              <a:rPr lang="en-US" sz="1200" b="1" dirty="0">
                 <a:solidFill>
                   <a:srgbClr val="1F6B5E"/>
                 </a:solidFill>
@@ -12271,7 +12305,7 @@
               </a:rPr>
               <a:t>Contexte</a:t>
             </a:r>
-            <a:endParaRPr lang="en-US" sz="1400" dirty="0"/>
+            <a:endParaRPr lang="en-US" sz="1100" dirty="0"/>
           </a:p>
           <a:p>
             <a:pPr indent="0" marL="0">
@@ -12281,17 +12315,17 @@
               <a:buNone/>
             </a:pPr>
             <a:r>
-              <a:rPr lang="en-US" sz="1400" dirty="0">
-                <a:solidFill>
-                  <a:srgbClr val="1F2937"/>
-                </a:solidFill>
-                <a:latin typeface="Calibri" pitchFamily="34" charset="0"/>
-                <a:ea typeface="Calibri" pitchFamily="34" charset="-122"/>
-                <a:cs typeface="Calibri" pitchFamily="34" charset="-120"/>
-              </a:rPr>
-              <a:t>Fait rapporté le mardi 27 octobre 2026. Lieu : Niamey, Niger. Actualité politique. Une seule source à ce stade (Jeune Afrique) : à confirmer par un second média.</a:t>
-            </a:r>
-            <a:endParaRPr lang="en-US" sz="1400" dirty="0"/>
+              <a:rPr lang="en-US" sz="1100" dirty="0">
+                <a:solidFill>
+                  <a:srgbClr val="1F2937"/>
+                </a:solidFill>
+                <a:latin typeface="Calibri" pitchFamily="34" charset="0"/>
+                <a:ea typeface="Calibri" pitchFamily="34" charset="-122"/>
+                <a:cs typeface="Calibri" pitchFamily="34" charset="-120"/>
+              </a:rPr>
+              <a:t>Fait rapporté le mercredi 28 octobre 2026. Lieu : Niamey, Niger. Actualité politique. Repris par 8 médias distincts (Maliactu, RFI Afrique, Malijet, ANP — Agence Nigérienne Presse, Journal du Tchad, Tchadinfos, Africanews — Chaine panafricaine, Africanews) : le fait est recoupé.</a:t>
+            </a:r>
+            <a:endParaRPr lang="en-US" sz="1100" dirty="0"/>
           </a:p>
           <a:p>
             <a:pPr indent="0" marL="0">
@@ -12304,7 +12338,7 @@
               <a:buNone/>
             </a:pPr>
             <a:r>
-              <a:rPr lang="en-US" sz="1500" b="1" dirty="0">
+              <a:rPr lang="en-US" sz="1200" b="1" dirty="0">
                 <a:solidFill>
                   <a:srgbClr val="1F6B5E"/>
                 </a:solidFill>
@@ -12314,7 +12348,7 @@
               </a:rPr>
               <a:t>Ce que rapportent les sources</a:t>
             </a:r>
-            <a:endParaRPr lang="en-US" sz="1400" dirty="0"/>
+            <a:endParaRPr lang="en-US" sz="1100" dirty="0"/>
           </a:p>
           <a:p>
             <a:pPr indent="0" marL="0">
@@ -12324,15 +12358,15 @@
               <a:buNone/>
             </a:pPr>
             <a:r>
-              <a:rPr lang="en-US" sz="1400" b="1" dirty="0">
-                <a:solidFill>
-                  <a:srgbClr val="1F2937"/>
-                </a:solidFill>
-                <a:latin typeface="Calibri" pitchFamily="34" charset="0"/>
-                <a:ea typeface="Calibri" pitchFamily="34" charset="-122"/>
-                <a:cs typeface="Calibri" pitchFamily="34" charset="-120"/>
-              </a:rPr>
-              <a:t>Jeune Afrique : </a:t>
+              <a:rPr lang="en-US" sz="1100" b="1" dirty="0">
+                <a:solidFill>
+                  <a:srgbClr val="1F2937"/>
+                </a:solidFill>
+                <a:latin typeface="Calibri" pitchFamily="34" charset="0"/>
+                <a:ea typeface="Calibri" pitchFamily="34" charset="-122"/>
+                <a:cs typeface="Calibri" pitchFamily="34" charset="-120"/>
+              </a:rPr>
+              <a:t>Maliactu : </a:t>
             </a:r>
             <a:pPr indent="0" marL="0">
               <a:spcAft>
@@ -12341,17 +12375,54 @@
               <a:buNone/>
             </a:pPr>
             <a:r>
-              <a:rPr lang="en-US" sz="1400" i="1" dirty="0">
-                <a:solidFill>
-                  <a:srgbClr val="1F2937"/>
-                </a:solidFill>
-                <a:latin typeface="Calibri" pitchFamily="34" charset="0"/>
-                <a:ea typeface="Calibri" pitchFamily="34" charset="-122"/>
-                <a:cs typeface="Calibri" pitchFamily="34" charset="-120"/>
-              </a:rPr>
-              <a:t>« Niamey accuse N’Djamena d’avoir lancé une frappe de drone sur son territoire, avec le soutien de la France. Une charge qui ravive la méfiance entre les deux voisins. »</a:t>
-            </a:r>
-            <a:endParaRPr lang="en-US" sz="1400" dirty="0"/>
+              <a:rPr lang="en-US" sz="1100" i="1" dirty="0">
+                <a:solidFill>
+                  <a:srgbClr val="1F2937"/>
+                </a:solidFill>
+                <a:latin typeface="Calibri" pitchFamily="34" charset="0"/>
+                <a:ea typeface="Calibri" pitchFamily="34" charset="-122"/>
+                <a:cs typeface="Calibri" pitchFamily="34" charset="-120"/>
+              </a:rPr>
+              <a:t>« Mali Actu - maliactu.net - Mali Actualités, Les Actus et Informations sur le Mali Mali Actu Frappe de drone à Agadez : le Niger convoque l’ambassadeur du Tchad et annonce des recours internationaux Les relations entre Niamey et N’Djamena connaissent une nouvelle tension après une frappe de drone signalée le 24 octobre dans la région nigérienne d’Agadez. »</a:t>
+            </a:r>
+            <a:endParaRPr lang="en-US" sz="1100" dirty="0"/>
+          </a:p>
+          <a:p>
+            <a:pPr indent="0" marL="0">
+              <a:spcAft>
+                <a:spcPts val="300"/>
+              </a:spcAft>
+              <a:buNone/>
+            </a:pPr>
+            <a:r>
+              <a:rPr lang="en-US" sz="1100" b="1" dirty="0">
+                <a:solidFill>
+                  <a:srgbClr val="1F2937"/>
+                </a:solidFill>
+                <a:latin typeface="Calibri" pitchFamily="34" charset="0"/>
+                <a:ea typeface="Calibri" pitchFamily="34" charset="-122"/>
+                <a:cs typeface="Calibri" pitchFamily="34" charset="-120"/>
+              </a:rPr>
+              <a:t>RFI Afrique : </a:t>
+            </a:r>
+            <a:pPr indent="0" marL="0">
+              <a:spcAft>
+                <a:spcPts val="300"/>
+              </a:spcAft>
+              <a:buNone/>
+            </a:pPr>
+            <a:r>
+              <a:rPr lang="en-US" sz="1100" i="1" dirty="0">
+                <a:solidFill>
+                  <a:srgbClr val="1F2937"/>
+                </a:solidFill>
+                <a:latin typeface="Calibri" pitchFamily="34" charset="0"/>
+                <a:ea typeface="Calibri" pitchFamily="34" charset="-122"/>
+                <a:cs typeface="Calibri" pitchFamily="34" charset="-120"/>
+              </a:rPr>
+              <a:t>« Le Niger accuse son voisin d’avoir mené « une frappe aérienne par drone menée depuis le territoire du Tchad » et à laquelle aurait, selon lui, participé la France. L’incident aurait eu lieu le 24 octobre à 1 heure du matin à l’est d’Emi Lulu, non loin des frontières algérienne et libyenne. »</a:t>
+            </a:r>
+            <a:endParaRPr lang="en-US" sz="1100" dirty="0"/>
           </a:p>
           <a:p>
             <a:pPr indent="0" marL="0">
@@ -12364,7 +12435,7 @@
               <a:buNone/>
             </a:pPr>
             <a:r>
-              <a:rPr lang="en-US" sz="1500" b="1" dirty="0">
+              <a:rPr lang="en-US" sz="1200" b="1" dirty="0">
                 <a:solidFill>
                   <a:srgbClr val="1F6B5E"/>
                 </a:solidFill>
@@ -12374,7 +12445,7 @@
               </a:rPr>
               <a:t>Enjeux sûreté</a:t>
             </a:r>
-            <a:endParaRPr lang="en-US" sz="1400" dirty="0"/>
+            <a:endParaRPr lang="en-US" sz="1100" dirty="0"/>
           </a:p>
           <a:p>
             <a:pPr indent="0" marL="0">
@@ -12384,7 +12455,7 @@
               <a:buNone/>
             </a:pPr>
             <a:r>
-              <a:rPr lang="en-US" sz="1400" dirty="0">
+              <a:rPr lang="en-US" sz="1100" dirty="0">
                 <a:solidFill>
                   <a:srgbClr val="1F2937"/>
                 </a:solidFill>
@@ -12394,7 +12465,7 @@
               </a:rPr>
               <a:t>Menace armée sur les axes et localités de la zone : réévaluer les déplacements terrestres (horaires, convois, itinéraires de repli) et les consignes des sites et des personnels présents à proximité.</a:t>
             </a:r>
-            <a:endParaRPr lang="en-US" sz="1400" dirty="0"/>
+            <a:endParaRPr lang="en-US" sz="1100" dirty="0"/>
           </a:p>
           <a:p>
             <a:pPr indent="0" marL="0">
@@ -12407,15 +12478,15 @@
               <a:buNone/>
             </a:pPr>
             <a:r>
-              <a:rPr lang="en-US" sz="1400" b="1" dirty="0">
-                <a:solidFill>
-                  <a:srgbClr val="1F2937"/>
-                </a:solidFill>
-                <a:latin typeface="Calibri" pitchFamily="34" charset="0"/>
-                <a:ea typeface="Calibri" pitchFamily="34" charset="-122"/>
-                <a:cs typeface="Calibri" pitchFamily="34" charset="-120"/>
-              </a:rPr>
-              <a:t>Source : </a:t>
+              <a:rPr lang="en-US" sz="1100" b="1" dirty="0">
+                <a:solidFill>
+                  <a:srgbClr val="1F2937"/>
+                </a:solidFill>
+                <a:latin typeface="Calibri" pitchFamily="34" charset="0"/>
+                <a:ea typeface="Calibri" pitchFamily="34" charset="-122"/>
+                <a:cs typeface="Calibri" pitchFamily="34" charset="-120"/>
+              </a:rPr>
+              <a:t>Sources : </a:t>
             </a:r>
             <a:pPr indent="0" marL="0">
               <a:spcAft>
@@ -12424,7 +12495,7 @@
               <a:buNone/>
             </a:pPr>
             <a:r>
-              <a:rPr lang="en-US" sz="1400" u="sng" dirty="0">
+              <a:rPr lang="en-US" sz="1100" u="sng" dirty="0">
                 <a:solidFill>
                   <a:srgbClr val="1F6B5E"/>
                 </a:solidFill>
@@ -12439,7 +12510,7 @@
                   </a:extLst>
                 </a:hlinkClick>
               </a:rPr>
-              <a:t>Jeune Afrique</a:t>
+              <a:t>Maliactu</a:t>
             </a:r>
             <a:pPr indent="0" marL="0">
               <a:spcAft>
@@ -12448,72 +12519,55 @@
               <a:buNone/>
             </a:pPr>
             <a:r>
-              <a:rPr lang="en-US" sz="1400" b="1" dirty="0">
-                <a:solidFill>
-                  <a:srgbClr val="1F2937"/>
-                </a:solidFill>
-                <a:latin typeface="Calibri" pitchFamily="34" charset="0"/>
-                <a:ea typeface="Calibri" pitchFamily="34" charset="-122"/>
-                <a:cs typeface="Calibri" pitchFamily="34" charset="-120"/>
-              </a:rPr>
-              <a:t> — 27 octobre 2026, 16 h UTC   ·   Cotation : Probable</a:t>
-            </a:r>
-            <a:endParaRPr lang="en-US" sz="1400" dirty="0"/>
-          </a:p>
-        </p:txBody>
-      </p:sp>
-      <p:pic>
-        <p:nvPicPr>
-          <p:cNvPr id="12" name="Image 0" descr="preencoded.png">
-            <a:hlinkClick r:id="rId3" tooltip=""/>
-          </p:cNvPr>
-          <p:cNvPicPr>
-            <a:picLocks noChangeAspect="1"/>
-          </p:cNvPicPr>
-          <p:nvPr/>
-        </p:nvPicPr>
-        <p:blipFill>
-          <a:blip r:embed="rId2"/>
-          <a:stretch>
-            <a:fillRect/>
-          </a:stretch>
-        </p:blipFill>
-        <p:spPr>
-          <a:xfrm>
-            <a:off x="7635240" y="2075688"/>
-            <a:ext cx="4114800" cy="2314575"/>
-          </a:xfrm>
-          <a:prstGeom prst="rect">
-            <a:avLst/>
-          </a:prstGeom>
-        </p:spPr>
-      </p:pic>
-      <p:sp>
-        <p:nvSpPr>
-          <p:cNvPr id="13" name="Text 10"/>
-          <p:cNvSpPr/>
-          <p:nvPr/>
-        </p:nvSpPr>
-        <p:spPr>
-          <a:xfrm>
-            <a:off x="7635240" y="4426839"/>
-            <a:ext cx="4114800" cy="256032"/>
-          </a:xfrm>
-          <a:prstGeom prst="rect">
-            <a:avLst/>
-          </a:prstGeom>
-          <a:noFill/>
-          <a:ln/>
-        </p:spPr>
-        <p:txBody>
-          <a:bodyPr wrap="square" rtlCol="0" anchor="ctr"/>
-          <a:lstStyle/>
-          <a:p>
-            <a:pPr algn="r" indent="0" marL="0">
-              <a:buNone/>
-            </a:pPr>
-            <a:r>
-              <a:rPr lang="en-US" sz="900" u="sng" dirty="0">
+              <a:rPr lang="en-US" sz="1100" u="sng" dirty="0">
+                <a:solidFill>
+                  <a:srgbClr val="1F6B5E"/>
+                </a:solidFill>
+                <a:latin typeface="Calibri" pitchFamily="34" charset="0"/>
+                <a:ea typeface="Calibri" pitchFamily="34" charset="-122"/>
+                <a:cs typeface="Calibri" pitchFamily="34" charset="-120"/>
+                <a:hlinkClick r:id="rId2" invalidUrl="" action="" tgtFrame="" tooltip="" history="1" highlightClick="0" endSnd="0">
+                  <a:extLst>
+                    <a:ext uri="{A12FA001-AC4F-418D-AE19-62706E023703}">
+                      <ahyp:hlinkClr xmlns:ahyp="http://schemas.microsoft.com/office/drawing/2018/hyperlinkcolor" val="tx"/>
+                    </a:ext>
+                  </a:extLst>
+                </a:hlinkClick>
+              </a:rPr>
+              <a:t> · RFI Afrique</a:t>
+            </a:r>
+            <a:pPr indent="0" marL="0">
+              <a:spcAft>
+                <a:spcPts val="300"/>
+              </a:spcAft>
+              <a:buNone/>
+            </a:pPr>
+            <a:r>
+              <a:rPr lang="en-US" sz="1100" u="sng" dirty="0">
+                <a:solidFill>
+                  <a:srgbClr val="1F6B5E"/>
+                </a:solidFill>
+                <a:latin typeface="Calibri" pitchFamily="34" charset="0"/>
+                <a:ea typeface="Calibri" pitchFamily="34" charset="-122"/>
+                <a:cs typeface="Calibri" pitchFamily="34" charset="-120"/>
+                <a:hlinkClick r:id="rId3" invalidUrl="" action="" tgtFrame="" tooltip="" history="1" highlightClick="0" endSnd="0">
+                  <a:extLst>
+                    <a:ext uri="{A12FA001-AC4F-418D-AE19-62706E023703}">
+                      <ahyp:hlinkClr xmlns:ahyp="http://schemas.microsoft.com/office/drawing/2018/hyperlinkcolor" val="tx"/>
+                    </a:ext>
+                  </a:extLst>
+                </a:hlinkClick>
+              </a:rPr>
+              <a:t> · Malijet</a:t>
+            </a:r>
+            <a:pPr indent="0" marL="0">
+              <a:spcAft>
+                <a:spcPts val="300"/>
+              </a:spcAft>
+              <a:buNone/>
+            </a:pPr>
+            <a:r>
+              <a:rPr lang="en-US" sz="1100" u="sng" dirty="0">
                 <a:solidFill>
                   <a:srgbClr val="1F6B5E"/>
                 </a:solidFill>
@@ -12528,7 +12582,113 @@
                   </a:extLst>
                 </a:hlinkClick>
               </a:rPr>
-              <a:t>Photo : © jeuneafrique.com</a:t>
+              <a:t> · ANP — Agence Nigérienne Presse</a:t>
+            </a:r>
+            <a:pPr indent="0" marL="0">
+              <a:spcAft>
+                <a:spcPts val="300"/>
+              </a:spcAft>
+              <a:buNone/>
+            </a:pPr>
+            <a:r>
+              <a:rPr lang="en-US" sz="1100" dirty="0">
+                <a:solidFill>
+                  <a:srgbClr val="1F2937"/>
+                </a:solidFill>
+                <a:latin typeface="Calibri" pitchFamily="34" charset="0"/>
+                <a:ea typeface="Calibri" pitchFamily="34" charset="-122"/>
+                <a:cs typeface="Calibri" pitchFamily="34" charset="-120"/>
+              </a:rPr>
+              <a:t> · Journal du Tchad · Tchadinfos · Africanews — Chaine panafricaine · Africanews</a:t>
+            </a:r>
+            <a:pPr indent="0" marL="0">
+              <a:spcAft>
+                <a:spcPts val="300"/>
+              </a:spcAft>
+              <a:buNone/>
+            </a:pPr>
+            <a:r>
+              <a:rPr lang="en-US" sz="1100" b="1" dirty="0">
+                <a:solidFill>
+                  <a:srgbClr val="1F2937"/>
+                </a:solidFill>
+                <a:latin typeface="Calibri" pitchFamily="34" charset="0"/>
+                <a:ea typeface="Calibri" pitchFamily="34" charset="-122"/>
+                <a:cs typeface="Calibri" pitchFamily="34" charset="-120"/>
+              </a:rPr>
+              <a:t> — 28 octobre 2026, 7 h UTC   ·   Cotation : Confirmé</a:t>
+            </a:r>
+            <a:endParaRPr lang="en-US" sz="1100" dirty="0"/>
+          </a:p>
+        </p:txBody>
+      </p:sp>
+      <p:pic>
+        <p:nvPicPr>
+          <p:cNvPr id="12" name="Image 0" descr="preencoded.png">
+            <a:hlinkClick r:id="rId6" tooltip=""/>
+          </p:cNvPr>
+          <p:cNvPicPr>
+            <a:picLocks noChangeAspect="1"/>
+          </p:cNvPicPr>
+          <p:nvPr/>
+        </p:nvPicPr>
+        <p:blipFill>
+          <a:blip r:embed="rId5"/>
+          <a:stretch>
+            <a:fillRect/>
+          </a:stretch>
+        </p:blipFill>
+        <p:spPr>
+          <a:xfrm>
+            <a:off x="7635240" y="2075688"/>
+            <a:ext cx="4114800" cy="2314575"/>
+          </a:xfrm>
+          <a:prstGeom prst="rect">
+            <a:avLst/>
+          </a:prstGeom>
+        </p:spPr>
+      </p:pic>
+      <p:sp>
+        <p:nvSpPr>
+          <p:cNvPr id="13" name="Text 10"/>
+          <p:cNvSpPr/>
+          <p:nvPr/>
+        </p:nvSpPr>
+        <p:spPr>
+          <a:xfrm>
+            <a:off x="7635240" y="4426839"/>
+            <a:ext cx="4114800" cy="256032"/>
+          </a:xfrm>
+          <a:prstGeom prst="rect">
+            <a:avLst/>
+          </a:prstGeom>
+          <a:noFill/>
+          <a:ln/>
+        </p:spPr>
+        <p:txBody>
+          <a:bodyPr wrap="square" rtlCol="0" anchor="ctr"/>
+          <a:lstStyle/>
+          <a:p>
+            <a:pPr algn="r" indent="0" marL="0">
+              <a:buNone/>
+            </a:pPr>
+            <a:r>
+              <a:rPr lang="en-US" sz="900" u="sng" dirty="0">
+                <a:solidFill>
+                  <a:srgbClr val="1F6B5E"/>
+                </a:solidFill>
+                <a:latin typeface="Calibri" pitchFamily="34" charset="0"/>
+                <a:ea typeface="Calibri" pitchFamily="34" charset="-122"/>
+                <a:cs typeface="Calibri" pitchFamily="34" charset="-120"/>
+                <a:hlinkClick r:id="rId7" invalidUrl="" action="" tgtFrame="" tooltip="" history="1" highlightClick="0" endSnd="0">
+                  <a:extLst>
+                    <a:ext uri="{A12FA001-AC4F-418D-AE19-62706E023703}">
+                      <ahyp:hlinkClr xmlns:ahyp="http://schemas.microsoft.com/office/drawing/2018/hyperlinkcolor" val="tx"/>
+                    </a:ext>
+                  </a:extLst>
+                </a:hlinkClick>
+              </a:rPr>
+              <a:t>Photo : © maliactu.net</a:t>
             </a:r>
             <a:endParaRPr lang="en-US" sz="900" dirty="0"/>
           </a:p>
@@ -12612,7 +12772,7 @@
                 <a:ea typeface="Calibri" pitchFamily="34" charset="-122"/>
                 <a:cs typeface="Calibri" pitchFamily="34" charset="-120"/>
               </a:rPr>
-              <a:t>|  27/10/26   |   20</a:t>
+              <a:t>|  28/10/26   |   20</a:t>
             </a:r>
             <a:endParaRPr lang="en-US" sz="1000" dirty="0"/>
           </a:p>
@@ -12885,7 +13045,7 @@
                 <a:ea typeface="Calibri" pitchFamily="34" charset="-122"/>
                 <a:cs typeface="Calibri" pitchFamily="34" charset="-120"/>
               </a:rPr>
-              <a:t>FRAPPE DE DRONE AU NIGER : NIAMEY ACCUSE LE TCHAD, N’DJAMENA REJETTE LES ACCUSATIONS</a:t>
+              <a:t>NIGER GOVERNOR’S CONVOY CRASH KILLS FOUR STUDENTS, DRIVER</a:t>
             </a:r>
             <a:endParaRPr lang="en-US" sz="1300" dirty="0"/>
           </a:p>
@@ -12930,7 +13090,7 @@
                   </a:extLst>
                 </a:hlinkClick>
               </a:rPr>
-              <a:t>Journal du Tchad · Tchadinfos · ANP — Agence Nigérienne Presse</a:t>
+              <a:t>Premium Times · Vanguard</a:t>
             </a:r>
             <a:pPr indent="0" marL="0">
               <a:spcAft>
@@ -12947,7 +13107,7 @@
                 <a:ea typeface="Calibri" pitchFamily="34" charset="-122"/>
                 <a:cs typeface="Calibri" pitchFamily="34" charset="-120"/>
               </a:rPr>
-              <a:t> — 27 octobre 2026, 13 h UTC   ·   </a:t>
+              <a:t> — 28 octobre 2026, 6 h UTC   ·   </a:t>
             </a:r>
             <a:pPr indent="0" marL="0">
               <a:spcAft>
@@ -12988,7 +13148,7 @@
                 <a:ea typeface="Calibri" pitchFamily="34" charset="-122"/>
                 <a:cs typeface="Calibri" pitchFamily="34" charset="-120"/>
               </a:rPr>
-              <a:t>LE NIGER AFFIRME QU'UNE FRAPPE DE DRONE DU TCHAD A TUÉ DEUX CIVILS</a:t>
+              <a:t>TCHAD-NIGER : UNE NOUVELLE ESCALADE ENTRE MAHAMAT IDRISS DÉBY ET ABDOURAHAMANE TIANI</a:t>
             </a:r>
             <a:endParaRPr lang="en-US" sz="1300" dirty="0"/>
           </a:p>
@@ -13009,7 +13169,7 @@
                 <a:ea typeface="Calibri" pitchFamily="34" charset="-122"/>
                 <a:cs typeface="Calibri" pitchFamily="34" charset="-120"/>
               </a:rPr>
-              <a:t>Sources : </a:t>
+              <a:t>Source : </a:t>
             </a:r>
             <a:pPr indent="0" marL="0">
               <a:spcAft>
@@ -13033,7 +13193,7 @@
                   </a:extLst>
                 </a:hlinkClick>
               </a:rPr>
-              <a:t>Africanews — Chaine panafricaine · Africanews</a:t>
+              <a:t>Jeune Afrique</a:t>
             </a:r>
             <a:pPr indent="0" marL="0">
               <a:spcAft>
@@ -13050,7 +13210,7 @@
                 <a:ea typeface="Calibri" pitchFamily="34" charset="-122"/>
                 <a:cs typeface="Calibri" pitchFamily="34" charset="-120"/>
               </a:rPr>
-              <a:t> — 27 octobre 2026, 9 h UTC   ·   </a:t>
+              <a:t> — 27 octobre 2026, 16 h UTC   ·   </a:t>
             </a:r>
             <a:pPr indent="0" marL="0">
               <a:spcAft>
@@ -13067,7 +13227,7 @@
                 <a:ea typeface="Calibri" pitchFamily="34" charset="-122"/>
                 <a:cs typeface="Calibri" pitchFamily="34" charset="-120"/>
               </a:rPr>
-              <a:t>Cotation : Confirmé</a:t>
+              <a:t>Cotation : Probable</a:t>
             </a:r>
             <a:endParaRPr lang="en-US" sz="1300" dirty="0"/>
           </a:p>
@@ -13091,7 +13251,7 @@
                 <a:ea typeface="Calibri" pitchFamily="34" charset="-122"/>
                 <a:cs typeface="Calibri" pitchFamily="34" charset="-120"/>
               </a:rPr>
-              <a:t>LE NIGER DÉNONCE UNE ATTAQUE DE DRONE DU TCHAD AVEC «L’APPUI DE LA FRANCE»</a:t>
+              <a:t>LE PAYS DÉNONCE UNE ATTAQUE DE DRONE DU TCHAD AVEC «L'APPUI DE LA FRANCE»</a:t>
             </a:r>
             <a:endParaRPr lang="en-US" sz="1300" dirty="0"/>
           </a:p>
@@ -13112,7 +13272,7 @@
                 <a:ea typeface="Calibri" pitchFamily="34" charset="-122"/>
                 <a:cs typeface="Calibri" pitchFamily="34" charset="-120"/>
               </a:rPr>
-              <a:t>Source : </a:t>
+              <a:t>Sources : </a:t>
             </a:r>
             <a:pPr indent="0" marL="0">
               <a:spcAft>
@@ -13136,7 +13296,7 @@
                   </a:extLst>
                 </a:hlinkClick>
               </a:rPr>
-              <a:t>RFI Afrique</a:t>
+              <a:t>AllAfrica (NE) · RFI Afrique</a:t>
             </a:r>
             <a:pPr indent="0" marL="0">
               <a:spcAft>
@@ -13153,7 +13313,7 @@
                 <a:ea typeface="Calibri" pitchFamily="34" charset="-122"/>
                 <a:cs typeface="Calibri" pitchFamily="34" charset="-120"/>
               </a:rPr>
-              <a:t> — 27 octobre 2026, 5 h UTC   ·   </a:t>
+              <a:t> — 27 octobre 2026, 9 h UTC   ·   </a:t>
             </a:r>
             <a:pPr indent="0" marL="0">
               <a:spcAft>
@@ -13443,7 +13603,7 @@
                 <a:ea typeface="Calibri" pitchFamily="34" charset="-122"/>
                 <a:cs typeface="Calibri" pitchFamily="34" charset="-120"/>
               </a:rPr>
-              <a:t>|  27/10/26   |   21</a:t>
+              <a:t>|  28/10/26   |   21</a:t>
             </a:r>
             <a:endParaRPr lang="en-US" sz="1000" dirty="0"/>
           </a:p>
@@ -13716,7 +13876,7 @@
                 <a:ea typeface="Calibri" pitchFamily="34" charset="-122"/>
                 <a:cs typeface="Calibri" pitchFamily="34" charset="-120"/>
               </a:rPr>
-              <a:t>4 STUDENTS, ONE LADY KILLED IN NIGER GOVERNOR’S CONVOY ROAD CRASH</a:t>
+              <a:t>POURQUOI N’DJAMÉNA SORT ENFIN DE SON SILENCE FACE À NIAMEY ?</a:t>
             </a:r>
             <a:endParaRPr lang="en-US" sz="1300" dirty="0"/>
           </a:p>
@@ -13761,7 +13921,7 @@
                   </a:extLst>
                 </a:hlinkClick>
               </a:rPr>
-              <a:t>Vanguard</a:t>
+              <a:t>Tchadinfos</a:t>
             </a:r>
             <a:pPr indent="0" marL="0">
               <a:spcAft>
@@ -13795,7 +13955,7 @@
                 <a:ea typeface="Calibri" pitchFamily="34" charset="-122"/>
                 <a:cs typeface="Calibri" pitchFamily="34" charset="-120"/>
               </a:rPr>
-              <a:t>Cotation : Probable</a:t>
+              <a:t>Cotation : Non confirmé</a:t>
             </a:r>
             <a:endParaRPr lang="en-US" sz="1300" dirty="0"/>
           </a:p>
@@ -13819,7 +13979,7 @@
                 <a:ea typeface="Calibri" pitchFamily="34" charset="-122"/>
                 <a:cs typeface="Calibri" pitchFamily="34" charset="-120"/>
               </a:rPr>
-              <a:t>POURQUOI N’DJAMÉNA SORT ENFIN DE SON SILENCE FACE À NIAMEY ?</a:t>
+              <a:t>AVIS À MANIFESTATION D’INTÉRÊT N°003/CA/TAFOUK TV/2026</a:t>
             </a:r>
             <a:endParaRPr lang="en-US" sz="1300" dirty="0"/>
           </a:p>
@@ -13864,7 +14024,7 @@
                   </a:extLst>
                 </a:hlinkClick>
               </a:rPr>
-              <a:t>Tchadinfos</a:t>
+              <a:t>Le Sahel</a:t>
             </a:r>
             <a:pPr indent="0" marL="0">
               <a:spcAft>
@@ -13881,7 +14041,7 @@
                 <a:ea typeface="Calibri" pitchFamily="34" charset="-122"/>
                 <a:cs typeface="Calibri" pitchFamily="34" charset="-120"/>
               </a:rPr>
-              <a:t> — 27 octobre 2026, 19 h UTC   ·   </a:t>
+              <a:t> — 27 octobre 2026, 14 h UTC   ·   </a:t>
             </a:r>
             <a:pPr indent="0" marL="0">
               <a:spcAft>
@@ -13922,7 +14082,7 @@
                 <a:ea typeface="Calibri" pitchFamily="34" charset="-122"/>
                 <a:cs typeface="Calibri" pitchFamily="34" charset="-120"/>
               </a:rPr>
-              <a:t>AVIS À MANIFESTATION D’INTÉRÊT N°003/CA/TAFOUK TV/2026</a:t>
+              <a:t>AGADEZ : LE GOUVERNEUR PRÉSIDE UNE RÉUNION ÉLARGIE DU CONSEIL RÉGIONAL DE SÉCURITÉ</a:t>
             </a:r>
             <a:endParaRPr lang="en-US" sz="1300" dirty="0"/>
           </a:p>
@@ -13967,7 +14127,7 @@
                   </a:extLst>
                 </a:hlinkClick>
               </a:rPr>
-              <a:t>Le Sahel</a:t>
+              <a:t>ANP — Agence Nigérienne Presse</a:t>
             </a:r>
             <a:pPr indent="0" marL="0">
               <a:spcAft>
@@ -13984,7 +14144,7 @@
                 <a:ea typeface="Calibri" pitchFamily="34" charset="-122"/>
                 <a:cs typeface="Calibri" pitchFamily="34" charset="-120"/>
               </a:rPr>
-              <a:t> — 27 octobre 2026, 14 h UTC   ·   </a:t>
+              <a:t> — 27 octobre 2026, 13 h UTC   ·   </a:t>
             </a:r>
             <a:pPr indent="0" marL="0">
               <a:spcAft>
@@ -14001,7 +14161,7 @@
                 <a:ea typeface="Calibri" pitchFamily="34" charset="-122"/>
                 <a:cs typeface="Calibri" pitchFamily="34" charset="-120"/>
               </a:rPr>
-              <a:t>Cotation : Non confirmé</a:t>
+              <a:t>Cotation : Probable</a:t>
             </a:r>
             <a:endParaRPr lang="en-US" sz="1300" dirty="0"/>
           </a:p>
@@ -14025,7 +14185,7 @@
                 <a:ea typeface="Calibri" pitchFamily="34" charset="-122"/>
                 <a:cs typeface="Calibri" pitchFamily="34" charset="-120"/>
               </a:rPr>
-              <a:t>AGADEZ : LE GOUVERNEUR PRÉSIDE UNE RÉUNION ÉLARGIE DU CONSEIL RÉGIONAL DE SÉCURITÉ</a:t>
+              <a:t>ALERTE – LA PRÉSIDENCE ANNONCE L’ENVOI D’UNITÉS DE L’ARMÉE NATIONALE AU NIGER</a:t>
             </a:r>
             <a:endParaRPr lang="en-US" sz="1300" dirty="0"/>
           </a:p>
@@ -14070,7 +14230,7 @@
                   </a:extLst>
                 </a:hlinkClick>
               </a:rPr>
-              <a:t>ANP — Agence Nigérienne Presse</a:t>
+              <a:t>tsa-algerie.com</a:t>
             </a:r>
             <a:pPr indent="0" marL="0">
               <a:spcAft>
@@ -14087,24 +14247,7 @@
                 <a:ea typeface="Calibri" pitchFamily="34" charset="-122"/>
                 <a:cs typeface="Calibri" pitchFamily="34" charset="-120"/>
               </a:rPr>
-              <a:t> — 27 octobre 2026, 13 h UTC   ·   </a:t>
-            </a:r>
-            <a:pPr indent="0" marL="0">
-              <a:spcAft>
-                <a:spcPts val="200"/>
-              </a:spcAft>
-              <a:buNone/>
-            </a:pPr>
-            <a:r>
-              <a:rPr lang="en-US" sz="1300" b="1" dirty="0">
-                <a:solidFill>
-                  <a:srgbClr val="1F2937"/>
-                </a:solidFill>
-                <a:latin typeface="Calibri" pitchFamily="34" charset="0"/>
-                <a:ea typeface="Calibri" pitchFamily="34" charset="-122"/>
-                <a:cs typeface="Calibri" pitchFamily="34" charset="-120"/>
-              </a:rPr>
-              <a:t>Cotation : Probable</a:t>
+              <a:t> — 26 octobre 2026, 15 h UTC</a:t>
             </a:r>
             <a:endParaRPr lang="en-US" sz="1300" dirty="0"/>
           </a:p>
@@ -14188,7 +14331,7 @@
                 <a:ea typeface="Calibri" pitchFamily="34" charset="-122"/>
                 <a:cs typeface="Calibri" pitchFamily="34" charset="-120"/>
               </a:rPr>
-              <a:t>|  27/10/26   |   22</a:t>
+              <a:t>|  28/10/26   |   22</a:t>
             </a:r>
             <a:endParaRPr lang="en-US" sz="1000" dirty="0"/>
           </a:p>
@@ -14454,7 +14597,7 @@
                 <a:ea typeface="Calibri" pitchFamily="34" charset="-122"/>
                 <a:cs typeface="Calibri" pitchFamily="34" charset="-120"/>
               </a:rPr>
-              <a:t>Indice de confiance : moyenne (incident vérifié le plus récent : 120 jours ; 2 signaux du jour)</a:t>
+              <a:t>Indice de confiance : faible (incident vérifié le plus récent : 121 jours ; aucun signal du jour)</a:t>
             </a:r>
             <a:endParaRPr lang="en-US" sz="1100" dirty="0"/>
           </a:p>
@@ -14493,7 +14636,7 @@
                 <a:ea typeface="Arial Narrow" pitchFamily="34" charset="-122"/>
                 <a:cs typeface="Arial Narrow" pitchFamily="34" charset="-120"/>
               </a:rPr>
-              <a:t>Seven shot dead by gunmen at church funeral in Jordan, officials say</a:t>
+              <a:t>Woman killed by Tema-Afienya train as residents demand footbridge</a:t>
             </a:r>
             <a:endParaRPr lang="en-US" sz="2200" dirty="0"/>
           </a:p>
@@ -14558,7 +14701,7 @@
                 <a:ea typeface="Calibri" pitchFamily="34" charset="-122"/>
                 <a:cs typeface="Calibri" pitchFamily="34" charset="-120"/>
               </a:rPr>
-              <a:t>Fait rapporté le vendredi 23 octobre 2026. Lieu : Ghana. Actualité sécuritaire. Une seule source à ce stade (JoyOnline) : à confirmer par un second média.</a:t>
+              <a:t>Fait rapporté le mercredi 28 octobre 2026. Lieu : Ghana. Actualité sécuritaire. Une seule source à ce stade (JoyOnline) : à confirmer par un second média.</a:t>
             </a:r>
             <a:endParaRPr lang="en-US" sz="1400" dirty="0"/>
           </a:p>
@@ -14593,15 +14736,32 @@
               <a:buNone/>
             </a:pPr>
             <a:r>
+              <a:rPr lang="en-US" sz="1400" b="1" dirty="0">
+                <a:solidFill>
+                  <a:srgbClr val="1F2937"/>
+                </a:solidFill>
+                <a:latin typeface="Calibri" pitchFamily="34" charset="0"/>
+                <a:ea typeface="Calibri" pitchFamily="34" charset="-122"/>
+                <a:cs typeface="Calibri" pitchFamily="34" charset="-120"/>
+              </a:rPr>
+              <a:t>JoyOnline : </a:t>
+            </a:r>
+            <a:pPr indent="0" marL="0">
+              <a:spcAft>
+                <a:spcPts val="300"/>
+              </a:spcAft>
+              <a:buNone/>
+            </a:pPr>
+            <a:r>
               <a:rPr lang="en-US" sz="1400" i="1" dirty="0">
                 <a:solidFill>
-                  <a:srgbClr val="6B7280"/>
-                </a:solidFill>
-                <a:latin typeface="Calibri" pitchFamily="34" charset="0"/>
-                <a:ea typeface="Calibri" pitchFamily="34" charset="-122"/>
-                <a:cs typeface="Calibri" pitchFamily="34" charset="-120"/>
-              </a:rPr>
-              <a:t>Les médias n'en publient que le titre dans leur flux : le détail est à lire dans l'article (lien ci-dessous).</a:t>
+                  <a:srgbClr val="1F2937"/>
+                </a:solidFill>
+                <a:latin typeface="Calibri" pitchFamily="34" charset="0"/>
+                <a:ea typeface="Calibri" pitchFamily="34" charset="-122"/>
+                <a:cs typeface="Calibri" pitchFamily="34" charset="-120"/>
+              </a:rPr>
+              <a:t>« Une femme non identifiée a été tuée après avoir été heurtée par un train de voyageurs sur la ligne ferroviaire Tema-Afienya à Mataheko-Sebrepo, incitant les habitants à renouveler leurs appels en faveur d'une passerelle pour assurer une traversée plus sûre entre les communautés de la région. »</a:t>
             </a:r>
             <a:endParaRPr lang="en-US" sz="1400" dirty="0"/>
           </a:p>
@@ -14644,7 +14804,7 @@
                 <a:ea typeface="Calibri" pitchFamily="34" charset="-122"/>
                 <a:cs typeface="Calibri" pitchFamily="34" charset="-120"/>
               </a:rPr>
-              <a:t>Menace armée sur les axes et localités de la zone : réévaluer les déplacements terrestres (horaires, convois, itinéraires de repli) et les consignes des sites et des personnels présents à proximité.</a:t>
+              <a:t>Fait sécuritaire à suivre : vérifier son incidence sur les sites, les itinéraires et les personnels présents dans la zone.</a:t>
             </a:r>
             <a:endParaRPr lang="en-US" sz="1400" dirty="0"/>
           </a:p>
@@ -14700,15 +14860,15 @@
               <a:buNone/>
             </a:pPr>
             <a:r>
-              <a:rPr lang="en-US" sz="1400" dirty="0">
-                <a:solidFill>
-                  <a:srgbClr val="1F2937"/>
-                </a:solidFill>
-                <a:latin typeface="Calibri" pitchFamily="34" charset="0"/>
-                <a:ea typeface="Calibri" pitchFamily="34" charset="-122"/>
-                <a:cs typeface="Calibri" pitchFamily="34" charset="-120"/>
-              </a:rPr>
-              <a:t> — 23 octobre 2026, 18 h UTC</a:t>
+              <a:rPr lang="en-US" sz="1400" b="1" dirty="0">
+                <a:solidFill>
+                  <a:srgbClr val="1F2937"/>
+                </a:solidFill>
+                <a:latin typeface="Calibri" pitchFamily="34" charset="0"/>
+                <a:ea typeface="Calibri" pitchFamily="34" charset="-122"/>
+                <a:cs typeface="Calibri" pitchFamily="34" charset="-120"/>
+              </a:rPr>
+              <a:t> — 28 octobre 2026, 7 h UTC   ·   Cotation : Probable</a:t>
             </a:r>
             <a:endParaRPr lang="en-US" sz="1400" dirty="0"/>
           </a:p>
@@ -14733,7 +14893,7 @@
         <p:spPr>
           <a:xfrm>
             <a:off x="7635240" y="2075688"/>
-            <a:ext cx="4114800" cy="2160270"/>
+            <a:ext cx="4114800" cy="2467273"/>
           </a:xfrm>
           <a:prstGeom prst="rect">
             <a:avLst/>
@@ -14748,7 +14908,7 @@
         </p:nvSpPr>
         <p:spPr>
           <a:xfrm>
-            <a:off x="7635240" y="4272534"/>
+            <a:off x="7635240" y="4579537"/>
             <a:ext cx="4114800" cy="256032"/>
           </a:xfrm>
           <a:prstGeom prst="rect">
@@ -14864,7 +15024,7 @@
                 <a:ea typeface="Calibri" pitchFamily="34" charset="-122"/>
                 <a:cs typeface="Calibri" pitchFamily="34" charset="-120"/>
               </a:rPr>
-              <a:t>|  27/10/26   |   23</a:t>
+              <a:t>|  28/10/26   |   23</a:t>
             </a:r>
             <a:endParaRPr lang="en-US" sz="1000" dirty="0"/>
           </a:p>
@@ -15137,7 +15297,7 @@
                 <a:ea typeface="Calibri" pitchFamily="34" charset="-122"/>
                 <a:cs typeface="Calibri" pitchFamily="34" charset="-120"/>
               </a:rPr>
-              <a:t>NPP WALEWALE CONSTITUENCY CONDEMNS PERSONAL ATTACKS AGAINST MP, URGES PARTY DISCIPLINE</a:t>
+              <a:t>SEVEN SHOT DEAD BY GUNMEN AT CHURCH FUNERAL IN JORDAN, OFFICIALS SAY</a:t>
             </a:r>
             <a:endParaRPr lang="en-US" sz="1300" dirty="0"/>
           </a:p>
@@ -15199,7 +15359,7 @@
                 <a:ea typeface="Calibri" pitchFamily="34" charset="-122"/>
                 <a:cs typeface="Calibri" pitchFamily="34" charset="-120"/>
               </a:rPr>
-              <a:t> — 23 octobre 2026, 15 h UTC</a:t>
+              <a:t> — 23 octobre 2026, 18 h UTC</a:t>
             </a:r>
             <a:endParaRPr lang="en-US" sz="1300" dirty="0"/>
           </a:p>
@@ -15223,7 +15383,7 @@
                 <a:ea typeface="Calibri" pitchFamily="34" charset="-122"/>
                 <a:cs typeface="Calibri" pitchFamily="34" charset="-120"/>
               </a:rPr>
-              <a:t>GAF TO STAGE LAND COMBAT FIREPOWER DEMONSTRATION AT BUNDASE ON OCTOBER 30</a:t>
+              <a:t>NPP WALEWALE CONSTITUENCY CONDEMNS PERSONAL ATTACKS AGAINST MP, URGES PARTY DISCIPLINE</a:t>
             </a:r>
             <a:endParaRPr lang="en-US" sz="1300" dirty="0"/>
           </a:p>
@@ -15285,7 +15445,7 @@
                 <a:ea typeface="Calibri" pitchFamily="34" charset="-122"/>
                 <a:cs typeface="Calibri" pitchFamily="34" charset="-120"/>
               </a:rPr>
-              <a:t> — 23 octobre 2026, 16 h UTC</a:t>
+              <a:t> — 23 octobre 2026, 15 h UTC</a:t>
             </a:r>
             <a:endParaRPr lang="en-US" sz="1300" dirty="0"/>
           </a:p>
@@ -15309,7 +15469,7 @@
                 <a:ea typeface="Calibri" pitchFamily="34" charset="-122"/>
                 <a:cs typeface="Calibri" pitchFamily="34" charset="-120"/>
               </a:rPr>
-              <a:t>LES FORTES PLUIES, PRINCIPALE MENACE POUR LA CULTURE DU CACAO</a:t>
+              <a:t>GAF TO STAGE LAND COMBAT FIREPOWER DEMONSTRATION AT BUNDASE ON OCTOBER 30</a:t>
             </a:r>
             <a:endParaRPr lang="en-US" sz="1300" dirty="0"/>
           </a:p>
@@ -15354,7 +15514,7 @@
                   </a:extLst>
                 </a:hlinkClick>
               </a:rPr>
-              <a:t>AllAfrica (GH)</a:t>
+              <a:t>JoyOnline</a:t>
             </a:r>
             <a:pPr indent="0" marL="0">
               <a:spcAft>
@@ -15371,24 +15531,7 @@
                 <a:ea typeface="Calibri" pitchFamily="34" charset="-122"/>
                 <a:cs typeface="Calibri" pitchFamily="34" charset="-120"/>
               </a:rPr>
-              <a:t> — 16 octobre 2026, 7 h UTC   ·   </a:t>
-            </a:r>
-            <a:pPr indent="0" marL="0">
-              <a:spcAft>
-                <a:spcPts val="200"/>
-              </a:spcAft>
-              <a:buNone/>
-            </a:pPr>
-            <a:r>
-              <a:rPr lang="en-US" sz="1300" b="1" dirty="0">
-                <a:solidFill>
-                  <a:srgbClr val="1F2937"/>
-                </a:solidFill>
-                <a:latin typeface="Calibri" pitchFamily="34" charset="0"/>
-                <a:ea typeface="Calibri" pitchFamily="34" charset="-122"/>
-                <a:cs typeface="Calibri" pitchFamily="34" charset="-120"/>
-              </a:rPr>
-              <a:t>Cotation : Probable</a:t>
+              <a:t> — 23 octobre 2026, 16 h UTC</a:t>
             </a:r>
             <a:endParaRPr lang="en-US" sz="1300" dirty="0"/>
           </a:p>
@@ -15412,7 +15555,7 @@
                 <a:ea typeface="Calibri" pitchFamily="34" charset="-122"/>
                 <a:cs typeface="Calibri" pitchFamily="34" charset="-120"/>
               </a:rPr>
-              <a:t>(EN) GRASAG PRESIDENT CALLS FOR SUSTAINABLE FUNDING FOR AGRICULTURAL RESEARCH IN AFRICA</a:t>
+              <a:t>LES FORTES PLUIES, PRINCIPALE MENACE POUR LA CULTURE DU CACAO</a:t>
             </a:r>
             <a:endParaRPr lang="en-US" sz="1300" dirty="0"/>
           </a:p>
@@ -15457,7 +15600,7 @@
                   </a:extLst>
                 </a:hlinkClick>
               </a:rPr>
-              <a:t>JoyOnline</a:t>
+              <a:t>AllAfrica (GH)</a:t>
             </a:r>
             <a:pPr indent="0" marL="0">
               <a:spcAft>
@@ -15474,7 +15617,7 @@
                 <a:ea typeface="Calibri" pitchFamily="34" charset="-122"/>
                 <a:cs typeface="Calibri" pitchFamily="34" charset="-120"/>
               </a:rPr>
-              <a:t> — 27 octobre 2026, 19 h UTC   ·   </a:t>
+              <a:t> — 16 octobre 2026, 7 h UTC   ·   </a:t>
             </a:r>
             <a:pPr indent="0" marL="0">
               <a:spcAft>
@@ -15515,7 +15658,7 @@
                 <a:ea typeface="Calibri" pitchFamily="34" charset="-122"/>
                 <a:cs typeface="Calibri" pitchFamily="34" charset="-120"/>
               </a:rPr>
-              <a:t>(EN) GHANA DEVELOPING FIRST NATIONAL ACTION PLAN ON YOUTH, PEACE AND SECURITY – OSMAN AYARIGA</a:t>
+              <a:t>LE PRÉSIDENT DU GRASAG APPELLE À UN FINANCEMENT DURABLE DE LA RECHERCHE AGRICOLE EN AFRIQUE</a:t>
             </a:r>
             <a:endParaRPr lang="en-US" sz="1300" dirty="0"/>
           </a:p>
@@ -15577,7 +15720,7 @@
                 <a:ea typeface="Calibri" pitchFamily="34" charset="-122"/>
                 <a:cs typeface="Calibri" pitchFamily="34" charset="-120"/>
               </a:rPr>
-              <a:t> — 27 octobre 2026, 18 h UTC   ·   </a:t>
+              <a:t> — 27 octobre 2026, 19 h UTC   ·   </a:t>
             </a:r>
             <a:pPr indent="0" marL="0">
               <a:spcAft>
@@ -15678,7 +15821,7 @@
                 <a:ea typeface="Calibri" pitchFamily="34" charset="-122"/>
                 <a:cs typeface="Calibri" pitchFamily="34" charset="-120"/>
               </a:rPr>
-              <a:t>|  27/10/26   |   24</a:t>
+              <a:t>|  28/10/26   |   24</a:t>
             </a:r>
             <a:endParaRPr lang="en-US" sz="1000" dirty="0"/>
           </a:p>
@@ -15951,7 +16094,7 @@
                 <a:ea typeface="Calibri" pitchFamily="34" charset="-122"/>
                 <a:cs typeface="Calibri" pitchFamily="34" charset="-120"/>
               </a:rPr>
-              <a:t>THREE ARRESTED IN ATEWA FOREST AS NAIMOS LAUNCHES OPERATION GREEN SHIELD</a:t>
+              <a:t>LE GHANA ÉLABORE SON PREMIER PLAN D’ACTION NATIONAL SUR LA JEUNESSE, LA PAIX ET LA SÉCURITÉ – OSMAN AYARIGA</a:t>
             </a:r>
             <a:endParaRPr lang="en-US" sz="1300" dirty="0"/>
           </a:p>
@@ -16013,7 +16156,7 @@
                 <a:ea typeface="Calibri" pitchFamily="34" charset="-122"/>
                 <a:cs typeface="Calibri" pitchFamily="34" charset="-120"/>
               </a:rPr>
-              <a:t> — 27 octobre 2026, 17 h UTC   ·   </a:t>
+              <a:t> — 27 octobre 2026, 18 h UTC   ·   </a:t>
             </a:r>
             <a:pPr indent="0" marL="0">
               <a:spcAft>
@@ -16054,7 +16197,7 @@
                 <a:ea typeface="Calibri" pitchFamily="34" charset="-122"/>
                 <a:cs typeface="Calibri" pitchFamily="34" charset="-120"/>
               </a:rPr>
-              <a:t>GHANA CHALLENGES UN TO TURN HISTORICAL JUSTICE PROMISES INTO ACTION</a:t>
+              <a:t>THREE ARRESTED IN ATEWA FOREST AS NAIMOS LAUNCHES OPERATION GREEN SHIELD</a:t>
             </a:r>
             <a:endParaRPr lang="en-US" sz="1300" dirty="0"/>
           </a:p>
@@ -16099,7 +16242,7 @@
                   </a:extLst>
                 </a:hlinkClick>
               </a:rPr>
-              <a:t>GBC Ghana Online</a:t>
+              <a:t>JoyOnline</a:t>
             </a:r>
             <a:pPr indent="0" marL="0">
               <a:spcAft>
@@ -16116,7 +16259,7 @@
                 <a:ea typeface="Calibri" pitchFamily="34" charset="-122"/>
                 <a:cs typeface="Calibri" pitchFamily="34" charset="-120"/>
               </a:rPr>
-              <a:t> — 27 octobre 2026, 15 h UTC   ·   </a:t>
+              <a:t> — 27 octobre 2026, 17 h UTC   ·   </a:t>
             </a:r>
             <a:pPr indent="0" marL="0">
               <a:spcAft>
@@ -16133,7 +16276,7 @@
                 <a:ea typeface="Calibri" pitchFamily="34" charset="-122"/>
                 <a:cs typeface="Calibri" pitchFamily="34" charset="-120"/>
               </a:rPr>
-              <a:t>Cotation : Non confirmé</a:t>
+              <a:t>Cotation : Probable</a:t>
             </a:r>
             <a:endParaRPr lang="en-US" sz="1300" dirty="0"/>
           </a:p>
@@ -16157,7 +16300,7 @@
                 <a:ea typeface="Calibri" pitchFamily="34" charset="-122"/>
                 <a:cs typeface="Calibri" pitchFamily="34" charset="-120"/>
               </a:rPr>
-              <a:t>(EN) GALAMSEY WILL PERSIST IF FINANCIERS GO UNTOUCHED — SECURITY ANALYST</a:t>
+              <a:t>GHANA CHALLENGES UN TO TURN HISTORICAL JUSTICE PROMISES INTO ACTION</a:t>
             </a:r>
             <a:endParaRPr lang="en-US" sz="1300" dirty="0"/>
           </a:p>
@@ -16219,7 +16362,24 @@
                 <a:ea typeface="Calibri" pitchFamily="34" charset="-122"/>
                 <a:cs typeface="Calibri" pitchFamily="34" charset="-120"/>
               </a:rPr>
-              <a:t> — 27 octobre 2026, 12 h UTC</a:t>
+              <a:t> — 27 octobre 2026, 15 h UTC   ·   </a:t>
+            </a:r>
+            <a:pPr indent="0" marL="0">
+              <a:spcAft>
+                <a:spcPts val="200"/>
+              </a:spcAft>
+              <a:buNone/>
+            </a:pPr>
+            <a:r>
+              <a:rPr lang="en-US" sz="1300" b="1" dirty="0">
+                <a:solidFill>
+                  <a:srgbClr val="1F2937"/>
+                </a:solidFill>
+                <a:latin typeface="Calibri" pitchFamily="34" charset="0"/>
+                <a:ea typeface="Calibri" pitchFamily="34" charset="-122"/>
+                <a:cs typeface="Calibri" pitchFamily="34" charset="-120"/>
+              </a:rPr>
+              <a:t>Cotation : Non confirmé</a:t>
             </a:r>
             <a:endParaRPr lang="en-US" sz="1300" dirty="0"/>
           </a:p>
@@ -16243,7 +16403,7 @@
                 <a:ea typeface="Calibri" pitchFamily="34" charset="-122"/>
                 <a:cs typeface="Calibri" pitchFamily="34" charset="-120"/>
               </a:rPr>
-              <a:t>GHANA MUST OWN DIGITAL INFRASTRUCTURE TO ENSURE DATA SECURITY — APAAK</a:t>
+              <a:t>GALAMSEY PERSISTERA SI LES FINANCIERS NE SONT PAS TOUCHÉS — ANALYSTE EN SÉCURITÉ</a:t>
             </a:r>
             <a:endParaRPr lang="en-US" sz="1300" dirty="0"/>
           </a:p>
@@ -16288,7 +16448,7 @@
                   </a:extLst>
                 </a:hlinkClick>
               </a:rPr>
-              <a:t>Ghanaian Times</a:t>
+              <a:t>GBC Ghana Online</a:t>
             </a:r>
             <a:pPr indent="0" marL="0">
               <a:spcAft>
@@ -16305,24 +16465,7 @@
                 <a:ea typeface="Calibri" pitchFamily="34" charset="-122"/>
                 <a:cs typeface="Calibri" pitchFamily="34" charset="-120"/>
               </a:rPr>
-              <a:t> — 27 octobre 2026, 8 h UTC   ·   </a:t>
-            </a:r>
-            <a:pPr indent="0" marL="0">
-              <a:spcAft>
-                <a:spcPts val="200"/>
-              </a:spcAft>
-              <a:buNone/>
-            </a:pPr>
-            <a:r>
-              <a:rPr lang="en-US" sz="1300" b="1" dirty="0">
-                <a:solidFill>
-                  <a:srgbClr val="1F2937"/>
-                </a:solidFill>
-                <a:latin typeface="Calibri" pitchFamily="34" charset="0"/>
-                <a:ea typeface="Calibri" pitchFamily="34" charset="-122"/>
-                <a:cs typeface="Calibri" pitchFamily="34" charset="-120"/>
-              </a:rPr>
-              <a:t>Cotation : Non confirmé</a:t>
+              <a:t> — 27 octobre 2026, 12 h UTC</a:t>
             </a:r>
             <a:endParaRPr lang="en-US" sz="1300" dirty="0"/>
           </a:p>
@@ -16406,7 +16549,7 @@
                 <a:ea typeface="Calibri" pitchFamily="34" charset="-122"/>
                 <a:cs typeface="Calibri" pitchFamily="34" charset="-120"/>
               </a:rPr>
-              <a:t>|  27/10/26   |   25</a:t>
+              <a:t>|  28/10/26   |   25</a:t>
             </a:r>
             <a:endParaRPr lang="en-US" sz="1000" dirty="0"/>
           </a:p>
@@ -16722,7 +16865,7 @@
                 <a:ea typeface="Calibri" pitchFamily="34" charset="-122"/>
                 <a:cs typeface="Calibri" pitchFamily="34" charset="-120"/>
               </a:rPr>
-              <a:t>Indice de confiance : moyenne (incident vérifié le plus récent : 121 jours ; 1 signal du jour)</a:t>
+              <a:t>Indice de confiance : faible (incident vérifié le plus récent : 122 jours ; aucun signal du jour)</a:t>
             </a:r>
             <a:endParaRPr lang="en-US" sz="1100" dirty="0"/>
           </a:p>
@@ -17149,7 +17292,7 @@
                 <a:ea typeface="Calibri" pitchFamily="34" charset="-122"/>
                 <a:cs typeface="Calibri" pitchFamily="34" charset="-120"/>
               </a:rPr>
-              <a:t>|  27/10/26   |   26</a:t>
+              <a:t>|  28/10/26   |   26</a:t>
             </a:r>
             <a:endParaRPr lang="en-US" sz="1000" dirty="0"/>
           </a:p>
@@ -17558,7 +17701,7 @@
                 <a:ea typeface="Calibri" pitchFamily="34" charset="-122"/>
                 <a:cs typeface="Calibri" pitchFamily="34" charset="-120"/>
               </a:rPr>
-              <a:t>SOUTENU PAR L’UNION AFRICAINE, LE TOGOLAIS GILBERT HOUNGBO RÉUSSIRA-T-IL À CONSERVER LA TÊTE DE L’OIT ?</a:t>
+              <a:t>GÉNIE IMHOTEP SAISON 3 : LE LYCÉE ZÉBÉVI STOPPE LE LYCÉE TOKOIN2 DANS SON ÉLAN</a:t>
             </a:r>
             <a:endParaRPr lang="en-US" sz="1300" dirty="0"/>
           </a:p>
@@ -17603,7 +17746,7 @@
                   </a:extLst>
                 </a:hlinkClick>
               </a:rPr>
-              <a:t>Jeune Afrique</a:t>
+              <a:t>Le Nouveau Reporter</a:t>
             </a:r>
             <a:pPr indent="0" marL="0">
               <a:spcAft>
@@ -17620,7 +17763,7 @@
                 <a:ea typeface="Calibri" pitchFamily="34" charset="-122"/>
                 <a:cs typeface="Calibri" pitchFamily="34" charset="-120"/>
               </a:rPr>
-              <a:t> — 27 octobre 2026, 13 h UTC   ·   </a:t>
+              <a:t> — 28 octobre 2026, 8 h UTC   ·   </a:t>
             </a:r>
             <a:pPr indent="0" marL="0">
               <a:spcAft>
@@ -17637,7 +17780,7 @@
                 <a:ea typeface="Calibri" pitchFamily="34" charset="-122"/>
                 <a:cs typeface="Calibri" pitchFamily="34" charset="-120"/>
               </a:rPr>
-              <a:t>Cotation : Probable</a:t>
+              <a:t>Cotation : Non confirmé</a:t>
             </a:r>
             <a:endParaRPr lang="en-US" sz="1300" dirty="0"/>
           </a:p>
@@ -17661,7 +17804,7 @@
                 <a:ea typeface="Calibri" pitchFamily="34" charset="-122"/>
                 <a:cs typeface="Calibri" pitchFamily="34" charset="-120"/>
               </a:rPr>
-              <a:t>VERS UNE PAIX DES CHAMPS ?</a:t>
+              <a:t>TOGO : LA SÉCURITÉ RENFORCÉE SUR LE LITTORAL DE LOMÉ APRÈS LE DÉMANTÈLEMENT DES INSTALLATIONS ILLÉGALES</a:t>
             </a:r>
             <a:endParaRPr lang="en-US" sz="1300" dirty="0"/>
           </a:p>
@@ -17682,7 +17825,7 @@
                 <a:ea typeface="Calibri" pitchFamily="34" charset="-122"/>
                 <a:cs typeface="Calibri" pitchFamily="34" charset="-120"/>
               </a:rPr>
-              <a:t>Source : </a:t>
+              <a:t>Sources : </a:t>
             </a:r>
             <a:pPr indent="0" marL="0">
               <a:spcAft>
@@ -17706,7 +17849,7 @@
                   </a:extLst>
                 </a:hlinkClick>
               </a:rPr>
-              <a:t>AllAfrica (TG)</a:t>
+              <a:t>24heureinfo.com · Togo Actualite · Icilome</a:t>
             </a:r>
             <a:pPr indent="0" marL="0">
               <a:spcAft>
@@ -17723,7 +17866,24 @@
                 <a:ea typeface="Calibri" pitchFamily="34" charset="-122"/>
                 <a:cs typeface="Calibri" pitchFamily="34" charset="-120"/>
               </a:rPr>
-              <a:t> — 26 octobre 2026, 15 h UTC</a:t>
+              <a:t> — 28 octobre 2026, 7 h UTC   ·   </a:t>
+            </a:r>
+            <a:pPr indent="0" marL="0">
+              <a:spcAft>
+                <a:spcPts val="200"/>
+              </a:spcAft>
+              <a:buNone/>
+            </a:pPr>
+            <a:r>
+              <a:rPr lang="en-US" sz="1300" b="1" dirty="0">
+                <a:solidFill>
+                  <a:srgbClr val="1F2937"/>
+                </a:solidFill>
+                <a:latin typeface="Calibri" pitchFamily="34" charset="0"/>
+                <a:ea typeface="Calibri" pitchFamily="34" charset="-122"/>
+                <a:cs typeface="Calibri" pitchFamily="34" charset="-120"/>
+              </a:rPr>
+              <a:t>Cotation : Confirmé</a:t>
             </a:r>
             <a:endParaRPr lang="en-US" sz="1300" dirty="0"/>
           </a:p>
@@ -17747,7 +17907,7 @@
                 <a:ea typeface="Calibri" pitchFamily="34" charset="-122"/>
                 <a:cs typeface="Calibri" pitchFamily="34" charset="-120"/>
               </a:rPr>
-              <a:t>LITTORAL DE LOMÉ : UN DISPOSITIF SÉCURITAIRE RENFORCÉ APRÈS LE DÉMANTÈLEMENT DES INSTALLATIONS ILLÉGALES</a:t>
+              <a:t>SOUTENU PAR L’UNION AFRICAINE, LE TOGOLAIS GILBERT HOUNGBO RÉUSSIRA-T-IL À CONSERVER LA TÊTE DE L’OIT ?</a:t>
             </a:r>
             <a:endParaRPr lang="en-US" sz="1300" dirty="0"/>
           </a:p>
@@ -17768,7 +17928,7 @@
                 <a:ea typeface="Calibri" pitchFamily="34" charset="-122"/>
                 <a:cs typeface="Calibri" pitchFamily="34" charset="-120"/>
               </a:rPr>
-              <a:t>Sources : </a:t>
+              <a:t>Source : </a:t>
             </a:r>
             <a:pPr indent="0" marL="0">
               <a:spcAft>
@@ -17792,7 +17952,7 @@
                   </a:extLst>
                 </a:hlinkClick>
               </a:rPr>
-              <a:t>Togo Actualite · Icilome</a:t>
+              <a:t>Jeune Afrique</a:t>
             </a:r>
             <a:pPr indent="0" marL="0">
               <a:spcAft>
@@ -17809,7 +17969,7 @@
                 <a:ea typeface="Calibri" pitchFamily="34" charset="-122"/>
                 <a:cs typeface="Calibri" pitchFamily="34" charset="-120"/>
               </a:rPr>
-              <a:t> — 26 octobre 2026, 15 h UTC   ·   </a:t>
+              <a:t> — 27 octobre 2026, 13 h UTC   ·   </a:t>
             </a:r>
             <a:pPr indent="0" marL="0">
               <a:spcAft>
@@ -17826,7 +17986,7 @@
                 <a:ea typeface="Calibri" pitchFamily="34" charset="-122"/>
                 <a:cs typeface="Calibri" pitchFamily="34" charset="-120"/>
               </a:rPr>
-              <a:t>Cotation : Confirmé</a:t>
+              <a:t>Cotation : Probable</a:t>
             </a:r>
             <a:endParaRPr lang="en-US" sz="1300" dirty="0"/>
           </a:p>
@@ -17850,7 +18010,7 @@
                 <a:ea typeface="Calibri" pitchFamily="34" charset="-122"/>
                 <a:cs typeface="Calibri" pitchFamily="34" charset="-120"/>
               </a:rPr>
-              <a:t>STOCKS DE SÉCURITÉ - RECORD DE 31 000 TONNES COLLECTÉES EN 2025</a:t>
+              <a:t>VERS UNE PAIX DES CHAMPS ?</a:t>
             </a:r>
             <a:endParaRPr lang="en-US" sz="1300" dirty="0"/>
           </a:p>
@@ -17912,7 +18072,7 @@
                 <a:ea typeface="Calibri" pitchFamily="34" charset="-122"/>
                 <a:cs typeface="Calibri" pitchFamily="34" charset="-120"/>
               </a:rPr>
-              <a:t> — 26 octobre 2026, 11 h UTC</a:t>
+              <a:t> — 26 octobre 2026, 15 h UTC</a:t>
             </a:r>
             <a:endParaRPr lang="en-US" sz="1300" dirty="0"/>
           </a:p>
@@ -17996,7 +18156,7 @@
                 <a:ea typeface="Calibri" pitchFamily="34" charset="-122"/>
                 <a:cs typeface="Calibri" pitchFamily="34" charset="-120"/>
               </a:rPr>
-              <a:t>|  27/10/26   |   27</a:t>
+              <a:t>|  28/10/26   |   27</a:t>
             </a:r>
             <a:endParaRPr lang="en-US" sz="1000" dirty="0"/>
           </a:p>
@@ -18319,7 +18479,7 @@
                 <a:ea typeface="Calibri" pitchFamily="34" charset="-122"/>
                 <a:cs typeface="Calibri" pitchFamily="34" charset="-120"/>
               </a:rPr>
-              <a:t>LA PLAGE DE LOMÉ SOUS SURVEILLANCE</a:t>
+              <a:t>STOCKS DE SÉCURITÉ - RECORD DE 31 000 TONNES COLLECTÉES EN 2025</a:t>
             </a:r>
             <a:endParaRPr lang="en-US" sz="1300" dirty="0"/>
           </a:p>
@@ -18405,7 +18565,7 @@
                 <a:ea typeface="Calibri" pitchFamily="34" charset="-122"/>
                 <a:cs typeface="Calibri" pitchFamily="34" charset="-120"/>
               </a:rPr>
-              <a:t>TSÉVIÉ : LES FORCES DE SÉCURITÉ DÉPLOYÉES SUR LE SITE DU MEETING REPORTÉ DU CNCC</a:t>
+              <a:t>LA PLAGE DE LOMÉ SOUS SURVEILLANCE</a:t>
             </a:r>
             <a:endParaRPr lang="en-US" sz="1300" dirty="0"/>
           </a:p>
@@ -18450,7 +18610,7 @@
                   </a:extLst>
                 </a:hlinkClick>
               </a:rPr>
-              <a:t>24heureinfo.com</a:t>
+              <a:t>AllAfrica (TG)</a:t>
             </a:r>
             <a:pPr indent="0" marL="0">
               <a:spcAft>
@@ -18467,7 +18627,7 @@
                 <a:ea typeface="Calibri" pitchFamily="34" charset="-122"/>
                 <a:cs typeface="Calibri" pitchFamily="34" charset="-120"/>
               </a:rPr>
-              <a:t> — 25 octobre 2026, 20 h UTC</a:t>
+              <a:t> — 26 octobre 2026, 11 h UTC</a:t>
             </a:r>
             <a:endParaRPr lang="en-US" sz="1300" dirty="0"/>
           </a:p>
@@ -18491,7 +18651,7 @@
                 <a:ea typeface="Calibri" pitchFamily="34" charset="-122"/>
                 <a:cs typeface="Calibri" pitchFamily="34" charset="-120"/>
               </a:rPr>
-              <a:t>EBOLA : AFRICA CDC CONVOQUE LES MINISTRES AFRICAINS DE LA SANTÉ EN URGENCE</a:t>
+              <a:t>TSÉVIÉ : LES FORCES DE SÉCURITÉ DÉPLOYÉES SUR LE SITE DU MEETING REPORTÉ DU CNCC</a:t>
             </a:r>
             <a:endParaRPr lang="en-US" sz="1300" dirty="0"/>
           </a:p>
@@ -18553,7 +18713,7 @@
                 <a:ea typeface="Calibri" pitchFamily="34" charset="-122"/>
                 <a:cs typeface="Calibri" pitchFamily="34" charset="-120"/>
               </a:rPr>
-              <a:t> — 25 octobre 2026, 10 h UTC</a:t>
+              <a:t> — 25 octobre 2026, 20 h UTC</a:t>
             </a:r>
             <a:endParaRPr lang="en-US" sz="1300" dirty="0"/>
           </a:p>
@@ -18577,7 +18737,7 @@
                 <a:ea typeface="Calibri" pitchFamily="34" charset="-122"/>
                 <a:cs typeface="Calibri" pitchFamily="34" charset="-120"/>
               </a:rPr>
-              <a:t>TOGO : AGRICULTURE, NUCLÉAIRE… LES DÉPUTÉS ADOPTENT QUATRE TEXTES STRATÉGIQUES</a:t>
+              <a:t>EBOLA : AFRICA CDC CONVOQUE LES MINISTRES AFRICAINS DE LA SANTÉ EN URGENCE</a:t>
             </a:r>
             <a:endParaRPr lang="en-US" sz="1300" dirty="0"/>
           </a:p>
@@ -18598,7 +18758,7 @@
                 <a:ea typeface="Calibri" pitchFamily="34" charset="-122"/>
                 <a:cs typeface="Calibri" pitchFamily="34" charset="-120"/>
               </a:rPr>
-              <a:t>Sources : </a:t>
+              <a:t>Source : </a:t>
             </a:r>
             <a:pPr indent="0" marL="0">
               <a:spcAft>
@@ -18622,7 +18782,7 @@
                   </a:extLst>
                 </a:hlinkClick>
               </a:rPr>
-              <a:t>24heureinfo.com · ATOP — Agence Togolaise Presse</a:t>
+              <a:t>24heureinfo.com</a:t>
             </a:r>
             <a:pPr indent="0" marL="0">
               <a:spcAft>
@@ -18639,24 +18799,7 @@
                 <a:ea typeface="Calibri" pitchFamily="34" charset="-122"/>
                 <a:cs typeface="Calibri" pitchFamily="34" charset="-120"/>
               </a:rPr>
-              <a:t> — 23 octobre 2026, 17 h UTC   ·   </a:t>
-            </a:r>
-            <a:pPr indent="0" marL="0">
-              <a:spcAft>
-                <a:spcPts val="200"/>
-              </a:spcAft>
-              <a:buNone/>
-            </a:pPr>
-            <a:r>
-              <a:rPr lang="en-US" sz="1300" b="1" dirty="0">
-                <a:solidFill>
-                  <a:srgbClr val="1F2937"/>
-                </a:solidFill>
-                <a:latin typeface="Calibri" pitchFamily="34" charset="0"/>
-                <a:ea typeface="Calibri" pitchFamily="34" charset="-122"/>
-                <a:cs typeface="Calibri" pitchFamily="34" charset="-120"/>
-              </a:rPr>
-              <a:t>Cotation : Confirmé</a:t>
+              <a:t> — 25 octobre 2026, 10 h UTC</a:t>
             </a:r>
             <a:endParaRPr lang="en-US" sz="1300" dirty="0"/>
           </a:p>
@@ -18740,7 +18883,7 @@
                 <a:ea typeface="Calibri" pitchFamily="34" charset="-122"/>
                 <a:cs typeface="Calibri" pitchFamily="34" charset="-120"/>
               </a:rPr>
-              <a:t>|  27/10/26   |   28</a:t>
+              <a:t>|  28/10/26   |   28</a:t>
             </a:r>
             <a:endParaRPr lang="en-US" sz="1000" dirty="0"/>
           </a:p>
@@ -19006,7 +19149,7 @@
                 <a:ea typeface="Calibri" pitchFamily="34" charset="-122"/>
                 <a:cs typeface="Calibri" pitchFamily="34" charset="-120"/>
               </a:rPr>
-              <a:t>Indice de confiance : faible (incident vérifié le plus récent : 120 jours ; aucun signal du jour)</a:t>
+              <a:t>Indice de confiance : faible (incident vérifié le plus récent : 121 jours ; aucun signal du jour)</a:t>
             </a:r>
             <a:endParaRPr lang="en-US" sz="1100" dirty="0"/>
           </a:p>
@@ -19416,7 +19559,7 @@
                 <a:ea typeface="Calibri" pitchFamily="34" charset="-122"/>
                 <a:cs typeface="Calibri" pitchFamily="34" charset="-120"/>
               </a:rPr>
-              <a:t>|  27/10/26   |   29</a:t>
+              <a:t>|  28/10/26   |   29</a:t>
             </a:r>
             <a:endParaRPr lang="en-US" sz="1000" dirty="0"/>
           </a:p>
@@ -19657,7 +19800,7 @@
                 <a:ea typeface="Calibri" pitchFamily="34" charset="-122"/>
                 <a:cs typeface="Calibri" pitchFamily="34" charset="-120"/>
               </a:rPr>
-              <a:t>|  27/10/26   |   3</a:t>
+              <a:t>|  28/10/26   |   3</a:t>
             </a:r>
             <a:endParaRPr lang="en-US" sz="1000" dirty="0"/>
           </a:p>
@@ -19923,7 +20066,7 @@
                 <a:ea typeface="Calibri" pitchFamily="34" charset="-122"/>
                 <a:cs typeface="Calibri" pitchFamily="34" charset="-120"/>
               </a:rPr>
-              <a:t>Indice de confiance : faible (incident vérifié le plus récent : 118 jours ; aucun signal du jour)</a:t>
+              <a:t>Indice de confiance : faible (incident vérifié le plus récent : 119 jours ; aucun signal du jour)</a:t>
             </a:r>
             <a:endParaRPr lang="en-US" sz="1100" dirty="0"/>
           </a:p>
@@ -20261,7 +20404,7 @@
                 <a:ea typeface="Calibri" pitchFamily="34" charset="-122"/>
                 <a:cs typeface="Calibri" pitchFamily="34" charset="-120"/>
               </a:rPr>
-              <a:t>|  27/10/26   |   30</a:t>
+              <a:t>|  28/10/26   |   30</a:t>
             </a:r>
             <a:endParaRPr lang="en-US" sz="1000" dirty="0"/>
           </a:p>
@@ -21024,7 +21167,7 @@
                 <a:ea typeface="Calibri" pitchFamily="34" charset="-122"/>
                 <a:cs typeface="Calibri" pitchFamily="34" charset="-120"/>
               </a:rPr>
-              <a:t>|  27/10/26   |   31</a:t>
+              <a:t>|  28/10/26   |   31</a:t>
             </a:r>
             <a:endParaRPr lang="en-US" sz="1000" dirty="0"/>
           </a:p>
@@ -21735,7 +21878,7 @@
                 <a:ea typeface="Calibri" pitchFamily="34" charset="-122"/>
                 <a:cs typeface="Calibri" pitchFamily="34" charset="-120"/>
               </a:rPr>
-              <a:t>|  27/10/26   |   32</a:t>
+              <a:t>|  28/10/26   |   32</a:t>
             </a:r>
             <a:endParaRPr lang="en-US" sz="1000" dirty="0"/>
           </a:p>
@@ -22051,7 +22194,7 @@
                 <a:ea typeface="Calibri" pitchFamily="34" charset="-122"/>
                 <a:cs typeface="Calibri" pitchFamily="34" charset="-120"/>
               </a:rPr>
-              <a:t>Indice de confiance : faible (incident vérifié le plus récent : 210 jours ; aucun signal du jour)</a:t>
+              <a:t>Indice de confiance : moyenne (incident vérifié le plus récent : 211 jours ; 1 signal du jour)</a:t>
             </a:r>
             <a:endParaRPr lang="en-US" sz="1100" dirty="0"/>
           </a:p>
@@ -22090,7 +22233,7 @@
                 <a:ea typeface="Arial Narrow" pitchFamily="34" charset="-122"/>
                 <a:cs typeface="Arial Narrow" pitchFamily="34" charset="-120"/>
               </a:rPr>
-              <a:t>Liberia: Dolphin Killed, Butchered Before NaFAA Rescue Team Arrived</a:t>
+              <a:t>Libéria : Un dauphin tué et massacré avant l'arrivée de l'équipe de secours de la NaFAA</a:t>
             </a:r>
             <a:endParaRPr lang="en-US" sz="2200" dirty="0"/>
           </a:p>
@@ -22215,7 +22358,7 @@
                 <a:ea typeface="Calibri" pitchFamily="34" charset="-122"/>
                 <a:cs typeface="Calibri" pitchFamily="34" charset="-120"/>
               </a:rPr>
-              <a:t>« Monrovia — What began as a moment of hope for conservationists ended in frustration after a dolphin that washed ashore at Miami Beach in Monrovia was killed and… »</a:t>
+              <a:t>« Monrovia — Ce qui a commencé comme un moment d'espoir pour les défenseurs de l'environnement s'est terminé par une frustration après qu'un dauphin qui s'est échoué à Miami Beach à Monrovia a été tué et… »</a:t>
             </a:r>
             <a:endParaRPr lang="en-US" sz="1400" dirty="0"/>
           </a:p>
@@ -22258,7 +22401,7 @@
                 <a:ea typeface="Calibri" pitchFamily="34" charset="-122"/>
                 <a:cs typeface="Calibri" pitchFamily="34" charset="-120"/>
               </a:rPr>
-              <a:t>Fait sécuritaire à suivre : vérifier son incidence sur les sites, les itinéraires et les personnels présents dans la zone.</a:t>
+              <a:t>Menace armée sur les axes et localités de la zone : réévaluer les déplacements terrestres (horaires, convois, itinéraires de repli) et les consignes des sites et des personnels présents à proximité.</a:t>
             </a:r>
             <a:endParaRPr lang="en-US" sz="1400" dirty="0"/>
           </a:p>
@@ -22406,7 +22549,7 @@
                 <a:ea typeface="Calibri" pitchFamily="34" charset="-122"/>
                 <a:cs typeface="Calibri" pitchFamily="34" charset="-120"/>
               </a:rPr>
-              <a:t>|  27/10/26   |   33</a:t>
+              <a:t>|  28/10/26   |   33</a:t>
             </a:r>
             <a:endParaRPr lang="en-US" sz="1000" dirty="0"/>
           </a:p>
@@ -22901,7 +23044,7 @@
                 <a:ea typeface="Calibri" pitchFamily="34" charset="-122"/>
                 <a:cs typeface="Calibri" pitchFamily="34" charset="-120"/>
               </a:rPr>
-              <a:t>(EN) A FORMER SECURITY CHIEF’S VISION FOR LIBERIA’S IMMIGRATION SERVICE FINALLY PLAYS</a:t>
+              <a:t>LIBÉRIA : DANS LE CADRE DE LA TENTATIVE DE LA DÉFENSE D’ANNULER LA CONDAMNATION DE PETER BON JALLAH</a:t>
             </a:r>
             <a:endParaRPr lang="en-US" sz="1300" dirty="0"/>
           </a:p>
@@ -22963,7 +23106,24 @@
                 <a:ea typeface="Calibri" pitchFamily="34" charset="-122"/>
                 <a:cs typeface="Calibri" pitchFamily="34" charset="-120"/>
               </a:rPr>
-              <a:t> — 26 octobre 2026, 6 h UTC</a:t>
+              <a:t> — 28 octobre 2026, 7 h UTC   ·   </a:t>
+            </a:r>
+            <a:pPr indent="0" marL="0">
+              <a:spcAft>
+                <a:spcPts val="200"/>
+              </a:spcAft>
+              <a:buNone/>
+            </a:pPr>
+            <a:r>
+              <a:rPr lang="en-US" sz="1300" b="1" dirty="0">
+                <a:solidFill>
+                  <a:srgbClr val="1F2937"/>
+                </a:solidFill>
+                <a:latin typeface="Calibri" pitchFamily="34" charset="0"/>
+                <a:ea typeface="Calibri" pitchFamily="34" charset="-122"/>
+                <a:cs typeface="Calibri" pitchFamily="34" charset="-120"/>
+              </a:rPr>
+              <a:t>Cotation : Probable</a:t>
             </a:r>
             <a:endParaRPr lang="en-US" sz="1300" dirty="0"/>
           </a:p>
@@ -22987,7 +23147,7 @@
                 <a:ea typeface="Calibri" pitchFamily="34" charset="-122"/>
                 <a:cs typeface="Calibri" pitchFamily="34" charset="-120"/>
               </a:rPr>
-              <a:t>(EN) LIBERIA IMPOSES 21-DAY ISOLATION AND MONITORING RULES FOR TRAVELERS AMID REGIONAL EBOLA THREAT</a:t>
+              <a:t>LA VISION D'UN ANCIEN CHEF DE LA SÉCURITÉ POUR LE SERVICE D'IMMIGRATION DU LIBÉRIA JOUE ENFIN</a:t>
             </a:r>
             <a:endParaRPr lang="en-US" sz="1300" dirty="0"/>
           </a:p>
@@ -23032,7 +23192,7 @@
                   </a:extLst>
                 </a:hlinkClick>
               </a:rPr>
-              <a:t>Global News Network Liberia</a:t>
+              <a:t>FrontPageAfrica — Liberia</a:t>
             </a:r>
             <a:pPr indent="0" marL="0">
               <a:spcAft>
@@ -23049,7 +23209,7 @@
                 <a:ea typeface="Calibri" pitchFamily="34" charset="-122"/>
                 <a:cs typeface="Calibri" pitchFamily="34" charset="-120"/>
               </a:rPr>
-              <a:t> — 24 octobre 2026, 22 h UTC</a:t>
+              <a:t> — 26 octobre 2026, 6 h UTC</a:t>
             </a:r>
             <a:endParaRPr lang="en-US" sz="1300" dirty="0"/>
           </a:p>
@@ -23073,7 +23233,7 @@
                 <a:ea typeface="Calibri" pitchFamily="34" charset="-122"/>
                 <a:cs typeface="Calibri" pitchFamily="34" charset="-120"/>
               </a:rPr>
-              <a:t>(EN) AFL FIRES TWO SOLDIERS OVER ASSAULT</a:t>
+              <a:t>LE LIBÉRIA IMPOSE DES RÈGLES D'ISOLEMENT ET DE SURVEILLANCE DE 21 JOURS AUX VOYAGEURS FACE À LA MENACE RÉGIONALE D'EBOLA</a:t>
             </a:r>
             <a:endParaRPr lang="en-US" sz="1300" dirty="0"/>
           </a:p>
@@ -23135,7 +23295,7 @@
                 <a:ea typeface="Calibri" pitchFamily="34" charset="-122"/>
                 <a:cs typeface="Calibri" pitchFamily="34" charset="-120"/>
               </a:rPr>
-              <a:t> — 22 octobre 2026, 17 h UTC</a:t>
+              <a:t> — 24 octobre 2026, 22 h UTC</a:t>
             </a:r>
             <a:endParaRPr lang="en-US" sz="1300" dirty="0"/>
           </a:p>
@@ -23219,7 +23379,7 @@
                 <a:ea typeface="Calibri" pitchFamily="34" charset="-122"/>
                 <a:cs typeface="Calibri" pitchFamily="34" charset="-120"/>
               </a:rPr>
-              <a:t>|  27/10/26   |   34</a:t>
+              <a:t>|  28/10/26   |   34</a:t>
             </a:r>
             <a:endParaRPr lang="en-US" sz="1000" dirty="0"/>
           </a:p>
@@ -23279,7 +23439,7 @@
               <a:buNone/>
             </a:pPr>
             <a:r>
-              <a:rPr lang="en-US" sz="2400" dirty="0">
+              <a:rPr lang="en-US" sz="1600" dirty="0">
                 <a:solidFill>
                   <a:srgbClr val="FFFFFF"/>
                 </a:solidFill>
@@ -23287,9 +23447,9 @@
                 <a:ea typeface="Arial Narrow" pitchFamily="34" charset="-122"/>
                 <a:cs typeface="Arial Narrow" pitchFamily="34" charset="-120"/>
               </a:rPr>
-              <a:t>IX</a:t>
-            </a:r>
-            <a:endParaRPr lang="en-US" sz="2400" dirty="0"/>
+              <a:t>VIII</a:t>
+            </a:r>
+            <a:endParaRPr lang="en-US" sz="1600" dirty="0"/>
           </a:p>
         </p:txBody>
       </p:sp>
@@ -23326,7 +23486,7 @@
                 <a:ea typeface="Arial Narrow" pitchFamily="34" charset="-122"/>
                 <a:cs typeface="Arial Narrow" pitchFamily="34" charset="-120"/>
               </a:rPr>
-              <a:t>Sénégal</a:t>
+              <a:t>Liberia</a:t>
             </a:r>
             <a:endParaRPr lang="en-US" sz="2800" dirty="0"/>
           </a:p>
@@ -23341,17 +23501,17 @@
         <p:spPr>
           <a:xfrm>
             <a:off x="10881360" y="274320"/>
-            <a:ext cx="301752" cy="566928"/>
+            <a:ext cx="905256" cy="113386"/>
           </a:xfrm>
           <a:prstGeom prst="rect">
             <a:avLst/>
           </a:prstGeom>
           <a:solidFill>
-            <a:srgbClr val="00853F"/>
+            <a:srgbClr val="BF0A30"/>
           </a:solidFill>
           <a:ln w="12700">
             <a:solidFill>
-              <a:srgbClr val="00853F"/>
+              <a:srgbClr val="BF0A30"/>
             </a:solidFill>
             <a:prstDash val="solid"/>
           </a:ln>
@@ -23365,18 +23525,18 @@
         </p:nvSpPr>
         <p:spPr>
           <a:xfrm>
-            <a:off x="11183112" y="274320"/>
-            <a:ext cx="301752" cy="566928"/>
+            <a:off x="10881360" y="387706"/>
+            <a:ext cx="905256" cy="113386"/>
           </a:xfrm>
           <a:prstGeom prst="rect">
             <a:avLst/>
           </a:prstGeom>
           <a:solidFill>
-            <a:srgbClr val="FDEF42"/>
+            <a:srgbClr val="FFFFFF"/>
           </a:solidFill>
           <a:ln w="12700">
             <a:solidFill>
-              <a:srgbClr val="FDEF42"/>
+              <a:srgbClr val="FFFFFF"/>
             </a:solidFill>
             <a:prstDash val="solid"/>
           </a:ln>
@@ -23390,18 +23550,18 @@
         </p:nvSpPr>
         <p:spPr>
           <a:xfrm>
-            <a:off x="11484864" y="274320"/>
-            <a:ext cx="301752" cy="566928"/>
+            <a:off x="10881360" y="501091"/>
+            <a:ext cx="905256" cy="113386"/>
           </a:xfrm>
           <a:prstGeom prst="rect">
             <a:avLst/>
           </a:prstGeom>
           <a:solidFill>
-            <a:srgbClr val="E31B23"/>
+            <a:srgbClr val="BF0A30"/>
           </a:solidFill>
           <a:ln w="12700">
             <a:solidFill>
-              <a:srgbClr val="E31B23"/>
+              <a:srgbClr val="BF0A30"/>
             </a:solidFill>
             <a:prstDash val="solid"/>
           </a:ln>
@@ -23410,6 +23570,56 @@
       <p:sp>
         <p:nvSpPr>
           <p:cNvPr id="7" name="Shape 5"/>
+          <p:cNvSpPr/>
+          <p:nvPr/>
+        </p:nvSpPr>
+        <p:spPr>
+          <a:xfrm>
+            <a:off x="10881360" y="614477"/>
+            <a:ext cx="905256" cy="113386"/>
+          </a:xfrm>
+          <a:prstGeom prst="rect">
+            <a:avLst/>
+          </a:prstGeom>
+          <a:solidFill>
+            <a:srgbClr val="FFFFFF"/>
+          </a:solidFill>
+          <a:ln w="12700">
+            <a:solidFill>
+              <a:srgbClr val="FFFFFF"/>
+            </a:solidFill>
+            <a:prstDash val="solid"/>
+          </a:ln>
+        </p:spPr>
+      </p:sp>
+      <p:sp>
+        <p:nvSpPr>
+          <p:cNvPr id="8" name="Shape 6"/>
+          <p:cNvSpPr/>
+          <p:nvPr/>
+        </p:nvSpPr>
+        <p:spPr>
+          <a:xfrm>
+            <a:off x="10881360" y="727862"/>
+            <a:ext cx="905256" cy="113386"/>
+          </a:xfrm>
+          <a:prstGeom prst="rect">
+            <a:avLst/>
+          </a:prstGeom>
+          <a:solidFill>
+            <a:srgbClr val="BF0A30"/>
+          </a:solidFill>
+          <a:ln w="12700">
+            <a:solidFill>
+              <a:srgbClr val="BF0A30"/>
+            </a:solidFill>
+            <a:prstDash val="solid"/>
+          </a:ln>
+        </p:spPr>
+      </p:sp>
+      <p:sp>
+        <p:nvSpPr>
+          <p:cNvPr id="9" name="Shape 7"/>
           <p:cNvSpPr/>
           <p:nvPr/>
         </p:nvSpPr>
@@ -23431,7 +23641,7 @@
       </p:sp>
       <p:sp>
         <p:nvSpPr>
-          <p:cNvPr id="8" name="Shape 6"/>
+          <p:cNvPr id="10" name="Shape 8"/>
           <p:cNvSpPr/>
           <p:nvPr/>
         </p:nvSpPr>
@@ -23454,14 +23664,14 @@
       </p:sp>
       <p:sp>
         <p:nvSpPr>
-          <p:cNvPr id="9" name="Text 7"/>
-          <p:cNvSpPr/>
-          <p:nvPr/>
-        </p:nvSpPr>
-        <p:spPr>
-          <a:xfrm>
-            <a:off x="640080" y="1024128"/>
-            <a:ext cx="10972800" cy="274320"/>
+          <p:cNvPr id="11" name="Text 9"/>
+          <p:cNvSpPr/>
+          <p:nvPr/>
+        </p:nvSpPr>
+        <p:spPr>
+          <a:xfrm>
+            <a:off x="640080" y="1188720"/>
+            <a:ext cx="10972800" cy="4663440"/>
           </a:xfrm>
           <a:prstGeom prst="rect">
             <a:avLst/>
@@ -23470,98 +23680,21 @@
           <a:ln/>
         </p:spPr>
         <p:txBody>
-          <a:bodyPr wrap="square" rtlCol="0" anchor="ctr"/>
-          <a:lstStyle/>
-          <a:p>
-            <a:pPr indent="0" marL="0">
-              <a:buNone/>
-            </a:pPr>
-            <a:r>
-              <a:rPr lang="en-US" sz="1100" i="1" dirty="0">
-                <a:solidFill>
-                  <a:srgbClr val="6B7280"/>
-                </a:solidFill>
-                <a:latin typeface="Calibri" pitchFamily="34" charset="0"/>
-                <a:ea typeface="Calibri" pitchFamily="34" charset="-122"/>
-                <a:cs typeface="Calibri" pitchFamily="34" charset="-120"/>
-              </a:rPr>
-              <a:t>Indice de confiance : moyenne (incident vérifié le plus récent : 120 jours ; 5 signaux du jour)</a:t>
-            </a:r>
-            <a:endParaRPr lang="en-US" sz="1100" dirty="0"/>
-          </a:p>
-        </p:txBody>
-      </p:sp>
-      <p:sp>
-        <p:nvSpPr>
-          <p:cNvPr id="10" name="Text 8"/>
-          <p:cNvSpPr/>
-          <p:nvPr/>
-        </p:nvSpPr>
-        <p:spPr>
-          <a:xfrm>
-            <a:off x="640080" y="1298448"/>
-            <a:ext cx="10972800" cy="685800"/>
-          </a:xfrm>
-          <a:prstGeom prst="rect">
-            <a:avLst/>
-          </a:prstGeom>
-          <a:noFill/>
-          <a:ln/>
-        </p:spPr>
-        <p:txBody>
           <a:bodyPr wrap="square" rtlCol="0" anchor="t"/>
           <a:lstStyle/>
           <a:p>
-            <a:pPr indent="0" marL="0">
-              <a:buNone/>
-            </a:pPr>
-            <a:r>
-              <a:rPr lang="en-US" sz="2200" b="1" dirty="0">
-                <a:solidFill>
-                  <a:srgbClr val="1F6B5E"/>
-                </a:solidFill>
-                <a:latin typeface="Arial Narrow" pitchFamily="34" charset="0"/>
-                <a:ea typeface="Arial Narrow" pitchFamily="34" charset="-122"/>
-                <a:cs typeface="Arial Narrow" pitchFamily="34" charset="-120"/>
-              </a:rPr>
-              <a:t>Immeuble effondré à Thiès : un mort et deux blessés, selon le bilan provisoire</a:t>
-            </a:r>
-            <a:endParaRPr lang="en-US" sz="2200" dirty="0"/>
-          </a:p>
-        </p:txBody>
-      </p:sp>
-      <p:sp>
-        <p:nvSpPr>
-          <p:cNvPr id="11" name="Text 9"/>
-          <p:cNvSpPr/>
-          <p:nvPr/>
-        </p:nvSpPr>
-        <p:spPr>
-          <a:xfrm>
-            <a:off x="640080" y="2029968"/>
-            <a:ext cx="6812280" cy="3867912"/>
-          </a:xfrm>
-          <a:prstGeom prst="rect">
-            <a:avLst/>
-          </a:prstGeom>
-          <a:noFill/>
-          <a:ln/>
-        </p:spPr>
-        <p:txBody>
-          <a:bodyPr wrap="square" rtlCol="0" anchor="t"/>
-          <a:lstStyle/>
-          <a:p>
-            <a:pPr indent="0" marL="0">
+            <a:pPr marL="342900" indent="-342900">
               <a:spcBef>
                 <a:spcPts val="800"/>
               </a:spcBef>
               <a:spcAft>
-                <a:spcPts val="300"/>
-              </a:spcAft>
-              <a:buNone/>
-            </a:pPr>
-            <a:r>
-              <a:rPr lang="en-US" sz="1400" b="1" dirty="0">
+                <a:spcPts val="200"/>
+              </a:spcAft>
+              <a:buSzPct val="100000"/>
+              <a:buChar char="❑"/>
+            </a:pPr>
+            <a:r>
+              <a:rPr lang="en-US" sz="1400" b="1" u="sng" dirty="0">
                 <a:solidFill>
                   <a:srgbClr val="1F6B5E"/>
                 </a:solidFill>
@@ -23569,16 +23702,17 @@
                 <a:ea typeface="Calibri" pitchFamily="34" charset="-122"/>
                 <a:cs typeface="Calibri" pitchFamily="34" charset="-120"/>
               </a:rPr>
-              <a:t>Contexte</a:t>
+              <a:t>L'AFL TIRE SUR DEUX SOLDATS À LA SUITE D'UN ASSAUT</a:t>
             </a:r>
             <a:endParaRPr lang="en-US" sz="1300" dirty="0"/>
           </a:p>
           <a:p>
-            <a:pPr indent="0" marL="0">
-              <a:spcAft>
-                <a:spcPts val="300"/>
-              </a:spcAft>
-              <a:buNone/>
+            <a:pPr lvl="1" marL="685800" indent="-342900">
+              <a:spcAft>
+                <a:spcPts val="200"/>
+              </a:spcAft>
+              <a:buSzPct val="100000"/>
+              <a:buChar char="▪"/>
             </a:pPr>
             <a:r>
               <a:rPr lang="en-US" sz="1300" dirty="0">
@@ -23589,174 +23723,11 @@
                 <a:ea typeface="Calibri" pitchFamily="34" charset="-122"/>
                 <a:cs typeface="Calibri" pitchFamily="34" charset="-120"/>
               </a:rPr>
-              <a:t>Fait rapporté le mardi 27 octobre 2026. Lieu : Thiès, Sénégal. Actualité sociale. Repris par 2 médias distincts (APS — Agence Sénégalaise Presse, Pressafrik) : le fait est recoupé.</a:t>
-            </a:r>
-            <a:endParaRPr lang="en-US" sz="1300" dirty="0"/>
-          </a:p>
-          <a:p>
-            <a:pPr indent="0" marL="0">
-              <a:spcBef>
-                <a:spcPts val="800"/>
-              </a:spcBef>
-              <a:spcAft>
-                <a:spcPts val="300"/>
-              </a:spcAft>
-              <a:buNone/>
-            </a:pPr>
-            <a:r>
-              <a:rPr lang="en-US" sz="1400" b="1" dirty="0">
-                <a:solidFill>
-                  <a:srgbClr val="1F6B5E"/>
-                </a:solidFill>
-                <a:latin typeface="Calibri" pitchFamily="34" charset="0"/>
-                <a:ea typeface="Calibri" pitchFamily="34" charset="-122"/>
-                <a:cs typeface="Calibri" pitchFamily="34" charset="-120"/>
-              </a:rPr>
-              <a:t>Ce que rapportent les sources</a:t>
-            </a:r>
-            <a:endParaRPr lang="en-US" sz="1300" dirty="0"/>
-          </a:p>
-          <a:p>
-            <a:pPr indent="0" marL="0">
-              <a:spcAft>
-                <a:spcPts val="300"/>
-              </a:spcAft>
-              <a:buNone/>
-            </a:pPr>
-            <a:r>
-              <a:rPr lang="en-US" sz="1300" b="1" dirty="0">
-                <a:solidFill>
-                  <a:srgbClr val="1F2937"/>
-                </a:solidFill>
-                <a:latin typeface="Calibri" pitchFamily="34" charset="0"/>
-                <a:ea typeface="Calibri" pitchFamily="34" charset="-122"/>
-                <a:cs typeface="Calibri" pitchFamily="34" charset="-120"/>
-              </a:rPr>
-              <a:t>APS — Agence Sénégalaise Presse : </a:t>
-            </a:r>
-            <a:pPr indent="0" marL="0">
-              <a:spcAft>
-                <a:spcPts val="300"/>
-              </a:spcAft>
-              <a:buNone/>
-            </a:pPr>
-            <a:r>
-              <a:rPr lang="en-US" sz="1300" i="1" dirty="0">
-                <a:solidFill>
-                  <a:srgbClr val="1F2937"/>
-                </a:solidFill>
-                <a:latin typeface="Calibri" pitchFamily="34" charset="0"/>
-                <a:ea typeface="Calibri" pitchFamily="34" charset="-122"/>
-                <a:cs typeface="Calibri" pitchFamily="34" charset="-120"/>
-              </a:rPr>
-              <a:t>« Thiès, 27 oct (APS) –L’effondrement d’un immeuble R+5 en construction mardi dans la commune de Thiès-Ouest a fait trois victimes, dont un mort et deux blessés extraits des décombres, selon le bilan provisoire tiré par le Groupement d’incendie et de secours numéro 2, couvrant les régions de Thiès et Diourbel. »</a:t>
-            </a:r>
-            <a:endParaRPr lang="en-US" sz="1300" dirty="0"/>
-          </a:p>
-          <a:p>
-            <a:pPr indent="0" marL="0">
-              <a:spcAft>
-                <a:spcPts val="300"/>
-              </a:spcAft>
-              <a:buNone/>
-            </a:pPr>
-            <a:r>
-              <a:rPr lang="en-US" sz="1300" b="1" dirty="0">
-                <a:solidFill>
-                  <a:srgbClr val="1F2937"/>
-                </a:solidFill>
-                <a:latin typeface="Calibri" pitchFamily="34" charset="0"/>
-                <a:ea typeface="Calibri" pitchFamily="34" charset="-122"/>
-                <a:cs typeface="Calibri" pitchFamily="34" charset="-120"/>
-              </a:rPr>
-              <a:t>Pressafrik : </a:t>
-            </a:r>
-            <a:pPr indent="0" marL="0">
-              <a:spcAft>
-                <a:spcPts val="300"/>
-              </a:spcAft>
-              <a:buNone/>
-            </a:pPr>
-            <a:r>
-              <a:rPr lang="en-US" sz="1300" i="1" dirty="0">
-                <a:solidFill>
-                  <a:srgbClr val="1F2937"/>
-                </a:solidFill>
-                <a:latin typeface="Calibri" pitchFamily="34" charset="0"/>
-                <a:ea typeface="Calibri" pitchFamily="34" charset="-122"/>
-                <a:cs typeface="Calibri" pitchFamily="34" charset="-120"/>
-              </a:rPr>
-              <a:t>« Les secours ont dégagé trois personnes des ruines de l’immeuble de deux étages en construction qu... www.pressafrik.com »</a:t>
-            </a:r>
-            <a:endParaRPr lang="en-US" sz="1300" dirty="0"/>
-          </a:p>
-          <a:p>
-            <a:pPr indent="0" marL="0">
-              <a:spcBef>
-                <a:spcPts val="800"/>
-              </a:spcBef>
-              <a:spcAft>
-                <a:spcPts val="300"/>
-              </a:spcAft>
-              <a:buNone/>
-            </a:pPr>
-            <a:r>
-              <a:rPr lang="en-US" sz="1400" b="1" dirty="0">
-                <a:solidFill>
-                  <a:srgbClr val="1F6B5E"/>
-                </a:solidFill>
-                <a:latin typeface="Calibri" pitchFamily="34" charset="0"/>
-                <a:ea typeface="Calibri" pitchFamily="34" charset="-122"/>
-                <a:cs typeface="Calibri" pitchFamily="34" charset="-120"/>
-              </a:rPr>
-              <a:t>Enjeux sûreté</a:t>
-            </a:r>
-            <a:endParaRPr lang="en-US" sz="1300" dirty="0"/>
-          </a:p>
-          <a:p>
-            <a:pPr indent="0" marL="0">
-              <a:spcAft>
-                <a:spcPts val="300"/>
-              </a:spcAft>
-              <a:buNone/>
-            </a:pPr>
-            <a:r>
-              <a:rPr lang="en-US" sz="1300" dirty="0">
-                <a:solidFill>
-                  <a:srgbClr val="1F2937"/>
-                </a:solidFill>
-                <a:latin typeface="Calibri" pitchFamily="34" charset="0"/>
-                <a:ea typeface="Calibri" pitchFamily="34" charset="-122"/>
-                <a:cs typeface="Calibri" pitchFamily="34" charset="-120"/>
-              </a:rPr>
-              <a:t>Risque accidentel ou technique : rappeler les consignes de sécurité routière et incendie, vérifier l'exposition des sites et des prestataires.</a:t>
-            </a:r>
-            <a:endParaRPr lang="en-US" sz="1300" dirty="0"/>
-          </a:p>
-          <a:p>
-            <a:pPr indent="0" marL="0">
-              <a:spcBef>
-                <a:spcPts val="800"/>
-              </a:spcBef>
-              <a:spcAft>
-                <a:spcPts val="300"/>
-              </a:spcAft>
-              <a:buNone/>
-            </a:pPr>
-            <a:r>
-              <a:rPr lang="en-US" sz="1300" b="1" dirty="0">
-                <a:solidFill>
-                  <a:srgbClr val="1F2937"/>
-                </a:solidFill>
-                <a:latin typeface="Calibri" pitchFamily="34" charset="0"/>
-                <a:ea typeface="Calibri" pitchFamily="34" charset="-122"/>
-                <a:cs typeface="Calibri" pitchFamily="34" charset="-120"/>
-              </a:rPr>
-              <a:t>Sources : </a:t>
-            </a:r>
-            <a:pPr indent="0" marL="0">
-              <a:spcAft>
-                <a:spcPts val="300"/>
+              <a:t>Source : </a:t>
+            </a:r>
+            <a:pPr indent="0" marL="0">
+              <a:spcAft>
+                <a:spcPts val="200"/>
               </a:spcAft>
               <a:buNone/>
             </a:pPr>
@@ -23776,128 +23747,32 @@
                   </a:extLst>
                 </a:hlinkClick>
               </a:rPr>
-              <a:t>APS — Agence Sénégalaise Presse</a:t>
-            </a:r>
-            <a:pPr indent="0" marL="0">
-              <a:spcAft>
-                <a:spcPts val="300"/>
-              </a:spcAft>
-              <a:buNone/>
-            </a:pPr>
-            <a:r>
-              <a:rPr lang="en-US" sz="1300" u="sng" dirty="0">
-                <a:solidFill>
-                  <a:srgbClr val="1F6B5E"/>
-                </a:solidFill>
-                <a:latin typeface="Calibri" pitchFamily="34" charset="0"/>
-                <a:ea typeface="Calibri" pitchFamily="34" charset="-122"/>
-                <a:cs typeface="Calibri" pitchFamily="34" charset="-120"/>
-                <a:hlinkClick r:id="rId2" invalidUrl="" action="" tgtFrame="" tooltip="" history="1" highlightClick="0" endSnd="0">
-                  <a:extLst>
-                    <a:ext uri="{A12FA001-AC4F-418D-AE19-62706E023703}">
-                      <ahyp:hlinkClr xmlns:ahyp="http://schemas.microsoft.com/office/drawing/2018/hyperlinkcolor" val="tx"/>
-                    </a:ext>
-                  </a:extLst>
-                </a:hlinkClick>
-              </a:rPr>
-              <a:t> · Pressafrik</a:t>
-            </a:r>
-            <a:pPr indent="0" marL="0">
-              <a:spcAft>
-                <a:spcPts val="300"/>
-              </a:spcAft>
-              <a:buNone/>
-            </a:pPr>
-            <a:r>
-              <a:rPr lang="en-US" sz="1300" b="1" dirty="0">
-                <a:solidFill>
-                  <a:srgbClr val="1F2937"/>
-                </a:solidFill>
-                <a:latin typeface="Calibri" pitchFamily="34" charset="0"/>
-                <a:ea typeface="Calibri" pitchFamily="34" charset="-122"/>
-                <a:cs typeface="Calibri" pitchFamily="34" charset="-120"/>
-              </a:rPr>
-              <a:t> — 27 octobre 2026, 19 h UTC   ·   Cotation : Confirmé</a:t>
+              <a:t>Global News Network Liberia</a:t>
+            </a:r>
+            <a:pPr indent="0" marL="0">
+              <a:spcAft>
+                <a:spcPts val="200"/>
+              </a:spcAft>
+              <a:buNone/>
+            </a:pPr>
+            <a:r>
+              <a:rPr lang="en-US" sz="1300" dirty="0">
+                <a:solidFill>
+                  <a:srgbClr val="1F2937"/>
+                </a:solidFill>
+                <a:latin typeface="Calibri" pitchFamily="34" charset="0"/>
+                <a:ea typeface="Calibri" pitchFamily="34" charset="-122"/>
+                <a:cs typeface="Calibri" pitchFamily="34" charset="-120"/>
+              </a:rPr>
+              <a:t> — 22 octobre 2026, 17 h UTC</a:t>
             </a:r>
             <a:endParaRPr lang="en-US" sz="1300" dirty="0"/>
           </a:p>
         </p:txBody>
       </p:sp>
-      <p:pic>
-        <p:nvPicPr>
-          <p:cNvPr id="12" name="Image 0" descr="preencoded.png">
-            <a:hlinkClick r:id="rId4" tooltip=""/>
-          </p:cNvPr>
-          <p:cNvPicPr>
-            <a:picLocks noChangeAspect="1"/>
-          </p:cNvPicPr>
-          <p:nvPr/>
-        </p:nvPicPr>
-        <p:blipFill>
-          <a:blip r:embed="rId3"/>
-          <a:stretch>
-            <a:fillRect/>
-          </a:stretch>
-        </p:blipFill>
-        <p:spPr>
-          <a:xfrm>
-            <a:off x="7635240" y="2075688"/>
-            <a:ext cx="4114800" cy="2447080"/>
-          </a:xfrm>
-          <a:prstGeom prst="rect">
-            <a:avLst/>
-          </a:prstGeom>
-        </p:spPr>
-      </p:pic>
-      <p:sp>
-        <p:nvSpPr>
-          <p:cNvPr id="13" name="Text 10"/>
-          <p:cNvSpPr/>
-          <p:nvPr/>
-        </p:nvSpPr>
-        <p:spPr>
-          <a:xfrm>
-            <a:off x="7635240" y="4559344"/>
-            <a:ext cx="4114800" cy="256032"/>
-          </a:xfrm>
-          <a:prstGeom prst="rect">
-            <a:avLst/>
-          </a:prstGeom>
-          <a:noFill/>
-          <a:ln/>
-        </p:spPr>
-        <p:txBody>
-          <a:bodyPr wrap="square" rtlCol="0" anchor="ctr"/>
-          <a:lstStyle/>
-          <a:p>
-            <a:pPr algn="r" indent="0" marL="0">
-              <a:buNone/>
-            </a:pPr>
-            <a:r>
-              <a:rPr lang="en-US" sz="900" u="sng" dirty="0">
-                <a:solidFill>
-                  <a:srgbClr val="1F6B5E"/>
-                </a:solidFill>
-                <a:latin typeface="Calibri" pitchFamily="34" charset="0"/>
-                <a:ea typeface="Calibri" pitchFamily="34" charset="-122"/>
-                <a:cs typeface="Calibri" pitchFamily="34" charset="-120"/>
-                <a:hlinkClick r:id="rId5" invalidUrl="" action="" tgtFrame="" tooltip="" history="1" highlightClick="0" endSnd="0">
-                  <a:extLst>
-                    <a:ext uri="{A12FA001-AC4F-418D-AE19-62706E023703}">
-                      <ahyp:hlinkClr xmlns:ahyp="http://schemas.microsoft.com/office/drawing/2018/hyperlinkcolor" val="tx"/>
-                    </a:ext>
-                  </a:extLst>
-                </a:hlinkClick>
-              </a:rPr>
-              <a:t>Photo : © pressafrik.com</a:t>
-            </a:r>
-            <a:endParaRPr lang="en-US" sz="900" dirty="0"/>
-          </a:p>
-        </p:txBody>
-      </p:sp>
-      <p:sp>
-        <p:nvSpPr>
-          <p:cNvPr id="14" name="Text 11"/>
+      <p:sp>
+        <p:nvSpPr>
+          <p:cNvPr id="12" name="Text 10"/>
           <p:cNvSpPr/>
           <p:nvPr/>
         </p:nvSpPr>
@@ -23942,7 +23817,7 @@
       </p:sp>
       <p:sp>
         <p:nvSpPr>
-          <p:cNvPr id="15" name="Text 12"/>
+          <p:cNvPr id="13" name="Text 11"/>
           <p:cNvSpPr/>
           <p:nvPr/>
         </p:nvSpPr>
@@ -23973,7 +23848,7 @@
                 <a:ea typeface="Calibri" pitchFamily="34" charset="-122"/>
                 <a:cs typeface="Calibri" pitchFamily="34" charset="-120"/>
               </a:rPr>
-              <a:t>|  27/10/26   |   35</a:t>
+              <a:t>|  28/10/26   |   35</a:t>
             </a:r>
             <a:endParaRPr lang="en-US" sz="1000" dirty="0"/>
           </a:p>
@@ -24214,8 +24089,8 @@
         </p:nvSpPr>
         <p:spPr>
           <a:xfrm>
-            <a:off x="640080" y="1188720"/>
-            <a:ext cx="10972800" cy="4663440"/>
+            <a:off x="640080" y="1024128"/>
+            <a:ext cx="10972800" cy="274320"/>
           </a:xfrm>
           <a:prstGeom prst="rect">
             <a:avLst/>
@@ -24224,21 +24099,98 @@
           <a:ln/>
         </p:spPr>
         <p:txBody>
+          <a:bodyPr wrap="square" rtlCol="0" anchor="ctr"/>
+          <a:lstStyle/>
+          <a:p>
+            <a:pPr indent="0" marL="0">
+              <a:buNone/>
+            </a:pPr>
+            <a:r>
+              <a:rPr lang="en-US" sz="1100" i="1" dirty="0">
+                <a:solidFill>
+                  <a:srgbClr val="6B7280"/>
+                </a:solidFill>
+                <a:latin typeface="Calibri" pitchFamily="34" charset="0"/>
+                <a:ea typeface="Calibri" pitchFamily="34" charset="-122"/>
+                <a:cs typeface="Calibri" pitchFamily="34" charset="-120"/>
+              </a:rPr>
+              <a:t>Indice de confiance : moyenne (incident vérifié le plus récent : 120 jours ; 5 signaux du jour)</a:t>
+            </a:r>
+            <a:endParaRPr lang="en-US" sz="1100" dirty="0"/>
+          </a:p>
+        </p:txBody>
+      </p:sp>
+      <p:sp>
+        <p:nvSpPr>
+          <p:cNvPr id="10" name="Text 8"/>
+          <p:cNvSpPr/>
+          <p:nvPr/>
+        </p:nvSpPr>
+        <p:spPr>
+          <a:xfrm>
+            <a:off x="640080" y="1298448"/>
+            <a:ext cx="10972800" cy="685800"/>
+          </a:xfrm>
+          <a:prstGeom prst="rect">
+            <a:avLst/>
+          </a:prstGeom>
+          <a:noFill/>
+          <a:ln/>
+        </p:spPr>
+        <p:txBody>
           <a:bodyPr wrap="square" rtlCol="0" anchor="t"/>
           <a:lstStyle/>
           <a:p>
-            <a:pPr marL="342900" indent="-342900">
+            <a:pPr indent="0" marL="0">
+              <a:buNone/>
+            </a:pPr>
+            <a:r>
+              <a:rPr lang="en-US" sz="2200" b="1" dirty="0">
+                <a:solidFill>
+                  <a:srgbClr val="1F6B5E"/>
+                </a:solidFill>
+                <a:latin typeface="Arial Narrow" pitchFamily="34" charset="0"/>
+                <a:ea typeface="Arial Narrow" pitchFamily="34" charset="-122"/>
+                <a:cs typeface="Arial Narrow" pitchFamily="34" charset="-120"/>
+              </a:rPr>
+              <a:t>Touba : un débat sur les moteurs de Jakarta se termine par la mort de Baye M. Diop</a:t>
+            </a:r>
+            <a:endParaRPr lang="en-US" sz="2200" dirty="0"/>
+          </a:p>
+        </p:txBody>
+      </p:sp>
+      <p:sp>
+        <p:nvSpPr>
+          <p:cNvPr id="11" name="Text 9"/>
+          <p:cNvSpPr/>
+          <p:nvPr/>
+        </p:nvSpPr>
+        <p:spPr>
+          <a:xfrm>
+            <a:off x="640080" y="2029968"/>
+            <a:ext cx="6812280" cy="3867912"/>
+          </a:xfrm>
+          <a:prstGeom prst="rect">
+            <a:avLst/>
+          </a:prstGeom>
+          <a:noFill/>
+          <a:ln/>
+        </p:spPr>
+        <p:txBody>
+          <a:bodyPr wrap="square" rtlCol="0" anchor="t"/>
+          <a:lstStyle/>
+          <a:p>
+            <a:pPr indent="0" marL="0">
               <a:spcBef>
                 <a:spcPts val="800"/>
               </a:spcBef>
               <a:spcAft>
-                <a:spcPts val="200"/>
-              </a:spcAft>
-              <a:buSzPct val="100000"/>
-              <a:buChar char="❑"/>
-            </a:pPr>
-            <a:r>
-              <a:rPr lang="en-US" sz="1400" b="1" u="sng" dirty="0">
+                <a:spcPts val="300"/>
+              </a:spcAft>
+              <a:buNone/>
+            </a:pPr>
+            <a:r>
+              <a:rPr lang="en-US" sz="1500" b="1" dirty="0">
                 <a:solidFill>
                   <a:srgbClr val="1F6B5E"/>
                 </a:solidFill>
@@ -24246,37 +24198,162 @@
                 <a:ea typeface="Calibri" pitchFamily="34" charset="-122"/>
                 <a:cs typeface="Calibri" pitchFamily="34" charset="-120"/>
               </a:rPr>
-              <a:t>PACTE DE STABILITÉ SOCIALE : LE GOUVERNEMENT VISE 71 % D’EXÉCUTION DES ENGAGEMENTS EN DÉCEMBRE</a:t>
-            </a:r>
-            <a:endParaRPr lang="en-US" sz="1300" dirty="0"/>
-          </a:p>
-          <a:p>
-            <a:pPr lvl="1" marL="685800" indent="-342900">
-              <a:spcAft>
-                <a:spcPts val="200"/>
-              </a:spcAft>
-              <a:buSzPct val="100000"/>
-              <a:buChar char="▪"/>
-            </a:pPr>
-            <a:r>
-              <a:rPr lang="en-US" sz="1300" dirty="0">
-                <a:solidFill>
-                  <a:srgbClr val="1F2937"/>
-                </a:solidFill>
-                <a:latin typeface="Calibri" pitchFamily="34" charset="0"/>
-                <a:ea typeface="Calibri" pitchFamily="34" charset="-122"/>
-                <a:cs typeface="Calibri" pitchFamily="34" charset="-120"/>
-              </a:rPr>
-              <a:t>Sources : </a:t>
-            </a:r>
-            <a:pPr indent="0" marL="0">
-              <a:spcAft>
-                <a:spcPts val="200"/>
-              </a:spcAft>
-              <a:buNone/>
-            </a:pPr>
-            <a:r>
-              <a:rPr lang="en-US" sz="1300" u="sng" dirty="0">
+              <a:t>Contexte</a:t>
+            </a:r>
+            <a:endParaRPr lang="en-US" sz="1400" dirty="0"/>
+          </a:p>
+          <a:p>
+            <a:pPr indent="0" marL="0">
+              <a:spcAft>
+                <a:spcPts val="300"/>
+              </a:spcAft>
+              <a:buNone/>
+            </a:pPr>
+            <a:r>
+              <a:rPr lang="en-US" sz="1400" dirty="0">
+                <a:solidFill>
+                  <a:srgbClr val="1F2937"/>
+                </a:solidFill>
+                <a:latin typeface="Calibri" pitchFamily="34" charset="0"/>
+                <a:ea typeface="Calibri" pitchFamily="34" charset="-122"/>
+                <a:cs typeface="Calibri" pitchFamily="34" charset="-120"/>
+              </a:rPr>
+              <a:t>Fait rapporté le mercredi 28 octobre 2026. Lieu : Sénégal. Actualité politique. Une seule source à ce stade (Dakar Actu) : à confirmer par un second média.</a:t>
+            </a:r>
+            <a:endParaRPr lang="en-US" sz="1400" dirty="0"/>
+          </a:p>
+          <a:p>
+            <a:pPr indent="0" marL="0">
+              <a:spcBef>
+                <a:spcPts val="800"/>
+              </a:spcBef>
+              <a:spcAft>
+                <a:spcPts val="300"/>
+              </a:spcAft>
+              <a:buNone/>
+            </a:pPr>
+            <a:r>
+              <a:rPr lang="en-US" sz="1500" b="1" dirty="0">
+                <a:solidFill>
+                  <a:srgbClr val="1F6B5E"/>
+                </a:solidFill>
+                <a:latin typeface="Calibri" pitchFamily="34" charset="0"/>
+                <a:ea typeface="Calibri" pitchFamily="34" charset="-122"/>
+                <a:cs typeface="Calibri" pitchFamily="34" charset="-120"/>
+              </a:rPr>
+              <a:t>Ce que rapportent les sources</a:t>
+            </a:r>
+            <a:endParaRPr lang="en-US" sz="1400" dirty="0"/>
+          </a:p>
+          <a:p>
+            <a:pPr indent="0" marL="0">
+              <a:spcAft>
+                <a:spcPts val="300"/>
+              </a:spcAft>
+              <a:buNone/>
+            </a:pPr>
+            <a:r>
+              <a:rPr lang="en-US" sz="1400" b="1" dirty="0">
+                <a:solidFill>
+                  <a:srgbClr val="1F2937"/>
+                </a:solidFill>
+                <a:latin typeface="Calibri" pitchFamily="34" charset="0"/>
+                <a:ea typeface="Calibri" pitchFamily="34" charset="-122"/>
+                <a:cs typeface="Calibri" pitchFamily="34" charset="-120"/>
+              </a:rPr>
+              <a:t>Dakar Actu : </a:t>
+            </a:r>
+            <a:pPr indent="0" marL="0">
+              <a:spcAft>
+                <a:spcPts val="300"/>
+              </a:spcAft>
+              <a:buNone/>
+            </a:pPr>
+            <a:r>
+              <a:rPr lang="en-US" sz="1400" i="1" dirty="0">
+                <a:solidFill>
+                  <a:srgbClr val="1F2937"/>
+                </a:solidFill>
+                <a:latin typeface="Calibri" pitchFamily="34" charset="0"/>
+                <a:ea typeface="Calibri" pitchFamily="34" charset="-122"/>
+                <a:cs typeface="Calibri" pitchFamily="34" charset="-120"/>
+              </a:rPr>
+              <a:t>« Une discussion entre deux amis a dégénéré dans la nuit du 26 au 27 octobre à Darou Khoudoss. Selon L’Observateur, Baye M. Diop a été mortellement poignardé par un conducteur de Jakarta qui a pris la fuite. Le différend portait sur la puissance et les caractéristiques des moteurs de motos Jakarta. Il s’est achevé par la mort de Baye M. »</a:t>
+            </a:r>
+            <a:endParaRPr lang="en-US" sz="1400" dirty="0"/>
+          </a:p>
+          <a:p>
+            <a:pPr indent="0" marL="0">
+              <a:spcBef>
+                <a:spcPts val="800"/>
+              </a:spcBef>
+              <a:spcAft>
+                <a:spcPts val="300"/>
+              </a:spcAft>
+              <a:buNone/>
+            </a:pPr>
+            <a:r>
+              <a:rPr lang="en-US" sz="1500" b="1" dirty="0">
+                <a:solidFill>
+                  <a:srgbClr val="1F6B5E"/>
+                </a:solidFill>
+                <a:latin typeface="Calibri" pitchFamily="34" charset="0"/>
+                <a:ea typeface="Calibri" pitchFamily="34" charset="-122"/>
+                <a:cs typeface="Calibri" pitchFamily="34" charset="-120"/>
+              </a:rPr>
+              <a:t>Enjeux sûreté</a:t>
+            </a:r>
+            <a:endParaRPr lang="en-US" sz="1400" dirty="0"/>
+          </a:p>
+          <a:p>
+            <a:pPr indent="0" marL="0">
+              <a:spcAft>
+                <a:spcPts val="300"/>
+              </a:spcAft>
+              <a:buNone/>
+            </a:pPr>
+            <a:r>
+              <a:rPr lang="en-US" sz="1400" dirty="0">
+                <a:solidFill>
+                  <a:srgbClr val="1F2937"/>
+                </a:solidFill>
+                <a:latin typeface="Calibri" pitchFamily="34" charset="0"/>
+                <a:ea typeface="Calibri" pitchFamily="34" charset="-122"/>
+                <a:cs typeface="Calibri" pitchFamily="34" charset="-120"/>
+              </a:rPr>
+              <a:t>Climat politique à suivre : en mesurer l'incidence sur la stabilité locale et les déplacements.</a:t>
+            </a:r>
+            <a:endParaRPr lang="en-US" sz="1400" dirty="0"/>
+          </a:p>
+          <a:p>
+            <a:pPr indent="0" marL="0">
+              <a:spcBef>
+                <a:spcPts val="800"/>
+              </a:spcBef>
+              <a:spcAft>
+                <a:spcPts val="300"/>
+              </a:spcAft>
+              <a:buNone/>
+            </a:pPr>
+            <a:r>
+              <a:rPr lang="en-US" sz="1400" b="1" dirty="0">
+                <a:solidFill>
+                  <a:srgbClr val="1F2937"/>
+                </a:solidFill>
+                <a:latin typeface="Calibri" pitchFamily="34" charset="0"/>
+                <a:ea typeface="Calibri" pitchFamily="34" charset="-122"/>
+                <a:cs typeface="Calibri" pitchFamily="34" charset="-120"/>
+              </a:rPr>
+              <a:t>Source : </a:t>
+            </a:r>
+            <a:pPr indent="0" marL="0">
+              <a:spcAft>
+                <a:spcPts val="300"/>
+              </a:spcAft>
+              <a:buNone/>
+            </a:pPr>
+            <a:r>
+              <a:rPr lang="en-US" sz="1400" u="sng" dirty="0">
                 <a:solidFill>
                   <a:srgbClr val="1F6B5E"/>
                 </a:solidFill>
@@ -24291,284 +24368,81 @@
                   </a:extLst>
                 </a:hlinkClick>
               </a:rPr>
-              <a:t>Pressafrik · APS — Agence Sénégalaise Presse</a:t>
-            </a:r>
-            <a:pPr indent="0" marL="0">
-              <a:spcAft>
-                <a:spcPts val="200"/>
-              </a:spcAft>
-              <a:buNone/>
-            </a:pPr>
-            <a:r>
-              <a:rPr lang="en-US" sz="1300" dirty="0">
-                <a:solidFill>
-                  <a:srgbClr val="1F2937"/>
-                </a:solidFill>
-                <a:latin typeface="Calibri" pitchFamily="34" charset="0"/>
-                <a:ea typeface="Calibri" pitchFamily="34" charset="-122"/>
-                <a:cs typeface="Calibri" pitchFamily="34" charset="-120"/>
-              </a:rPr>
-              <a:t> — 27 octobre 2026, 15 h UTC   ·   </a:t>
-            </a:r>
-            <a:pPr indent="0" marL="0">
-              <a:spcAft>
-                <a:spcPts val="200"/>
-              </a:spcAft>
-              <a:buNone/>
-            </a:pPr>
-            <a:r>
-              <a:rPr lang="en-US" sz="1300" b="1" dirty="0">
-                <a:solidFill>
-                  <a:srgbClr val="1F2937"/>
-                </a:solidFill>
-                <a:latin typeface="Calibri" pitchFamily="34" charset="0"/>
-                <a:ea typeface="Calibri" pitchFamily="34" charset="-122"/>
-                <a:cs typeface="Calibri" pitchFamily="34" charset="-120"/>
-              </a:rPr>
-              <a:t>Cotation : Confirmé</a:t>
-            </a:r>
-            <a:endParaRPr lang="en-US" sz="1300" dirty="0"/>
-          </a:p>
-          <a:p>
-            <a:pPr marL="342900" indent="-342900">
-              <a:spcBef>
-                <a:spcPts val="800"/>
-              </a:spcBef>
-              <a:spcAft>
-                <a:spcPts val="200"/>
-              </a:spcAft>
-              <a:buSzPct val="100000"/>
-              <a:buChar char="❑"/>
-            </a:pPr>
-            <a:r>
-              <a:rPr lang="en-US" sz="1400" b="1" u="sng" dirty="0">
-                <a:solidFill>
-                  <a:srgbClr val="1F6B5E"/>
-                </a:solidFill>
-                <a:latin typeface="Calibri" pitchFamily="34" charset="0"/>
-                <a:ea typeface="Calibri" pitchFamily="34" charset="-122"/>
-                <a:cs typeface="Calibri" pitchFamily="34" charset="-120"/>
-              </a:rPr>
-              <a:t>MALIKA : UN LOCATAIRE INTERPELLÉ POUR AVOIR POIGNARDÉ À MORT SON VOISIN LORS D'UNE ALTERCATION</a:t>
-            </a:r>
-            <a:endParaRPr lang="en-US" sz="1300" dirty="0"/>
-          </a:p>
-          <a:p>
-            <a:pPr lvl="1" marL="685800" indent="-342900">
-              <a:spcAft>
-                <a:spcPts val="200"/>
-              </a:spcAft>
-              <a:buSzPct val="100000"/>
-              <a:buChar char="▪"/>
-            </a:pPr>
-            <a:r>
-              <a:rPr lang="en-US" sz="1300" dirty="0">
-                <a:solidFill>
-                  <a:srgbClr val="1F2937"/>
-                </a:solidFill>
-                <a:latin typeface="Calibri" pitchFamily="34" charset="0"/>
-                <a:ea typeface="Calibri" pitchFamily="34" charset="-122"/>
-                <a:cs typeface="Calibri" pitchFamily="34" charset="-120"/>
-              </a:rPr>
-              <a:t>Source : </a:t>
-            </a:r>
-            <a:pPr indent="0" marL="0">
-              <a:spcAft>
-                <a:spcPts val="200"/>
-              </a:spcAft>
-              <a:buNone/>
-            </a:pPr>
-            <a:r>
-              <a:rPr lang="en-US" sz="1300" u="sng" dirty="0">
-                <a:solidFill>
-                  <a:srgbClr val="1F6B5E"/>
-                </a:solidFill>
-                <a:latin typeface="Calibri" pitchFamily="34" charset="0"/>
-                <a:ea typeface="Calibri" pitchFamily="34" charset="-122"/>
-                <a:cs typeface="Calibri" pitchFamily="34" charset="-120"/>
-                <a:hlinkClick r:id="rId2" invalidUrl="" action="" tgtFrame="" tooltip="" history="1" highlightClick="0" endSnd="0">
-                  <a:extLst>
-                    <a:ext uri="{A12FA001-AC4F-418D-AE19-62706E023703}">
-                      <ahyp:hlinkClr xmlns:ahyp="http://schemas.microsoft.com/office/drawing/2018/hyperlinkcolor" val="tx"/>
-                    </a:ext>
-                  </a:extLst>
-                </a:hlinkClick>
-              </a:rPr>
-              <a:t>Seneweb</a:t>
-            </a:r>
-            <a:pPr indent="0" marL="0">
-              <a:spcAft>
-                <a:spcPts val="200"/>
-              </a:spcAft>
-              <a:buNone/>
-            </a:pPr>
-            <a:r>
-              <a:rPr lang="en-US" sz="1300" dirty="0">
-                <a:solidFill>
-                  <a:srgbClr val="1F2937"/>
-                </a:solidFill>
-                <a:latin typeface="Calibri" pitchFamily="34" charset="0"/>
-                <a:ea typeface="Calibri" pitchFamily="34" charset="-122"/>
-                <a:cs typeface="Calibri" pitchFamily="34" charset="-120"/>
-              </a:rPr>
-              <a:t> — 27 octobre 2026, 13 h UTC</a:t>
-            </a:r>
-            <a:endParaRPr lang="en-US" sz="1300" dirty="0"/>
-          </a:p>
-          <a:p>
-            <a:pPr marL="342900" indent="-342900">
-              <a:spcBef>
-                <a:spcPts val="800"/>
-              </a:spcBef>
-              <a:spcAft>
-                <a:spcPts val="200"/>
-              </a:spcAft>
-              <a:buSzPct val="100000"/>
-              <a:buChar char="❑"/>
-            </a:pPr>
-            <a:r>
-              <a:rPr lang="en-US" sz="1400" b="1" u="sng" dirty="0">
-                <a:solidFill>
-                  <a:srgbClr val="1F6B5E"/>
-                </a:solidFill>
-                <a:latin typeface="Calibri" pitchFamily="34" charset="0"/>
-                <a:ea typeface="Calibri" pitchFamily="34" charset="-122"/>
-                <a:cs typeface="Calibri" pitchFamily="34" charset="-120"/>
-              </a:rPr>
-              <a:t>MEURTRE PRÉSUMÉ D’AMINATA SY À PODOR : LE SUSPECT RETROUVÉ DANS UNE CACHETTE ET ARRÊTÉ À MBACKÉ</a:t>
-            </a:r>
-            <a:endParaRPr lang="en-US" sz="1300" dirty="0"/>
-          </a:p>
-          <a:p>
-            <a:pPr lvl="1" marL="685800" indent="-342900">
-              <a:spcAft>
-                <a:spcPts val="200"/>
-              </a:spcAft>
-              <a:buSzPct val="100000"/>
-              <a:buChar char="▪"/>
-            </a:pPr>
-            <a:r>
-              <a:rPr lang="en-US" sz="1300" dirty="0">
-                <a:solidFill>
-                  <a:srgbClr val="1F2937"/>
-                </a:solidFill>
-                <a:latin typeface="Calibri" pitchFamily="34" charset="0"/>
-                <a:ea typeface="Calibri" pitchFamily="34" charset="-122"/>
-                <a:cs typeface="Calibri" pitchFamily="34" charset="-120"/>
-              </a:rPr>
-              <a:t>Sources : </a:t>
-            </a:r>
-            <a:pPr indent="0" marL="0">
-              <a:spcAft>
-                <a:spcPts val="200"/>
-              </a:spcAft>
-              <a:buNone/>
-            </a:pPr>
-            <a:r>
-              <a:rPr lang="en-US" sz="1300" u="sng" dirty="0">
-                <a:solidFill>
-                  <a:srgbClr val="1F6B5E"/>
-                </a:solidFill>
-                <a:latin typeface="Calibri" pitchFamily="34" charset="0"/>
-                <a:ea typeface="Calibri" pitchFamily="34" charset="-122"/>
-                <a:cs typeface="Calibri" pitchFamily="34" charset="-120"/>
-                <a:hlinkClick r:id="rId3" invalidUrl="" action="" tgtFrame="" tooltip="" history="1" highlightClick="0" endSnd="0">
-                  <a:extLst>
-                    <a:ext uri="{A12FA001-AC4F-418D-AE19-62706E023703}">
-                      <ahyp:hlinkClr xmlns:ahyp="http://schemas.microsoft.com/office/drawing/2018/hyperlinkcolor" val="tx"/>
-                    </a:ext>
-                  </a:extLst>
-                </a:hlinkClick>
-              </a:rPr>
-              <a:t>Dakar Actu · Seneweb</a:t>
-            </a:r>
-            <a:pPr indent="0" marL="0">
-              <a:spcAft>
-                <a:spcPts val="200"/>
-              </a:spcAft>
-              <a:buNone/>
-            </a:pPr>
-            <a:r>
-              <a:rPr lang="en-US" sz="1300" dirty="0">
-                <a:solidFill>
-                  <a:srgbClr val="1F2937"/>
-                </a:solidFill>
-                <a:latin typeface="Calibri" pitchFamily="34" charset="0"/>
-                <a:ea typeface="Calibri" pitchFamily="34" charset="-122"/>
-                <a:cs typeface="Calibri" pitchFamily="34" charset="-120"/>
-              </a:rPr>
-              <a:t> — 27 octobre 2026, 11 h UTC   ·   </a:t>
-            </a:r>
-            <a:pPr indent="0" marL="0">
-              <a:spcAft>
-                <a:spcPts val="200"/>
-              </a:spcAft>
-              <a:buNone/>
-            </a:pPr>
-            <a:r>
-              <a:rPr lang="en-US" sz="1300" b="1" dirty="0">
-                <a:solidFill>
-                  <a:srgbClr val="1F2937"/>
-                </a:solidFill>
-                <a:latin typeface="Calibri" pitchFamily="34" charset="0"/>
-                <a:ea typeface="Calibri" pitchFamily="34" charset="-122"/>
-                <a:cs typeface="Calibri" pitchFamily="34" charset="-120"/>
-              </a:rPr>
-              <a:t>Cotation : Confirmé</a:t>
-            </a:r>
-            <a:endParaRPr lang="en-US" sz="1300" dirty="0"/>
-          </a:p>
-          <a:p>
-            <a:pPr marL="342900" indent="-342900">
-              <a:spcBef>
-                <a:spcPts val="800"/>
-              </a:spcBef>
-              <a:spcAft>
-                <a:spcPts val="200"/>
-              </a:spcAft>
-              <a:buSzPct val="100000"/>
-              <a:buChar char="❑"/>
-            </a:pPr>
-            <a:r>
-              <a:rPr lang="en-US" sz="1400" b="1" u="sng" dirty="0">
-                <a:solidFill>
-                  <a:srgbClr val="1F6B5E"/>
-                </a:solidFill>
-                <a:latin typeface="Calibri" pitchFamily="34" charset="0"/>
-                <a:ea typeface="Calibri" pitchFamily="34" charset="-122"/>
-                <a:cs typeface="Calibri" pitchFamily="34" charset="-120"/>
-              </a:rPr>
-              <a:t>KARAMO CISSÉ NDIAYE ARRÊTÉ POUR LE MEURTRE D’AMINATA SY APRÈS UNE DISPUTE VIOLENTE</a:t>
-            </a:r>
-            <a:endParaRPr lang="en-US" sz="1300" dirty="0"/>
-          </a:p>
-          <a:p>
-            <a:pPr lvl="1" marL="685800" indent="-342900">
-              <a:spcAft>
-                <a:spcPts val="200"/>
-              </a:spcAft>
-              <a:buSzPct val="100000"/>
-              <a:buChar char="▪"/>
-            </a:pPr>
-            <a:r>
-              <a:rPr lang="en-US" sz="1300" dirty="0">
-                <a:solidFill>
-                  <a:srgbClr val="1F2937"/>
-                </a:solidFill>
-                <a:latin typeface="Calibri" pitchFamily="34" charset="0"/>
-                <a:ea typeface="Calibri" pitchFamily="34" charset="-122"/>
-                <a:cs typeface="Calibri" pitchFamily="34" charset="-120"/>
-              </a:rPr>
-              <a:t>Source : </a:t>
-            </a:r>
-            <a:pPr indent="0" marL="0">
-              <a:spcAft>
-                <a:spcPts val="200"/>
-              </a:spcAft>
-              <a:buNone/>
-            </a:pPr>
-            <a:r>
-              <a:rPr lang="en-US" sz="1300" u="sng" dirty="0">
+              <a:t>Dakar Actu</a:t>
+            </a:r>
+            <a:pPr indent="0" marL="0">
+              <a:spcAft>
+                <a:spcPts val="300"/>
+              </a:spcAft>
+              <a:buNone/>
+            </a:pPr>
+            <a:r>
+              <a:rPr lang="en-US" sz="1400" b="1" dirty="0">
+                <a:solidFill>
+                  <a:srgbClr val="1F2937"/>
+                </a:solidFill>
+                <a:latin typeface="Calibri" pitchFamily="34" charset="0"/>
+                <a:ea typeface="Calibri" pitchFamily="34" charset="-122"/>
+                <a:cs typeface="Calibri" pitchFamily="34" charset="-120"/>
+              </a:rPr>
+              <a:t> — 28 octobre 2026, 8 h UTC   ·   Cotation : Probable</a:t>
+            </a:r>
+            <a:endParaRPr lang="en-US" sz="1400" dirty="0"/>
+          </a:p>
+        </p:txBody>
+      </p:sp>
+      <p:pic>
+        <p:nvPicPr>
+          <p:cNvPr id="12" name="Image 0" descr="preencoded.png">
+            <a:hlinkClick r:id="rId3" tooltip=""/>
+          </p:cNvPr>
+          <p:cNvPicPr>
+            <a:picLocks noChangeAspect="1"/>
+          </p:cNvPicPr>
+          <p:nvPr/>
+        </p:nvPicPr>
+        <p:blipFill>
+          <a:blip r:embed="rId2"/>
+          <a:stretch>
+            <a:fillRect/>
+          </a:stretch>
+        </p:blipFill>
+        <p:spPr>
+          <a:xfrm>
+            <a:off x="7635240" y="2075688"/>
+            <a:ext cx="4114800" cy="2314575"/>
+          </a:xfrm>
+          <a:prstGeom prst="rect">
+            <a:avLst/>
+          </a:prstGeom>
+        </p:spPr>
+      </p:pic>
+      <p:sp>
+        <p:nvSpPr>
+          <p:cNvPr id="13" name="Text 10"/>
+          <p:cNvSpPr/>
+          <p:nvPr/>
+        </p:nvSpPr>
+        <p:spPr>
+          <a:xfrm>
+            <a:off x="7635240" y="4426839"/>
+            <a:ext cx="4114800" cy="256032"/>
+          </a:xfrm>
+          <a:prstGeom prst="rect">
+            <a:avLst/>
+          </a:prstGeom>
+          <a:noFill/>
+          <a:ln/>
+        </p:spPr>
+        <p:txBody>
+          <a:bodyPr wrap="square" rtlCol="0" anchor="ctr"/>
+          <a:lstStyle/>
+          <a:p>
+            <a:pPr algn="r" indent="0" marL="0">
+              <a:buNone/>
+            </a:pPr>
+            <a:r>
+              <a:rPr lang="en-US" sz="900" u="sng" dirty="0">
                 <a:solidFill>
                   <a:srgbClr val="1F6B5E"/>
                 </a:solidFill>
@@ -24583,118 +24457,15 @@
                   </a:extLst>
                 </a:hlinkClick>
               </a:rPr>
-              <a:t>SeneNews</a:t>
-            </a:r>
-            <a:pPr indent="0" marL="0">
-              <a:spcAft>
-                <a:spcPts val="200"/>
-              </a:spcAft>
-              <a:buNone/>
-            </a:pPr>
-            <a:r>
-              <a:rPr lang="en-US" sz="1300" dirty="0">
-                <a:solidFill>
-                  <a:srgbClr val="1F2937"/>
-                </a:solidFill>
-                <a:latin typeface="Calibri" pitchFamily="34" charset="0"/>
-                <a:ea typeface="Calibri" pitchFamily="34" charset="-122"/>
-                <a:cs typeface="Calibri" pitchFamily="34" charset="-120"/>
-              </a:rPr>
-              <a:t> — 27 octobre 2026, 8 h UTC</a:t>
-            </a:r>
-            <a:endParaRPr lang="en-US" sz="1300" dirty="0"/>
-          </a:p>
-          <a:p>
-            <a:pPr marL="342900" indent="-342900">
-              <a:spcBef>
-                <a:spcPts val="800"/>
-              </a:spcBef>
-              <a:spcAft>
-                <a:spcPts val="200"/>
-              </a:spcAft>
-              <a:buSzPct val="100000"/>
-              <a:buChar char="❑"/>
-            </a:pPr>
-            <a:r>
-              <a:rPr lang="en-US" sz="1400" b="1" u="sng" dirty="0">
-                <a:solidFill>
-                  <a:srgbClr val="1F6B5E"/>
-                </a:solidFill>
-                <a:latin typeface="Calibri" pitchFamily="34" charset="0"/>
-                <a:ea typeface="Calibri" pitchFamily="34" charset="-122"/>
-                <a:cs typeface="Calibri" pitchFamily="34" charset="-120"/>
-              </a:rPr>
-              <a:t>DRAME À ZIGUINCHOR : UN COMMERÇANT RETROUVÉ MORT PENDU APRÈS LA PERTE DE 800 000 F CFA</a:t>
-            </a:r>
-            <a:endParaRPr lang="en-US" sz="1300" dirty="0"/>
-          </a:p>
-          <a:p>
-            <a:pPr lvl="1" marL="685800" indent="-342900">
-              <a:spcAft>
-                <a:spcPts val="200"/>
-              </a:spcAft>
-              <a:buSzPct val="100000"/>
-              <a:buChar char="▪"/>
-            </a:pPr>
-            <a:r>
-              <a:rPr lang="en-US" sz="1300" dirty="0">
-                <a:solidFill>
-                  <a:srgbClr val="1F2937"/>
-                </a:solidFill>
-                <a:latin typeface="Calibri" pitchFamily="34" charset="0"/>
-                <a:ea typeface="Calibri" pitchFamily="34" charset="-122"/>
-                <a:cs typeface="Calibri" pitchFamily="34" charset="-120"/>
-              </a:rPr>
-              <a:t>Source : </a:t>
-            </a:r>
-            <a:pPr indent="0" marL="0">
-              <a:spcAft>
-                <a:spcPts val="200"/>
-              </a:spcAft>
-              <a:buNone/>
-            </a:pPr>
-            <a:r>
-              <a:rPr lang="en-US" sz="1300" u="sng" dirty="0">
-                <a:solidFill>
-                  <a:srgbClr val="1F6B5E"/>
-                </a:solidFill>
-                <a:latin typeface="Calibri" pitchFamily="34" charset="0"/>
-                <a:ea typeface="Calibri" pitchFamily="34" charset="-122"/>
-                <a:cs typeface="Calibri" pitchFamily="34" charset="-120"/>
-                <a:hlinkClick r:id="rId5" invalidUrl="" action="" tgtFrame="" tooltip="" history="1" highlightClick="0" endSnd="0">
-                  <a:extLst>
-                    <a:ext uri="{A12FA001-AC4F-418D-AE19-62706E023703}">
-                      <ahyp:hlinkClr xmlns:ahyp="http://schemas.microsoft.com/office/drawing/2018/hyperlinkcolor" val="tx"/>
-                    </a:ext>
-                  </a:extLst>
-                </a:hlinkClick>
-              </a:rPr>
-              <a:t>Seneweb</a:t>
-            </a:r>
-            <a:pPr indent="0" marL="0">
-              <a:spcAft>
-                <a:spcPts val="200"/>
-              </a:spcAft>
-              <a:buNone/>
-            </a:pPr>
-            <a:r>
-              <a:rPr lang="en-US" sz="1300" dirty="0">
-                <a:solidFill>
-                  <a:srgbClr val="1F2937"/>
-                </a:solidFill>
-                <a:latin typeface="Calibri" pitchFamily="34" charset="0"/>
-                <a:ea typeface="Calibri" pitchFamily="34" charset="-122"/>
-                <a:cs typeface="Calibri" pitchFamily="34" charset="-120"/>
-              </a:rPr>
-              <a:t> — 26 octobre 2026, 23 h UTC</a:t>
-            </a:r>
-            <a:endParaRPr lang="en-US" sz="1300" dirty="0"/>
-          </a:p>
-        </p:txBody>
-      </p:sp>
-      <p:sp>
-        <p:nvSpPr>
-          <p:cNvPr id="10" name="Text 8"/>
+              <a:t>Photo : © dakaractu.com</a:t>
+            </a:r>
+            <a:endParaRPr lang="en-US" sz="900" dirty="0"/>
+          </a:p>
+        </p:txBody>
+      </p:sp>
+      <p:sp>
+        <p:nvSpPr>
+          <p:cNvPr id="14" name="Text 11"/>
           <p:cNvSpPr/>
           <p:nvPr/>
         </p:nvSpPr>
@@ -24739,7 +24510,7 @@
       </p:sp>
       <p:sp>
         <p:nvSpPr>
-          <p:cNvPr id="11" name="Text 9"/>
+          <p:cNvPr id="15" name="Text 12"/>
           <p:cNvSpPr/>
           <p:nvPr/>
         </p:nvSpPr>
@@ -24770,7 +24541,7 @@
                 <a:ea typeface="Calibri" pitchFamily="34" charset="-122"/>
                 <a:cs typeface="Calibri" pitchFamily="34" charset="-120"/>
               </a:rPr>
-              <a:t>|  27/10/26   |   36</a:t>
+              <a:t>|  28/10/26   |   36</a:t>
             </a:r>
             <a:endParaRPr lang="en-US" sz="1000" dirty="0"/>
           </a:p>
@@ -25043,7 +24814,7 @@
                 <a:ea typeface="Calibri" pitchFamily="34" charset="-122"/>
                 <a:cs typeface="Calibri" pitchFamily="34" charset="-120"/>
               </a:rPr>
-              <a:t>« ILS L’ONT DÉCOUVERT PENDU » : LE GRAND COMMERÇANT ABDOULAYE DIALLO S’EST DONNÉ LA MORT DANS SA BOUTIQUE</a:t>
+              <a:t>MORT D’AMINATA SY : LE SUSPECT INVOQUE UNE CHUTE, LES CONSTATATIONS DÉCRIVENT DES VIOLENCES</a:t>
             </a:r>
             <a:endParaRPr lang="en-US" sz="1300" dirty="0"/>
           </a:p>
@@ -25088,7 +24859,7 @@
                   </a:extLst>
                 </a:hlinkClick>
               </a:rPr>
-              <a:t>SeneNews</a:t>
+              <a:t>Dakar Actu</a:t>
             </a:r>
             <a:pPr indent="0" marL="0">
               <a:spcAft>
@@ -25105,7 +24876,7 @@
                 <a:ea typeface="Calibri" pitchFamily="34" charset="-122"/>
                 <a:cs typeface="Calibri" pitchFamily="34" charset="-120"/>
               </a:rPr>
-              <a:t> — 26 octobre 2026, 21 h UTC   ·   </a:t>
+              <a:t> — 28 octobre 2026, 8 h UTC   ·   </a:t>
             </a:r>
             <a:pPr indent="0" marL="0">
               <a:spcAft>
@@ -25122,7 +24893,7 @@
                 <a:ea typeface="Calibri" pitchFamily="34" charset="-122"/>
                 <a:cs typeface="Calibri" pitchFamily="34" charset="-120"/>
               </a:rPr>
-              <a:t>Cotation : Non confirmé</a:t>
+              <a:t>Cotation : Probable</a:t>
             </a:r>
             <a:endParaRPr lang="en-US" sz="1300" dirty="0"/>
           </a:p>
@@ -25146,7 +24917,7 @@
                 <a:ea typeface="Calibri" pitchFamily="34" charset="-122"/>
                 <a:cs typeface="Calibri" pitchFamily="34" charset="-120"/>
               </a:rPr>
-              <a:t>ZIGUINCHOR : UN JEUNE HOMME RETROUVÉ MORT DANS UNE BOUTIQUE À TILÈNE</a:t>
+              <a:t>TALIBOU DIALLO TUÉ AU COU ET AU THORAX : UNE DISPUTE ENTRE COLOCATAIRES POUR UNE PRISE ÉLECTRIQUE, AU CŒUR DU DRAME</a:t>
             </a:r>
             <a:endParaRPr lang="en-US" sz="1300" dirty="0"/>
           </a:p>
@@ -25208,7 +24979,24 @@
                 <a:ea typeface="Calibri" pitchFamily="34" charset="-122"/>
                 <a:cs typeface="Calibri" pitchFamily="34" charset="-120"/>
               </a:rPr>
-              <a:t> — 26 octobre 2026, 17 h UTC</a:t>
+              <a:t> — 28 octobre 2026, 8 h UTC   ·   </a:t>
+            </a:r>
+            <a:pPr indent="0" marL="0">
+              <a:spcAft>
+                <a:spcPts val="200"/>
+              </a:spcAft>
+              <a:buNone/>
+            </a:pPr>
+            <a:r>
+              <a:rPr lang="en-US" sz="1300" b="1" dirty="0">
+                <a:solidFill>
+                  <a:srgbClr val="1F2937"/>
+                </a:solidFill>
+                <a:latin typeface="Calibri" pitchFamily="34" charset="0"/>
+                <a:ea typeface="Calibri" pitchFamily="34" charset="-122"/>
+                <a:cs typeface="Calibri" pitchFamily="34" charset="-120"/>
+              </a:rPr>
+              <a:t>Cotation : Probable</a:t>
             </a:r>
             <a:endParaRPr lang="en-US" sz="1300" dirty="0"/>
           </a:p>
@@ -25232,7 +25020,7 @@
                 <a:ea typeface="Calibri" pitchFamily="34" charset="-122"/>
                 <a:cs typeface="Calibri" pitchFamily="34" charset="-120"/>
               </a:rPr>
-              <a:t>FÉMINICIDES AU SÉNÉGAL – AMINATA SY ET MAME DIARRA SOW TUÉES LE MÊME JOUR : SEYDI GASSAMA LANCE UN CRI D’ALARME</a:t>
+              <a:t>LYCÉENNE TUÉE À PODOR : DE L'HISTOIRE D'AMOUR AU DRAME</a:t>
             </a:r>
             <a:endParaRPr lang="en-US" sz="1300" dirty="0"/>
           </a:p>
@@ -25277,7 +25065,7 @@
                   </a:extLst>
                 </a:hlinkClick>
               </a:rPr>
-              <a:t>SeneNews</a:t>
+              <a:t>Seneweb</a:t>
             </a:r>
             <a:pPr indent="0" marL="0">
               <a:spcAft>
@@ -25294,7 +25082,24 @@
                 <a:ea typeface="Calibri" pitchFamily="34" charset="-122"/>
                 <a:cs typeface="Calibri" pitchFamily="34" charset="-120"/>
               </a:rPr>
-              <a:t> — 26 octobre 2026, 17 h UTC</a:t>
+              <a:t> — 28 octobre 2026, 7 h UTC   ·   </a:t>
+            </a:r>
+            <a:pPr indent="0" marL="0">
+              <a:spcAft>
+                <a:spcPts val="200"/>
+              </a:spcAft>
+              <a:buNone/>
+            </a:pPr>
+            <a:r>
+              <a:rPr lang="en-US" sz="1300" b="1" dirty="0">
+                <a:solidFill>
+                  <a:srgbClr val="1F2937"/>
+                </a:solidFill>
+                <a:latin typeface="Calibri" pitchFamily="34" charset="0"/>
+                <a:ea typeface="Calibri" pitchFamily="34" charset="-122"/>
+                <a:cs typeface="Calibri" pitchFamily="34" charset="-120"/>
+              </a:rPr>
+              <a:t>Cotation : Probable</a:t>
             </a:r>
             <a:endParaRPr lang="en-US" sz="1300" dirty="0"/>
           </a:p>
@@ -25318,7 +25123,7 @@
                 <a:ea typeface="Calibri" pitchFamily="34" charset="-122"/>
                 <a:cs typeface="Calibri" pitchFamily="34" charset="-120"/>
               </a:rPr>
-              <a:t>TROPHÉE ANPS : LE TROPHÉE DU MEILLEUR LUTTEUR EN LUTTE AVEC FRAPPE PORTE DÉSORMAIS LE NOM DE MANGA II</a:t>
+              <a:t>IMMEUBLE EFFONDRÉ À THIÈS : UN MORT ET DEUX BLESSÉS, SELON LE BILAN PROVISOIRE</a:t>
             </a:r>
             <a:endParaRPr lang="en-US" sz="1300" dirty="0"/>
           </a:p>
@@ -25339,7 +25144,7 @@
                 <a:ea typeface="Calibri" pitchFamily="34" charset="-122"/>
                 <a:cs typeface="Calibri" pitchFamily="34" charset="-120"/>
               </a:rPr>
-              <a:t>Source : </a:t>
+              <a:t>Sources : </a:t>
             </a:r>
             <a:pPr indent="0" marL="0">
               <a:spcAft>
@@ -25363,7 +25168,7 @@
                   </a:extLst>
                 </a:hlinkClick>
               </a:rPr>
-              <a:t>wiwsport</a:t>
+              <a:t>APS — Agence Sénégalaise Presse · Pressafrik</a:t>
             </a:r>
             <a:pPr indent="0" marL="0">
               <a:spcAft>
@@ -25380,7 +25185,127 @@
                 <a:ea typeface="Calibri" pitchFamily="34" charset="-122"/>
                 <a:cs typeface="Calibri" pitchFamily="34" charset="-120"/>
               </a:rPr>
-              <a:t> — 26 octobre 2026, 13 h UTC</a:t>
+              <a:t> — 27 octobre 2026, 19 h UTC   ·   </a:t>
+            </a:r>
+            <a:pPr indent="0" marL="0">
+              <a:spcAft>
+                <a:spcPts val="200"/>
+              </a:spcAft>
+              <a:buNone/>
+            </a:pPr>
+            <a:r>
+              <a:rPr lang="en-US" sz="1300" b="1" dirty="0">
+                <a:solidFill>
+                  <a:srgbClr val="1F2937"/>
+                </a:solidFill>
+                <a:latin typeface="Calibri" pitchFamily="34" charset="0"/>
+                <a:ea typeface="Calibri" pitchFamily="34" charset="-122"/>
+                <a:cs typeface="Calibri" pitchFamily="34" charset="-120"/>
+              </a:rPr>
+              <a:t>Cotation : Confirmé</a:t>
+            </a:r>
+            <a:endParaRPr lang="en-US" sz="1300" dirty="0"/>
+          </a:p>
+          <a:p>
+            <a:pPr marL="342900" indent="-342900">
+              <a:spcBef>
+                <a:spcPts val="800"/>
+              </a:spcBef>
+              <a:spcAft>
+                <a:spcPts val="200"/>
+              </a:spcAft>
+              <a:buSzPct val="100000"/>
+              <a:buChar char="❑"/>
+            </a:pPr>
+            <a:r>
+              <a:rPr lang="en-US" sz="1400" b="1" u="sng" dirty="0">
+                <a:solidFill>
+                  <a:srgbClr val="1F6B5E"/>
+                </a:solidFill>
+                <a:latin typeface="Calibri" pitchFamily="34" charset="0"/>
+                <a:ea typeface="Calibri" pitchFamily="34" charset="-122"/>
+                <a:cs typeface="Calibri" pitchFamily="34" charset="-120"/>
+              </a:rPr>
+              <a:t>PACTE DE STABILITÉ SOCIALE : LE GOUVERNEMENT VISE 71 % D’EXÉCUTION DES ENGAGEMENTS EN DÉCEMBRE</a:t>
+            </a:r>
+            <a:endParaRPr lang="en-US" sz="1300" dirty="0"/>
+          </a:p>
+          <a:p>
+            <a:pPr lvl="1" marL="685800" indent="-342900">
+              <a:spcAft>
+                <a:spcPts val="200"/>
+              </a:spcAft>
+              <a:buSzPct val="100000"/>
+              <a:buChar char="▪"/>
+            </a:pPr>
+            <a:r>
+              <a:rPr lang="en-US" sz="1300" dirty="0">
+                <a:solidFill>
+                  <a:srgbClr val="1F2937"/>
+                </a:solidFill>
+                <a:latin typeface="Calibri" pitchFamily="34" charset="0"/>
+                <a:ea typeface="Calibri" pitchFamily="34" charset="-122"/>
+                <a:cs typeface="Calibri" pitchFamily="34" charset="-120"/>
+              </a:rPr>
+              <a:t>Sources : </a:t>
+            </a:r>
+            <a:pPr indent="0" marL="0">
+              <a:spcAft>
+                <a:spcPts val="200"/>
+              </a:spcAft>
+              <a:buNone/>
+            </a:pPr>
+            <a:r>
+              <a:rPr lang="en-US" sz="1300" u="sng" dirty="0">
+                <a:solidFill>
+                  <a:srgbClr val="1F6B5E"/>
+                </a:solidFill>
+                <a:latin typeface="Calibri" pitchFamily="34" charset="0"/>
+                <a:ea typeface="Calibri" pitchFamily="34" charset="-122"/>
+                <a:cs typeface="Calibri" pitchFamily="34" charset="-120"/>
+                <a:hlinkClick r:id="rId5" invalidUrl="" action="" tgtFrame="" tooltip="" history="1" highlightClick="0" endSnd="0">
+                  <a:extLst>
+                    <a:ext uri="{A12FA001-AC4F-418D-AE19-62706E023703}">
+                      <ahyp:hlinkClr xmlns:ahyp="http://schemas.microsoft.com/office/drawing/2018/hyperlinkcolor" val="tx"/>
+                    </a:ext>
+                  </a:extLst>
+                </a:hlinkClick>
+              </a:rPr>
+              <a:t>Pressafrik · APS — Agence Sénégalaise Presse</a:t>
+            </a:r>
+            <a:pPr indent="0" marL="0">
+              <a:spcAft>
+                <a:spcPts val="200"/>
+              </a:spcAft>
+              <a:buNone/>
+            </a:pPr>
+            <a:r>
+              <a:rPr lang="en-US" sz="1300" dirty="0">
+                <a:solidFill>
+                  <a:srgbClr val="1F2937"/>
+                </a:solidFill>
+                <a:latin typeface="Calibri" pitchFamily="34" charset="0"/>
+                <a:ea typeface="Calibri" pitchFamily="34" charset="-122"/>
+                <a:cs typeface="Calibri" pitchFamily="34" charset="-120"/>
+              </a:rPr>
+              <a:t> — 27 octobre 2026, 15 h UTC   ·   </a:t>
+            </a:r>
+            <a:pPr indent="0" marL="0">
+              <a:spcAft>
+                <a:spcPts val="200"/>
+              </a:spcAft>
+              <a:buNone/>
+            </a:pPr>
+            <a:r>
+              <a:rPr lang="en-US" sz="1300" b="1" dirty="0">
+                <a:solidFill>
+                  <a:srgbClr val="1F2937"/>
+                </a:solidFill>
+                <a:latin typeface="Calibri" pitchFamily="34" charset="0"/>
+                <a:ea typeface="Calibri" pitchFamily="34" charset="-122"/>
+                <a:cs typeface="Calibri" pitchFamily="34" charset="-120"/>
+              </a:rPr>
+              <a:t>Cotation : Confirmé</a:t>
             </a:r>
             <a:endParaRPr lang="en-US" sz="1300" dirty="0"/>
           </a:p>
@@ -25464,7 +25389,7 @@
                 <a:ea typeface="Calibri" pitchFamily="34" charset="-122"/>
                 <a:cs typeface="Calibri" pitchFamily="34" charset="-120"/>
               </a:rPr>
-              <a:t>|  27/10/26   |   37</a:t>
+              <a:t>|  28/10/26   |   37</a:t>
             </a:r>
             <a:endParaRPr lang="en-US" sz="1000" dirty="0"/>
           </a:p>
@@ -25481,6 +25406,700 @@
 <file path=ppt/slides/slide38.xml><?xml version="1.0" encoding="utf-8"?>
 <p:sld xmlns:a="http://schemas.openxmlformats.org/drawingml/2006/main" xmlns:r="http://schemas.openxmlformats.org/officeDocument/2006/relationships" xmlns:p="http://schemas.openxmlformats.org/presentationml/2006/main">
   <p:cSld name="Slide 38">
+    <p:spTree>
+      <p:nvGrpSpPr>
+        <p:cNvPr id="1" name=""/>
+        <p:cNvGrpSpPr/>
+        <p:nvPr/>
+      </p:nvGrpSpPr>
+      <p:grpSpPr>
+        <a:xfrm>
+          <a:off x="0" y="0"/>
+          <a:ext cx="0" cy="0"/>
+          <a:chOff x="0" y="0"/>
+          <a:chExt cx="0" cy="0"/>
+        </a:xfrm>
+      </p:grpSpPr>
+      <p:sp>
+        <p:nvSpPr>
+          <p:cNvPr id="2" name="Text 0"/>
+          <p:cNvSpPr/>
+          <p:nvPr/>
+        </p:nvSpPr>
+        <p:spPr>
+          <a:xfrm>
+            <a:off x="457200" y="274320"/>
+            <a:ext cx="640080" cy="548640"/>
+          </a:xfrm>
+          <a:prstGeom prst="rect">
+            <a:avLst/>
+          </a:prstGeom>
+          <a:solidFill>
+            <a:srgbClr val="1F6B5E"/>
+          </a:solidFill>
+          <a:ln/>
+        </p:spPr>
+        <p:txBody>
+          <a:bodyPr wrap="square" rtlCol="0" anchor="ctr">
+            <a:normAutofit/>
+          </a:bodyPr>
+          <a:lstStyle/>
+          <a:p>
+            <a:pPr algn="ctr" indent="0" marL="0">
+              <a:buNone/>
+            </a:pPr>
+            <a:r>
+              <a:rPr lang="en-US" sz="2400" dirty="0">
+                <a:solidFill>
+                  <a:srgbClr val="FFFFFF"/>
+                </a:solidFill>
+                <a:latin typeface="Arial Narrow" pitchFamily="34" charset="0"/>
+                <a:ea typeface="Arial Narrow" pitchFamily="34" charset="-122"/>
+                <a:cs typeface="Arial Narrow" pitchFamily="34" charset="-120"/>
+              </a:rPr>
+              <a:t>IX</a:t>
+            </a:r>
+            <a:endParaRPr lang="en-US" sz="2400" dirty="0"/>
+          </a:p>
+        </p:txBody>
+      </p:sp>
+      <p:sp>
+        <p:nvSpPr>
+          <p:cNvPr id="3" name="Text 1"/>
+          <p:cNvSpPr/>
+          <p:nvPr/>
+        </p:nvSpPr>
+        <p:spPr>
+          <a:xfrm>
+            <a:off x="1234440" y="274320"/>
+            <a:ext cx="8961120" cy="548640"/>
+          </a:xfrm>
+          <a:prstGeom prst="rect">
+            <a:avLst/>
+          </a:prstGeom>
+          <a:noFill/>
+          <a:ln/>
+        </p:spPr>
+        <p:txBody>
+          <a:bodyPr wrap="square" rtlCol="0" anchor="ctr"/>
+          <a:lstStyle/>
+          <a:p>
+            <a:pPr indent="0" marL="0">
+              <a:buNone/>
+            </a:pPr>
+            <a:r>
+              <a:rPr lang="en-US" sz="2800" dirty="0">
+                <a:solidFill>
+                  <a:srgbClr val="1F6B5E"/>
+                </a:solidFill>
+                <a:latin typeface="Arial Narrow" pitchFamily="34" charset="0"/>
+                <a:ea typeface="Arial Narrow" pitchFamily="34" charset="-122"/>
+                <a:cs typeface="Arial Narrow" pitchFamily="34" charset="-120"/>
+              </a:rPr>
+              <a:t>Sénégal</a:t>
+            </a:r>
+            <a:endParaRPr lang="en-US" sz="2800" dirty="0"/>
+          </a:p>
+        </p:txBody>
+      </p:sp>
+      <p:sp>
+        <p:nvSpPr>
+          <p:cNvPr id="4" name="Shape 2"/>
+          <p:cNvSpPr/>
+          <p:nvPr/>
+        </p:nvSpPr>
+        <p:spPr>
+          <a:xfrm>
+            <a:off x="10881360" y="274320"/>
+            <a:ext cx="301752" cy="566928"/>
+          </a:xfrm>
+          <a:prstGeom prst="rect">
+            <a:avLst/>
+          </a:prstGeom>
+          <a:solidFill>
+            <a:srgbClr val="00853F"/>
+          </a:solidFill>
+          <a:ln w="12700">
+            <a:solidFill>
+              <a:srgbClr val="00853F"/>
+            </a:solidFill>
+            <a:prstDash val="solid"/>
+          </a:ln>
+        </p:spPr>
+      </p:sp>
+      <p:sp>
+        <p:nvSpPr>
+          <p:cNvPr id="5" name="Shape 3"/>
+          <p:cNvSpPr/>
+          <p:nvPr/>
+        </p:nvSpPr>
+        <p:spPr>
+          <a:xfrm>
+            <a:off x="11183112" y="274320"/>
+            <a:ext cx="301752" cy="566928"/>
+          </a:xfrm>
+          <a:prstGeom prst="rect">
+            <a:avLst/>
+          </a:prstGeom>
+          <a:solidFill>
+            <a:srgbClr val="FDEF42"/>
+          </a:solidFill>
+          <a:ln w="12700">
+            <a:solidFill>
+              <a:srgbClr val="FDEF42"/>
+            </a:solidFill>
+            <a:prstDash val="solid"/>
+          </a:ln>
+        </p:spPr>
+      </p:sp>
+      <p:sp>
+        <p:nvSpPr>
+          <p:cNvPr id="6" name="Shape 4"/>
+          <p:cNvSpPr/>
+          <p:nvPr/>
+        </p:nvSpPr>
+        <p:spPr>
+          <a:xfrm>
+            <a:off x="11484864" y="274320"/>
+            <a:ext cx="301752" cy="566928"/>
+          </a:xfrm>
+          <a:prstGeom prst="rect">
+            <a:avLst/>
+          </a:prstGeom>
+          <a:solidFill>
+            <a:srgbClr val="E31B23"/>
+          </a:solidFill>
+          <a:ln w="12700">
+            <a:solidFill>
+              <a:srgbClr val="E31B23"/>
+            </a:solidFill>
+            <a:prstDash val="solid"/>
+          </a:ln>
+        </p:spPr>
+      </p:sp>
+      <p:sp>
+        <p:nvSpPr>
+          <p:cNvPr id="7" name="Shape 5"/>
+          <p:cNvSpPr/>
+          <p:nvPr/>
+        </p:nvSpPr>
+        <p:spPr>
+          <a:xfrm>
+            <a:off x="10881360" y="274320"/>
+            <a:ext cx="905256" cy="566928"/>
+          </a:xfrm>
+          <a:prstGeom prst="rect">
+            <a:avLst/>
+          </a:prstGeom>
+          <a:ln w="6350">
+            <a:solidFill>
+              <a:srgbClr val="1F2937"/>
+            </a:solidFill>
+            <a:prstDash val="solid"/>
+          </a:ln>
+        </p:spPr>
+      </p:sp>
+      <p:sp>
+        <p:nvSpPr>
+          <p:cNvPr id="8" name="Shape 6"/>
+          <p:cNvSpPr/>
+          <p:nvPr/>
+        </p:nvSpPr>
+        <p:spPr>
+          <a:xfrm>
+            <a:off x="457200" y="960120"/>
+            <a:ext cx="11292840" cy="0"/>
+          </a:xfrm>
+          <a:prstGeom prst="line">
+            <a:avLst/>
+          </a:prstGeom>
+          <a:noFill/>
+          <a:ln w="6350">
+            <a:solidFill>
+              <a:srgbClr val="A3A3A3"/>
+            </a:solidFill>
+            <a:prstDash val="solid"/>
+          </a:ln>
+        </p:spPr>
+      </p:sp>
+      <p:sp>
+        <p:nvSpPr>
+          <p:cNvPr id="9" name="Text 7"/>
+          <p:cNvSpPr/>
+          <p:nvPr/>
+        </p:nvSpPr>
+        <p:spPr>
+          <a:xfrm>
+            <a:off x="640080" y="1188720"/>
+            <a:ext cx="10972800" cy="4663440"/>
+          </a:xfrm>
+          <a:prstGeom prst="rect">
+            <a:avLst/>
+          </a:prstGeom>
+          <a:noFill/>
+          <a:ln/>
+        </p:spPr>
+        <p:txBody>
+          <a:bodyPr wrap="square" rtlCol="0" anchor="t"/>
+          <a:lstStyle/>
+          <a:p>
+            <a:pPr marL="342900" indent="-342900">
+              <a:spcBef>
+                <a:spcPts val="800"/>
+              </a:spcBef>
+              <a:spcAft>
+                <a:spcPts val="200"/>
+              </a:spcAft>
+              <a:buSzPct val="100000"/>
+              <a:buChar char="❑"/>
+            </a:pPr>
+            <a:r>
+              <a:rPr lang="en-US" sz="1400" b="1" u="sng" dirty="0">
+                <a:solidFill>
+                  <a:srgbClr val="1F6B5E"/>
+                </a:solidFill>
+                <a:latin typeface="Calibri" pitchFamily="34" charset="0"/>
+                <a:ea typeface="Calibri" pitchFamily="34" charset="-122"/>
+                <a:cs typeface="Calibri" pitchFamily="34" charset="-120"/>
+              </a:rPr>
+              <a:t>MALIKA : UN LOCATAIRE INTERPELLÉ POUR AVOIR POIGNARDÉ À MORT SON VOISIN LORS D'UNE ALTERCATION</a:t>
+            </a:r>
+            <a:endParaRPr lang="en-US" sz="1300" dirty="0"/>
+          </a:p>
+          <a:p>
+            <a:pPr lvl="1" marL="685800" indent="-342900">
+              <a:spcAft>
+                <a:spcPts val="200"/>
+              </a:spcAft>
+              <a:buSzPct val="100000"/>
+              <a:buChar char="▪"/>
+            </a:pPr>
+            <a:r>
+              <a:rPr lang="en-US" sz="1300" dirty="0">
+                <a:solidFill>
+                  <a:srgbClr val="1F2937"/>
+                </a:solidFill>
+                <a:latin typeface="Calibri" pitchFamily="34" charset="0"/>
+                <a:ea typeface="Calibri" pitchFamily="34" charset="-122"/>
+                <a:cs typeface="Calibri" pitchFamily="34" charset="-120"/>
+              </a:rPr>
+              <a:t>Source : </a:t>
+            </a:r>
+            <a:pPr indent="0" marL="0">
+              <a:spcAft>
+                <a:spcPts val="200"/>
+              </a:spcAft>
+              <a:buNone/>
+            </a:pPr>
+            <a:r>
+              <a:rPr lang="en-US" sz="1300" u="sng" dirty="0">
+                <a:solidFill>
+                  <a:srgbClr val="1F6B5E"/>
+                </a:solidFill>
+                <a:latin typeface="Calibri" pitchFamily="34" charset="0"/>
+                <a:ea typeface="Calibri" pitchFamily="34" charset="-122"/>
+                <a:cs typeface="Calibri" pitchFamily="34" charset="-120"/>
+                <a:hlinkClick r:id="rId1" invalidUrl="" action="" tgtFrame="" tooltip="" history="1" highlightClick="0" endSnd="0">
+                  <a:extLst>
+                    <a:ext uri="{A12FA001-AC4F-418D-AE19-62706E023703}">
+                      <ahyp:hlinkClr xmlns:ahyp="http://schemas.microsoft.com/office/drawing/2018/hyperlinkcolor" val="tx"/>
+                    </a:ext>
+                  </a:extLst>
+                </a:hlinkClick>
+              </a:rPr>
+              <a:t>Seneweb</a:t>
+            </a:r>
+            <a:pPr indent="0" marL="0">
+              <a:spcAft>
+                <a:spcPts val="200"/>
+              </a:spcAft>
+              <a:buNone/>
+            </a:pPr>
+            <a:r>
+              <a:rPr lang="en-US" sz="1300" dirty="0">
+                <a:solidFill>
+                  <a:srgbClr val="1F2937"/>
+                </a:solidFill>
+                <a:latin typeface="Calibri" pitchFamily="34" charset="0"/>
+                <a:ea typeface="Calibri" pitchFamily="34" charset="-122"/>
+                <a:cs typeface="Calibri" pitchFamily="34" charset="-120"/>
+              </a:rPr>
+              <a:t> — 27 octobre 2026, 13 h UTC</a:t>
+            </a:r>
+            <a:endParaRPr lang="en-US" sz="1300" dirty="0"/>
+          </a:p>
+          <a:p>
+            <a:pPr marL="342900" indent="-342900">
+              <a:spcBef>
+                <a:spcPts val="800"/>
+              </a:spcBef>
+              <a:spcAft>
+                <a:spcPts val="200"/>
+              </a:spcAft>
+              <a:buSzPct val="100000"/>
+              <a:buChar char="❑"/>
+            </a:pPr>
+            <a:r>
+              <a:rPr lang="en-US" sz="1400" b="1" u="sng" dirty="0">
+                <a:solidFill>
+                  <a:srgbClr val="1F6B5E"/>
+                </a:solidFill>
+                <a:latin typeface="Calibri" pitchFamily="34" charset="0"/>
+                <a:ea typeface="Calibri" pitchFamily="34" charset="-122"/>
+                <a:cs typeface="Calibri" pitchFamily="34" charset="-120"/>
+              </a:rPr>
+              <a:t>MEURTRE PRÉSUMÉ D’AMINATA SY À PODOR : LE SUSPECT RETROUVÉ DANS UNE CACHETTE ET ARRÊTÉ À MBACKÉ</a:t>
+            </a:r>
+            <a:endParaRPr lang="en-US" sz="1300" dirty="0"/>
+          </a:p>
+          <a:p>
+            <a:pPr lvl="1" marL="685800" indent="-342900">
+              <a:spcAft>
+                <a:spcPts val="200"/>
+              </a:spcAft>
+              <a:buSzPct val="100000"/>
+              <a:buChar char="▪"/>
+            </a:pPr>
+            <a:r>
+              <a:rPr lang="en-US" sz="1300" dirty="0">
+                <a:solidFill>
+                  <a:srgbClr val="1F2937"/>
+                </a:solidFill>
+                <a:latin typeface="Calibri" pitchFamily="34" charset="0"/>
+                <a:ea typeface="Calibri" pitchFamily="34" charset="-122"/>
+                <a:cs typeface="Calibri" pitchFamily="34" charset="-120"/>
+              </a:rPr>
+              <a:t>Sources : </a:t>
+            </a:r>
+            <a:pPr indent="0" marL="0">
+              <a:spcAft>
+                <a:spcPts val="200"/>
+              </a:spcAft>
+              <a:buNone/>
+            </a:pPr>
+            <a:r>
+              <a:rPr lang="en-US" sz="1300" u="sng" dirty="0">
+                <a:solidFill>
+                  <a:srgbClr val="1F6B5E"/>
+                </a:solidFill>
+                <a:latin typeface="Calibri" pitchFamily="34" charset="0"/>
+                <a:ea typeface="Calibri" pitchFamily="34" charset="-122"/>
+                <a:cs typeface="Calibri" pitchFamily="34" charset="-120"/>
+                <a:hlinkClick r:id="rId2" invalidUrl="" action="" tgtFrame="" tooltip="" history="1" highlightClick="0" endSnd="0">
+                  <a:extLst>
+                    <a:ext uri="{A12FA001-AC4F-418D-AE19-62706E023703}">
+                      <ahyp:hlinkClr xmlns:ahyp="http://schemas.microsoft.com/office/drawing/2018/hyperlinkcolor" val="tx"/>
+                    </a:ext>
+                  </a:extLst>
+                </a:hlinkClick>
+              </a:rPr>
+              <a:t>Dakar Actu · Seneweb</a:t>
+            </a:r>
+            <a:pPr indent="0" marL="0">
+              <a:spcAft>
+                <a:spcPts val="200"/>
+              </a:spcAft>
+              <a:buNone/>
+            </a:pPr>
+            <a:r>
+              <a:rPr lang="en-US" sz="1300" dirty="0">
+                <a:solidFill>
+                  <a:srgbClr val="1F2937"/>
+                </a:solidFill>
+                <a:latin typeface="Calibri" pitchFamily="34" charset="0"/>
+                <a:ea typeface="Calibri" pitchFamily="34" charset="-122"/>
+                <a:cs typeface="Calibri" pitchFamily="34" charset="-120"/>
+              </a:rPr>
+              <a:t> — 27 octobre 2026, 11 h UTC   ·   </a:t>
+            </a:r>
+            <a:pPr indent="0" marL="0">
+              <a:spcAft>
+                <a:spcPts val="200"/>
+              </a:spcAft>
+              <a:buNone/>
+            </a:pPr>
+            <a:r>
+              <a:rPr lang="en-US" sz="1300" b="1" dirty="0">
+                <a:solidFill>
+                  <a:srgbClr val="1F2937"/>
+                </a:solidFill>
+                <a:latin typeface="Calibri" pitchFamily="34" charset="0"/>
+                <a:ea typeface="Calibri" pitchFamily="34" charset="-122"/>
+                <a:cs typeface="Calibri" pitchFamily="34" charset="-120"/>
+              </a:rPr>
+              <a:t>Cotation : Confirmé</a:t>
+            </a:r>
+            <a:endParaRPr lang="en-US" sz="1300" dirty="0"/>
+          </a:p>
+          <a:p>
+            <a:pPr marL="342900" indent="-342900">
+              <a:spcBef>
+                <a:spcPts val="800"/>
+              </a:spcBef>
+              <a:spcAft>
+                <a:spcPts val="200"/>
+              </a:spcAft>
+              <a:buSzPct val="100000"/>
+              <a:buChar char="❑"/>
+            </a:pPr>
+            <a:r>
+              <a:rPr lang="en-US" sz="1400" b="1" u="sng" dirty="0">
+                <a:solidFill>
+                  <a:srgbClr val="1F6B5E"/>
+                </a:solidFill>
+                <a:latin typeface="Calibri" pitchFamily="34" charset="0"/>
+                <a:ea typeface="Calibri" pitchFamily="34" charset="-122"/>
+                <a:cs typeface="Calibri" pitchFamily="34" charset="-120"/>
+              </a:rPr>
+              <a:t>KARAMO CISSÉ NDIAYE ARRÊTÉ POUR LE MEURTRE D’AMINATA SY APRÈS UNE DISPUTE VIOLENTE</a:t>
+            </a:r>
+            <a:endParaRPr lang="en-US" sz="1300" dirty="0"/>
+          </a:p>
+          <a:p>
+            <a:pPr lvl="1" marL="685800" indent="-342900">
+              <a:spcAft>
+                <a:spcPts val="200"/>
+              </a:spcAft>
+              <a:buSzPct val="100000"/>
+              <a:buChar char="▪"/>
+            </a:pPr>
+            <a:r>
+              <a:rPr lang="en-US" sz="1300" dirty="0">
+                <a:solidFill>
+                  <a:srgbClr val="1F2937"/>
+                </a:solidFill>
+                <a:latin typeface="Calibri" pitchFamily="34" charset="0"/>
+                <a:ea typeface="Calibri" pitchFamily="34" charset="-122"/>
+                <a:cs typeface="Calibri" pitchFamily="34" charset="-120"/>
+              </a:rPr>
+              <a:t>Source : </a:t>
+            </a:r>
+            <a:pPr indent="0" marL="0">
+              <a:spcAft>
+                <a:spcPts val="200"/>
+              </a:spcAft>
+              <a:buNone/>
+            </a:pPr>
+            <a:r>
+              <a:rPr lang="en-US" sz="1300" u="sng" dirty="0">
+                <a:solidFill>
+                  <a:srgbClr val="1F6B5E"/>
+                </a:solidFill>
+                <a:latin typeface="Calibri" pitchFamily="34" charset="0"/>
+                <a:ea typeface="Calibri" pitchFamily="34" charset="-122"/>
+                <a:cs typeface="Calibri" pitchFamily="34" charset="-120"/>
+                <a:hlinkClick r:id="rId3" invalidUrl="" action="" tgtFrame="" tooltip="" history="1" highlightClick="0" endSnd="0">
+                  <a:extLst>
+                    <a:ext uri="{A12FA001-AC4F-418D-AE19-62706E023703}">
+                      <ahyp:hlinkClr xmlns:ahyp="http://schemas.microsoft.com/office/drawing/2018/hyperlinkcolor" val="tx"/>
+                    </a:ext>
+                  </a:extLst>
+                </a:hlinkClick>
+              </a:rPr>
+              <a:t>SeneNews</a:t>
+            </a:r>
+            <a:pPr indent="0" marL="0">
+              <a:spcAft>
+                <a:spcPts val="200"/>
+              </a:spcAft>
+              <a:buNone/>
+            </a:pPr>
+            <a:r>
+              <a:rPr lang="en-US" sz="1300" dirty="0">
+                <a:solidFill>
+                  <a:srgbClr val="1F2937"/>
+                </a:solidFill>
+                <a:latin typeface="Calibri" pitchFamily="34" charset="0"/>
+                <a:ea typeface="Calibri" pitchFamily="34" charset="-122"/>
+                <a:cs typeface="Calibri" pitchFamily="34" charset="-120"/>
+              </a:rPr>
+              <a:t> — 27 octobre 2026, 8 h UTC</a:t>
+            </a:r>
+            <a:endParaRPr lang="en-US" sz="1300" dirty="0"/>
+          </a:p>
+          <a:p>
+            <a:pPr marL="342900" indent="-342900">
+              <a:spcBef>
+                <a:spcPts val="800"/>
+              </a:spcBef>
+              <a:spcAft>
+                <a:spcPts val="200"/>
+              </a:spcAft>
+              <a:buSzPct val="100000"/>
+              <a:buChar char="❑"/>
+            </a:pPr>
+            <a:r>
+              <a:rPr lang="en-US" sz="1400" b="1" u="sng" dirty="0">
+                <a:solidFill>
+                  <a:srgbClr val="1F6B5E"/>
+                </a:solidFill>
+                <a:latin typeface="Calibri" pitchFamily="34" charset="0"/>
+                <a:ea typeface="Calibri" pitchFamily="34" charset="-122"/>
+                <a:cs typeface="Calibri" pitchFamily="34" charset="-120"/>
+              </a:rPr>
+              <a:t>DRAME À ZIGUINCHOR : UN COMMERÇANT RETROUVÉ MORT PENDU APRÈS LA PERTE DE 800 000 F CFA</a:t>
+            </a:r>
+            <a:endParaRPr lang="en-US" sz="1300" dirty="0"/>
+          </a:p>
+          <a:p>
+            <a:pPr lvl="1" marL="685800" indent="-342900">
+              <a:spcAft>
+                <a:spcPts val="200"/>
+              </a:spcAft>
+              <a:buSzPct val="100000"/>
+              <a:buChar char="▪"/>
+            </a:pPr>
+            <a:r>
+              <a:rPr lang="en-US" sz="1300" dirty="0">
+                <a:solidFill>
+                  <a:srgbClr val="1F2937"/>
+                </a:solidFill>
+                <a:latin typeface="Calibri" pitchFamily="34" charset="0"/>
+                <a:ea typeface="Calibri" pitchFamily="34" charset="-122"/>
+                <a:cs typeface="Calibri" pitchFamily="34" charset="-120"/>
+              </a:rPr>
+              <a:t>Source : </a:t>
+            </a:r>
+            <a:pPr indent="0" marL="0">
+              <a:spcAft>
+                <a:spcPts val="200"/>
+              </a:spcAft>
+              <a:buNone/>
+            </a:pPr>
+            <a:r>
+              <a:rPr lang="en-US" sz="1300" u="sng" dirty="0">
+                <a:solidFill>
+                  <a:srgbClr val="1F6B5E"/>
+                </a:solidFill>
+                <a:latin typeface="Calibri" pitchFamily="34" charset="0"/>
+                <a:ea typeface="Calibri" pitchFamily="34" charset="-122"/>
+                <a:cs typeface="Calibri" pitchFamily="34" charset="-120"/>
+                <a:hlinkClick r:id="rId4" invalidUrl="" action="" tgtFrame="" tooltip="" history="1" highlightClick="0" endSnd="0">
+                  <a:extLst>
+                    <a:ext uri="{A12FA001-AC4F-418D-AE19-62706E023703}">
+                      <ahyp:hlinkClr xmlns:ahyp="http://schemas.microsoft.com/office/drawing/2018/hyperlinkcolor" val="tx"/>
+                    </a:ext>
+                  </a:extLst>
+                </a:hlinkClick>
+              </a:rPr>
+              <a:t>Seneweb</a:t>
+            </a:r>
+            <a:pPr indent="0" marL="0">
+              <a:spcAft>
+                <a:spcPts val="200"/>
+              </a:spcAft>
+              <a:buNone/>
+            </a:pPr>
+            <a:r>
+              <a:rPr lang="en-US" sz="1300" dirty="0">
+                <a:solidFill>
+                  <a:srgbClr val="1F2937"/>
+                </a:solidFill>
+                <a:latin typeface="Calibri" pitchFamily="34" charset="0"/>
+                <a:ea typeface="Calibri" pitchFamily="34" charset="-122"/>
+                <a:cs typeface="Calibri" pitchFamily="34" charset="-120"/>
+              </a:rPr>
+              <a:t> — 26 octobre 2026, 23 h UTC</a:t>
+            </a:r>
+            <a:endParaRPr lang="en-US" sz="1300" dirty="0"/>
+          </a:p>
+        </p:txBody>
+      </p:sp>
+      <p:sp>
+        <p:nvSpPr>
+          <p:cNvPr id="10" name="Text 8"/>
+          <p:cNvSpPr/>
+          <p:nvPr/>
+        </p:nvSpPr>
+        <p:spPr>
+          <a:xfrm>
+            <a:off x="3108960" y="6217920"/>
+            <a:ext cx="5486400" cy="329184"/>
+          </a:xfrm>
+          <a:prstGeom prst="rect">
+            <a:avLst/>
+          </a:prstGeom>
+          <a:noFill/>
+          <a:ln w="9525">
+            <a:solidFill>
+              <a:srgbClr val="1F6B5E"/>
+            </a:solidFill>
+          </a:ln>
+        </p:spPr>
+        <p:txBody>
+          <a:bodyPr wrap="square" rtlCol="0" anchor="ctr">
+            <a:normAutofit/>
+          </a:bodyPr>
+          <a:lstStyle/>
+          <a:p>
+            <a:pPr algn="ctr" indent="0" marL="0">
+              <a:buNone/>
+            </a:pPr>
+            <a:r>
+              <a:rPr lang="en-US" sz="1200" dirty="0">
+                <a:solidFill>
+                  <a:srgbClr val="1F2937"/>
+                </a:solidFill>
+                <a:latin typeface="Calibri" pitchFamily="34" charset="0"/>
+                <a:ea typeface="Calibri" pitchFamily="34" charset="-122"/>
+                <a:cs typeface="Calibri" pitchFamily="34" charset="-120"/>
+              </a:rPr>
+              <a:t>SentiqS — veille de sûreté sur l'Afrique</a:t>
+            </a:r>
+            <a:endParaRPr lang="en-US" sz="1200" dirty="0"/>
+          </a:p>
+        </p:txBody>
+      </p:sp>
+      <p:sp>
+        <p:nvSpPr>
+          <p:cNvPr id="11" name="Text 9"/>
+          <p:cNvSpPr/>
+          <p:nvPr/>
+        </p:nvSpPr>
+        <p:spPr>
+          <a:xfrm>
+            <a:off x="9418320" y="6309360"/>
+            <a:ext cx="2468880" cy="274320"/>
+          </a:xfrm>
+          <a:prstGeom prst="rect">
+            <a:avLst/>
+          </a:prstGeom>
+          <a:noFill/>
+          <a:ln/>
+        </p:spPr>
+        <p:txBody>
+          <a:bodyPr wrap="square" rtlCol="0" anchor="ctr"/>
+          <a:lstStyle/>
+          <a:p>
+            <a:pPr algn="r" indent="0" marL="0">
+              <a:buNone/>
+            </a:pPr>
+            <a:r>
+              <a:rPr lang="en-US" sz="1000" dirty="0">
+                <a:solidFill>
+                  <a:srgbClr val="1F2937"/>
+                </a:solidFill>
+                <a:latin typeface="Calibri" pitchFamily="34" charset="0"/>
+                <a:ea typeface="Calibri" pitchFamily="34" charset="-122"/>
+                <a:cs typeface="Calibri" pitchFamily="34" charset="-120"/>
+              </a:rPr>
+              <a:t>|  28/10/26   |   38</a:t>
+            </a:r>
+            <a:endParaRPr lang="en-US" sz="1000" dirty="0"/>
+          </a:p>
+        </p:txBody>
+      </p:sp>
+    </p:spTree>
+  </p:cSld>
+  <p:clrMapOvr>
+    <a:masterClrMapping/>
+  </p:clrMapOvr>
+</p:sld>
+</file>
+
+<file path=ppt/slides/slide39.xml><?xml version="1.0" encoding="utf-8"?>
+<p:sld xmlns:a="http://schemas.openxmlformats.org/drawingml/2006/main" xmlns:r="http://schemas.openxmlformats.org/officeDocument/2006/relationships" xmlns:p="http://schemas.openxmlformats.org/presentationml/2006/main">
+  <p:cSld name="Slide 39">
     <p:bg>
       <p:bgPr>
         <a:solidFill>
@@ -25619,7 +26238,7 @@
                 <a:ea typeface="Calibri" pitchFamily="34" charset="-122"/>
                 <a:cs typeface="Calibri" pitchFamily="34" charset="-120"/>
               </a:rPr>
-              <a:t>|  27/10/26   |   38</a:t>
+              <a:t>|  28/10/26   |   39</a:t>
             </a:r>
             <a:endParaRPr lang="en-US" sz="1000" dirty="0"/>
           </a:p>
@@ -25885,7 +26504,7 @@
                 <a:ea typeface="Calibri" pitchFamily="34" charset="-122"/>
                 <a:cs typeface="Calibri" pitchFamily="34" charset="-120"/>
               </a:rPr>
-              <a:t>Indice de confiance : moyenne (incident vérifié le plus récent : 120 jours ; 2 signaux du jour)</a:t>
+              <a:t>Indice de confiance : faible (incident vérifié le plus récent : 121 jours ; aucun signal du jour)</a:t>
             </a:r>
             <a:endParaRPr lang="en-US" sz="1100" dirty="0"/>
           </a:p>
@@ -26223,7 +26842,7 @@
                 <a:ea typeface="Calibri" pitchFamily="34" charset="-122"/>
                 <a:cs typeface="Calibri" pitchFamily="34" charset="-120"/>
               </a:rPr>
-              <a:t>|  27/10/26   |   4</a:t>
+              <a:t>|  28/10/26   |   4</a:t>
             </a:r>
             <a:endParaRPr lang="en-US" sz="1000" dirty="0"/>
           </a:p>
@@ -26788,7 +27407,7 @@
                 <a:ea typeface="Calibri" pitchFamily="34" charset="-122"/>
                 <a:cs typeface="Calibri" pitchFamily="34" charset="-120"/>
               </a:rPr>
-              <a:t>|  27/10/26   |   5</a:t>
+              <a:t>|  28/10/26   |   5</a:t>
             </a:r>
             <a:endParaRPr lang="en-US" sz="1000" dirty="0"/>
           </a:p>
@@ -27353,7 +27972,7 @@
                 <a:ea typeface="Calibri" pitchFamily="34" charset="-122"/>
                 <a:cs typeface="Calibri" pitchFamily="34" charset="-120"/>
               </a:rPr>
-              <a:t>|  27/10/26   |   6</a:t>
+              <a:t>|  28/10/26   |   6</a:t>
             </a:r>
             <a:endParaRPr lang="en-US" sz="1000" dirty="0"/>
           </a:p>
@@ -27858,7 +28477,7 @@
                 <a:ea typeface="Calibri" pitchFamily="34" charset="-122"/>
                 <a:cs typeface="Calibri" pitchFamily="34" charset="-120"/>
               </a:rPr>
-              <a:t>|  27/10/26   |   7</a:t>
+              <a:t>|  28/10/26   |   7</a:t>
             </a:r>
             <a:endParaRPr lang="en-US" sz="1000" dirty="0"/>
           </a:p>
@@ -28124,7 +28743,7 @@
                 <a:ea typeface="Calibri" pitchFamily="34" charset="-122"/>
                 <a:cs typeface="Calibri" pitchFamily="34" charset="-120"/>
               </a:rPr>
-              <a:t>Indice de confiance : moyenne (incident vérifié le plus récent : 120 jours ; 2 signaux du jour)</a:t>
+              <a:t>Indice de confiance : faible (incident vérifié le plus récent : 121 jours ; aucun signal du jour)</a:t>
             </a:r>
             <a:endParaRPr lang="en-US" sz="1100" dirty="0"/>
           </a:p>
@@ -28402,7 +29021,7 @@
                 <a:ea typeface="Calibri" pitchFamily="34" charset="-122"/>
                 <a:cs typeface="Calibri" pitchFamily="34" charset="-120"/>
               </a:rPr>
-              <a:t>|  27/10/26   |   8</a:t>
+              <a:t>|  28/10/26   |   8</a:t>
             </a:r>
             <a:endParaRPr lang="en-US" sz="1000" dirty="0"/>
           </a:p>
@@ -28668,7 +29287,7 @@
                 <a:ea typeface="Calibri" pitchFamily="34" charset="-122"/>
                 <a:cs typeface="Calibri" pitchFamily="34" charset="-120"/>
               </a:rPr>
-              <a:t>Indice de confiance : moyenne (incident vérifié le plus récent : 120 jours ; 2 signaux du jour)</a:t>
+              <a:t>Indice de confiance : faible (incident vérifié le plus récent : 121 jours ; aucun signal du jour)</a:t>
             </a:r>
             <a:endParaRPr lang="en-US" sz="1100" dirty="0"/>
           </a:p>
@@ -29255,7 +29874,7 @@
                 <a:ea typeface="Calibri" pitchFamily="34" charset="-122"/>
                 <a:cs typeface="Calibri" pitchFamily="34" charset="-120"/>
               </a:rPr>
-              <a:t>|  27/10/26   |   9</a:t>
+              <a:t>|  28/10/26   |   9</a:t>
             </a:r>
             <a:endParaRPr lang="en-US" sz="1000" dirty="0"/>
           </a:p>

</xml_diff>